<commit_message>
Restore diagram and screenshot descriptions in teaching materials
</commit_message>
<xml_diff>
--- a/week_01/week_01_responsibility_relational_thinking.pptx
+++ b/week_01/week_01_responsibility_relational_thinking.pptx
@@ -16556,1514 +16556,1514 @@
 </file>
 
 <file path=ppt/slides/slide5.xml><?xml version="1.0" encoding="utf-8"?>
-<p:sld xmlns:p="http://schemas.openxmlformats.org/presentationml/2006/main">
-  <p:cSld>
-    <p:bg>
-      <p:bgPr>
-        <a:solidFill xmlns:a="http://schemas.openxmlformats.org/drawingml/2006/main">
-          <a:srgbClr val="F7F3EA"/>
-        </a:solidFill>
-      </p:bgPr>
-    </p:bg>
-    <p:spTree>
-      <p:nvGrpSpPr>
-        <p:cNvPr id="1" name=""/>
-        <p:cNvGrpSpPr/>
-        <p:nvPr/>
-      </p:nvGrpSpPr>
-      <p:grpSpPr>
-        <a:xfrm xmlns:a="http://schemas.openxmlformats.org/drawingml/2006/main"/>
-      </p:grpSpPr>
-      <p:sp>
-        <p:nvSpPr>
-          <p:cNvPr id="15" name="">
-            <a:extLst xmlns:a="http://schemas.openxmlformats.org/drawingml/2006/main">
-              <a:ext uri="{FF2B5EF4-FFF2-40B4-BE49-F238E27FC236}">
-                <a16:creationId xmlns:a16="http://schemas.microsoft.com/office/drawing/2014/main" id="{ECE5B4E2-067F-4DCA-8105-FE99E439C22C}"/>
-              </a:ext>
-            </a:extLst>
-          </p:cNvPr>
-          <p:cNvSpPr>
-            <a:spLocks xmlns:a="http://schemas.openxmlformats.org/drawingml/2006/main" noGrp="1"/>
-          </p:cNvSpPr>
-          <p:nvPr/>
-        </p:nvSpPr>
-        <p:spPr>
-          <a:xfrm xmlns:a="http://schemas.openxmlformats.org/drawingml/2006/main">
-            <a:off x="552450" y="400050"/>
-            <a:ext cx="1447800" cy="323850"/>
-          </a:xfrm>
-          <a:prstGeom xmlns:a="http://schemas.openxmlformats.org/drawingml/2006/main" prst="roundRect">
-            <a:avLst>
-              <a:gd name="adj" fmla="val 50000"/>
-            </a:avLst>
-          </a:prstGeom>
-          <a:solidFill xmlns:a="http://schemas.openxmlformats.org/drawingml/2006/main">
-            <a:srgbClr val="14213D"/>
-          </a:solidFill>
-          <a:ln xmlns:a="http://schemas.openxmlformats.org/drawingml/2006/main" w="9525">
-            <a:solidFill>
-              <a:srgbClr val="14213D"/>
-            </a:solidFill>
-            <a:prstDash val="solid"/>
-          </a:ln>
-        </p:spPr>
-        <p:txBody>
-          <a:bodyPr xmlns:a="http://schemas.openxmlformats.org/drawingml/2006/main" lIns="76200" tIns="0" rIns="76200" bIns="0" anchor="ctr">
-            <a:normAutofit fontScale="96996"/>
-          </a:bodyPr>
-          <a:lstStyle xmlns:a="http://schemas.openxmlformats.org/drawingml/2006/main"/>
-          <a:p xmlns:a="http://schemas.openxmlformats.org/drawingml/2006/main">
-            <a:pPr algn="ctr">
-              <a:buNone/>
-              <a:defRPr sz="1050" b="1">
-                <a:solidFill>
-                  <a:srgbClr val="FFFFFF"/>
-                </a:solidFill>
-                <a:latin typeface="Avenir Next"/>
-                <a:ea typeface="Avenir Next"/>
-                <a:cs typeface="Avenir Next"/>
-              </a:defRPr>
-            </a:pPr>
-            <a:r>
-              <a:rPr sz="1050" b="1">
-                <a:solidFill>
-                  <a:srgbClr val="FFFFFF"/>
-                </a:solidFill>
-                <a:latin typeface="Avenir Next"/>
-                <a:ea typeface="Avenir Next"/>
-                <a:cs typeface="Avenir Next"/>
-              </a:rPr>
-              <a:t>CLOUD INTERFACE</a:t>
-            </a:r>
-          </a:p>
-        </p:txBody>
-      </p:sp>
-      <p:sp>
-        <p:nvSpPr>
-          <p:cNvPr id="2" name="slide-title">
-            <a:extLst xmlns:a="http://schemas.openxmlformats.org/drawingml/2006/main">
-              <a:ext uri="{FF2B5EF4-FFF2-40B4-BE49-F238E27FC236}">
-                <a16:creationId xmlns:a16="http://schemas.microsoft.com/office/drawing/2014/main" id="{4EE0B915-1960-47EC-9286-DC4133E09536}"/>
-              </a:ext>
-            </a:extLst>
-          </p:cNvPr>
-          <p:cNvSpPr>
-            <a:spLocks xmlns:a="http://schemas.openxmlformats.org/drawingml/2006/main" noGrp="1"/>
-          </p:cNvSpPr>
-          <p:nvPr/>
-        </p:nvSpPr>
-        <p:spPr>
-          <a:xfrm xmlns:a="http://schemas.openxmlformats.org/drawingml/2006/main">
-            <a:off x="552450" y="876300"/>
-            <a:ext cx="11087100" cy="704850"/>
-          </a:xfrm>
-          <a:prstGeom xmlns:a="http://schemas.openxmlformats.org/drawingml/2006/main" prst="rect">
-            <a:avLst/>
-          </a:prstGeom>
-          <a:noFill xmlns:a="http://schemas.openxmlformats.org/drawingml/2006/main"/>
-          <a:ln xmlns:a="http://schemas.openxmlformats.org/drawingml/2006/main" w="0">
-            <a:noFill/>
-            <a:prstDash val="solid"/>
-          </a:ln>
-        </p:spPr>
-        <p:txBody>
-          <a:bodyPr xmlns:a="http://schemas.openxmlformats.org/drawingml/2006/main" lIns="0" tIns="0" rIns="0" bIns="0" anchor="t">
-            <a:normAutofit fontScale="100000"/>
-          </a:bodyPr>
-          <a:lstStyle xmlns:a="http://schemas.openxmlformats.org/drawingml/2006/main"/>
-          <a:p xmlns:a="http://schemas.openxmlformats.org/drawingml/2006/main">
-            <a:pPr>
-              <a:lnSpc>
-                <a:spcPct val="95000"/>
-              </a:lnSpc>
-              <a:buNone/>
-              <a:defRPr sz="3000" b="1">
-                <a:solidFill>
-                  <a:srgbClr val="14213D"/>
-                </a:solidFill>
-                <a:latin typeface="Georgia"/>
-                <a:ea typeface="Georgia"/>
-                <a:cs typeface="Georgia"/>
-              </a:defRPr>
-            </a:pPr>
-            <a:r>
-              <a:rPr sz="3000" b="1">
-                <a:solidFill>
-                  <a:srgbClr val="14213D"/>
-                </a:solidFill>
-                <a:latin typeface="Georgia"/>
-                <a:ea typeface="Georgia"/>
-                <a:cs typeface="Georgia"/>
-              </a:rPr>
-              <a:t>Supabase is a platform built around PostgreSQL</a:t>
-            </a:r>
-          </a:p>
-        </p:txBody>
-      </p:sp>
-      <p:sp>
-        <p:nvSpPr>
-          <p:cNvPr id="3" name="">
-            <a:extLst xmlns:a="http://schemas.openxmlformats.org/drawingml/2006/main">
-              <a:ext uri="{FF2B5EF4-FFF2-40B4-BE49-F238E27FC236}">
-                <a16:creationId xmlns:a16="http://schemas.microsoft.com/office/drawing/2014/main" id="{9C69D724-C471-40F9-BE5A-7CF3D5C1EC8C}"/>
-              </a:ext>
-            </a:extLst>
-          </p:cNvPr>
-          <p:cNvSpPr>
-            <a:spLocks xmlns:a="http://schemas.openxmlformats.org/drawingml/2006/main" noGrp="1"/>
-          </p:cNvSpPr>
-          <p:nvPr/>
-        </p:nvSpPr>
-        <p:spPr>
-          <a:xfrm xmlns:a="http://schemas.openxmlformats.org/drawingml/2006/main">
-            <a:off x="571500" y="1562100"/>
-            <a:ext cx="10477500" cy="381000"/>
-          </a:xfrm>
-          <a:prstGeom xmlns:a="http://schemas.openxmlformats.org/drawingml/2006/main" prst="rect">
-            <a:avLst/>
-          </a:prstGeom>
-          <a:noFill xmlns:a="http://schemas.openxmlformats.org/drawingml/2006/main"/>
-          <a:ln xmlns:a="http://schemas.openxmlformats.org/drawingml/2006/main" w="0">
-            <a:noFill/>
-            <a:prstDash val="solid"/>
-          </a:ln>
-        </p:spPr>
-        <p:txBody>
-          <a:bodyPr xmlns:a="http://schemas.openxmlformats.org/drawingml/2006/main" lIns="0" tIns="0" rIns="0" bIns="0" anchor="t">
-            <a:normAutofit fontScale="100000"/>
-          </a:bodyPr>
-          <a:lstStyle xmlns:a="http://schemas.openxmlformats.org/drawingml/2006/main"/>
-          <a:p xmlns:a="http://schemas.openxmlformats.org/drawingml/2006/main">
-            <a:pPr>
-              <a:buNone/>
-              <a:defRPr sz="1425">
-                <a:solidFill>
-                  <a:srgbClr val="5C6577"/>
-                </a:solidFill>
-                <a:latin typeface="Avenir Next"/>
-                <a:ea typeface="Avenir Next"/>
-                <a:cs typeface="Avenir Next"/>
-              </a:defRPr>
-            </a:pPr>
-            <a:r>
-              <a:rPr sz="1425">
-                <a:solidFill>
-                  <a:srgbClr val="5C6577"/>
-                </a:solidFill>
-                <a:latin typeface="Avenir Next"/>
-                <a:ea typeface="Avenir Next"/>
-                <a:cs typeface="Avenir Next"/>
-              </a:rPr>
-              <a:t>The dashboard exposes projects and services; PostgreSQL remains the database engine.</a:t>
-            </a:r>
-          </a:p>
-        </p:txBody>
-      </p:sp>
-      <p:sp>
-        <p:nvSpPr>
-          <p:cNvPr id="4" name="">
-            <a:extLst xmlns:a="http://schemas.openxmlformats.org/drawingml/2006/main">
-              <a:ext uri="{FF2B5EF4-FFF2-40B4-BE49-F238E27FC236}">
-                <a16:creationId xmlns:a16="http://schemas.microsoft.com/office/drawing/2014/main" id="{EC90CB12-698B-49BA-8F98-BAD9E65B7181}"/>
-              </a:ext>
-            </a:extLst>
-          </p:cNvPr>
-          <p:cNvSpPr>
-            <a:spLocks xmlns:a="http://schemas.openxmlformats.org/drawingml/2006/main" noGrp="1"/>
-          </p:cNvSpPr>
-          <p:nvPr/>
-        </p:nvSpPr>
-        <p:spPr>
-          <a:xfrm xmlns:a="http://schemas.openxmlformats.org/drawingml/2006/main">
-            <a:off x="11144250" y="6334125"/>
-            <a:ext cx="495300" cy="228600"/>
-          </a:xfrm>
-          <a:prstGeom xmlns:a="http://schemas.openxmlformats.org/drawingml/2006/main" prst="rect">
-            <a:avLst/>
-          </a:prstGeom>
-          <a:noFill xmlns:a="http://schemas.openxmlformats.org/drawingml/2006/main"/>
-          <a:ln xmlns:a="http://schemas.openxmlformats.org/drawingml/2006/main" w="0">
-            <a:noFill/>
-            <a:prstDash val="solid"/>
-          </a:ln>
-        </p:spPr>
-        <p:txBody>
-          <a:bodyPr xmlns:a="http://schemas.openxmlformats.org/drawingml/2006/main" wrap="square" lIns="0" tIns="0" rIns="0" bIns="0" anchor="t">
-            <a:noAutofit/>
-          </a:bodyPr>
-          <a:lstStyle xmlns:a="http://schemas.openxmlformats.org/drawingml/2006/main"/>
-          <a:p xmlns:a="http://schemas.openxmlformats.org/drawingml/2006/main">
-            <a:pPr algn="r">
-              <a:buNone/>
-              <a:defRPr sz="1050" b="1">
-                <a:solidFill>
-                  <a:srgbClr val="5C6577"/>
-                </a:solidFill>
-                <a:latin typeface="Menlo"/>
-                <a:ea typeface="Menlo"/>
-                <a:cs typeface="Menlo"/>
-              </a:defRPr>
-            </a:pPr>
-            <a:r>
-              <a:rPr sz="1050" b="1">
-                <a:solidFill>
-                  <a:srgbClr val="5C6577"/>
-                </a:solidFill>
-                <a:latin typeface="Menlo"/>
-                <a:ea typeface="Menlo"/>
-                <a:cs typeface="Menlo"/>
-              </a:rPr>
-              <a:t>05</a:t>
-            </a:r>
-          </a:p>
-        </p:txBody>
-      </p:sp>
-      <p:sp>
-        <p:nvSpPr>
-          <p:cNvPr id="5" name="">
-            <a:extLst xmlns:a="http://schemas.openxmlformats.org/drawingml/2006/main">
-              <a:ext uri="{FF2B5EF4-FFF2-40B4-BE49-F238E27FC236}">
-                <a16:creationId xmlns:a16="http://schemas.microsoft.com/office/drawing/2014/main" id="{A420DB7B-3F95-4CE2-B782-695A52096B0F}"/>
-              </a:ext>
-            </a:extLst>
-          </p:cNvPr>
-          <p:cNvSpPr>
-            <a:spLocks xmlns:a="http://schemas.openxmlformats.org/drawingml/2006/main" noGrp="1"/>
-          </p:cNvSpPr>
-          <p:nvPr/>
-        </p:nvSpPr>
-        <p:spPr>
-          <a:xfrm xmlns:a="http://schemas.openxmlformats.org/drawingml/2006/main">
-            <a:off x="552450" y="2038350"/>
-            <a:ext cx="5810250" cy="4095750"/>
-          </a:xfrm>
-          <a:prstGeom xmlns:a="http://schemas.openxmlformats.org/drawingml/2006/main" prst="roundRect">
-            <a:avLst>
-              <a:gd name="adj" fmla="val 4186"/>
-            </a:avLst>
-          </a:prstGeom>
-          <a:solidFill xmlns:a="http://schemas.openxmlformats.org/drawingml/2006/main">
-            <a:srgbClr val="FFFFFF"/>
-          </a:solidFill>
-          <a:ln xmlns:a="http://schemas.openxmlformats.org/drawingml/2006/main" w="9525">
-            <a:solidFill>
-              <a:srgbClr val="E9E4D8"/>
-            </a:solidFill>
-            <a:prstDash val="solid"/>
-          </a:ln>
-        </p:spPr>
-      </p:sp>
-      <p:pic>
-        <p:nvPicPr>
-          <p:cNvPr id="22" name=""/>
-          <p:cNvPicPr>
-            <a:picLocks xmlns:a="http://schemas.openxmlformats.org/drawingml/2006/main" noChangeAspect="1"/>
-          </p:cNvPicPr>
-          <p:nvPr/>
-        </p:nvPicPr>
-        <p:blipFill>
-          <a:blip xmlns:r="http://schemas.openxmlformats.org/officeDocument/2006/relationships" xmlns:a="http://schemas.openxmlformats.org/drawingml/2006/main" r:embed="Ra9a661b4d442464f"/>
-          <a:srcRect xmlns:a="http://schemas.openxmlformats.org/drawingml/2006/main" l="0" t="21016" r="0" b="21016"/>
-          <a:stretch xmlns:a="http://schemas.openxmlformats.org/drawingml/2006/main">
-            <a:fillRect l="0" t="0" r="0" b="0"/>
-          </a:stretch>
-        </p:blipFill>
-        <p:spPr>
-          <a:xfrm xmlns:a="http://schemas.openxmlformats.org/drawingml/2006/main">
-            <a:off x="714375" y="2181225"/>
-            <a:ext cx="5486400" cy="3810000"/>
-          </a:xfrm>
-          <a:prstGeom xmlns:a="http://schemas.openxmlformats.org/drawingml/2006/main" prst="roundRect">
-            <a:avLst>
-              <a:gd name="adj" fmla="val 3000"/>
-            </a:avLst>
-          </a:prstGeom>
-        </p:spPr>
-      </p:pic>
-      <p:sp>
-        <p:nvSpPr>
-          <p:cNvPr id="7" name="">
-            <a:extLst xmlns:a="http://schemas.openxmlformats.org/drawingml/2006/main">
-              <a:ext uri="{FF2B5EF4-FFF2-40B4-BE49-F238E27FC236}">
-                <a16:creationId xmlns:a16="http://schemas.microsoft.com/office/drawing/2014/main" id="{2E7E305D-5ADE-42FC-9B30-AD0427C6DC83}"/>
-              </a:ext>
-            </a:extLst>
-          </p:cNvPr>
-          <p:cNvSpPr>
-            <a:spLocks xmlns:a="http://schemas.openxmlformats.org/drawingml/2006/main" noGrp="1"/>
-          </p:cNvSpPr>
-          <p:nvPr/>
-        </p:nvSpPr>
-        <p:spPr>
-          <a:xfrm xmlns:a="http://schemas.openxmlformats.org/drawingml/2006/main">
-            <a:off x="6762750" y="2143125"/>
-            <a:ext cx="4876800" cy="1619250"/>
-          </a:xfrm>
-          <a:prstGeom xmlns:a="http://schemas.openxmlformats.org/drawingml/2006/main" prst="roundRect">
-            <a:avLst>
-              <a:gd name="adj" fmla="val 10588"/>
-            </a:avLst>
-          </a:prstGeom>
-          <a:solidFill xmlns:a="http://schemas.openxmlformats.org/drawingml/2006/main">
-            <a:srgbClr val="F4F8FF"/>
-          </a:solidFill>
-          <a:ln xmlns:a="http://schemas.openxmlformats.org/drawingml/2006/main" w="9525">
-            <a:solidFill>
-              <a:srgbClr val="E9E4D8"/>
-            </a:solidFill>
-            <a:prstDash val="solid"/>
-          </a:ln>
-        </p:spPr>
-        <p:style>
-          <a:lnRef xmlns:a="http://schemas.openxmlformats.org/drawingml/2006/main" idx="0"/>
-          <a:fillRef xmlns:a="http://schemas.openxmlformats.org/drawingml/2006/main" idx="0"/>
-          <a:effectRef xmlns:a="http://schemas.openxmlformats.org/drawingml/2006/main" idx="4"/>
-          <a:fontRef xmlns:a="http://schemas.openxmlformats.org/drawingml/2006/main" idx="major"/>
-        </p:style>
-      </p:sp>
-      <p:sp>
-        <p:nvSpPr>
-          <p:cNvPr id="8" name="">
-            <a:extLst xmlns:a="http://schemas.openxmlformats.org/drawingml/2006/main">
-              <a:ext uri="{FF2B5EF4-FFF2-40B4-BE49-F238E27FC236}">
-                <a16:creationId xmlns:a16="http://schemas.microsoft.com/office/drawing/2014/main" id="{A2DC7162-A4DE-4D19-AF39-7A86DC8D6B78}"/>
-              </a:ext>
-            </a:extLst>
-          </p:cNvPr>
-          <p:cNvSpPr>
-            <a:spLocks xmlns:a="http://schemas.openxmlformats.org/drawingml/2006/main" noGrp="1"/>
-          </p:cNvSpPr>
-          <p:nvPr/>
-        </p:nvSpPr>
-        <p:spPr>
-          <a:xfrm xmlns:a="http://schemas.openxmlformats.org/drawingml/2006/main">
-            <a:off x="6762750" y="2143125"/>
-            <a:ext cx="76200" cy="1619250"/>
-          </a:xfrm>
-          <a:prstGeom xmlns:a="http://schemas.openxmlformats.org/drawingml/2006/main" prst="rect">
-            <a:avLst/>
-          </a:prstGeom>
-          <a:solidFill xmlns:a="http://schemas.openxmlformats.org/drawingml/2006/main">
-            <a:srgbClr val="0B5FFF"/>
-          </a:solidFill>
-          <a:ln xmlns:a="http://schemas.openxmlformats.org/drawingml/2006/main" w="0">
-            <a:solidFill>
-              <a:srgbClr val="0B5FFF"/>
-            </a:solidFill>
-            <a:prstDash val="solid"/>
-          </a:ln>
-        </p:spPr>
-      </p:sp>
-      <p:sp>
-        <p:nvSpPr>
-          <p:cNvPr id="9" name="">
-            <a:extLst xmlns:a="http://schemas.openxmlformats.org/drawingml/2006/main">
-              <a:ext uri="{FF2B5EF4-FFF2-40B4-BE49-F238E27FC236}">
-                <a16:creationId xmlns:a16="http://schemas.microsoft.com/office/drawing/2014/main" id="{44E97D5F-4372-4193-A08D-E443E636BCC3}"/>
-              </a:ext>
-            </a:extLst>
-          </p:cNvPr>
-          <p:cNvSpPr>
-            <a:spLocks xmlns:a="http://schemas.openxmlformats.org/drawingml/2006/main" noGrp="1"/>
-          </p:cNvSpPr>
-          <p:nvPr/>
-        </p:nvSpPr>
-        <p:spPr>
-          <a:xfrm xmlns:a="http://schemas.openxmlformats.org/drawingml/2006/main">
-            <a:off x="7010400" y="2333625"/>
-            <a:ext cx="4419600" cy="361950"/>
-          </a:xfrm>
-          <a:prstGeom xmlns:a="http://schemas.openxmlformats.org/drawingml/2006/main" prst="rect">
-            <a:avLst/>
-          </a:prstGeom>
-          <a:noFill xmlns:a="http://schemas.openxmlformats.org/drawingml/2006/main"/>
-          <a:ln xmlns:a="http://schemas.openxmlformats.org/drawingml/2006/main" w="0">
-            <a:noFill/>
-            <a:prstDash val="solid"/>
-          </a:ln>
-        </p:spPr>
-        <p:txBody>
-          <a:bodyPr xmlns:a="http://schemas.openxmlformats.org/drawingml/2006/main" lIns="0" tIns="0" rIns="0" bIns="0" anchor="t">
-            <a:normAutofit fontScale="100000"/>
-          </a:bodyPr>
-          <a:lstStyle xmlns:a="http://schemas.openxmlformats.org/drawingml/2006/main"/>
-          <a:p xmlns:a="http://schemas.openxmlformats.org/drawingml/2006/main">
-            <a:pPr>
-              <a:buNone/>
-              <a:defRPr sz="1725" b="1">
-                <a:solidFill>
-                  <a:srgbClr val="14213D"/>
-                </a:solidFill>
-                <a:latin typeface="Georgia"/>
-                <a:ea typeface="Georgia"/>
-                <a:cs typeface="Georgia"/>
-              </a:defRPr>
-            </a:pPr>
-            <a:r>
-              <a:rPr sz="1725" b="1">
-                <a:solidFill>
-                  <a:srgbClr val="14213D"/>
-                </a:solidFill>
-                <a:latin typeface="Georgia"/>
-                <a:ea typeface="Georgia"/>
-                <a:cs typeface="Georgia"/>
-              </a:rPr>
-              <a:t>What the platform adds</a:t>
-            </a:r>
-          </a:p>
-        </p:txBody>
-      </p:sp>
-      <p:sp>
-        <p:nvSpPr>
-          <p:cNvPr id="10" name="">
-            <a:extLst xmlns:a="http://schemas.openxmlformats.org/drawingml/2006/main">
-              <a:ext uri="{FF2B5EF4-FFF2-40B4-BE49-F238E27FC236}">
-                <a16:creationId xmlns:a16="http://schemas.microsoft.com/office/drawing/2014/main" id="{A4A2429C-939D-4C2C-8727-F53BA3D9C158}"/>
-              </a:ext>
-            </a:extLst>
-          </p:cNvPr>
-          <p:cNvSpPr>
-            <a:spLocks xmlns:a="http://schemas.openxmlformats.org/drawingml/2006/main" noGrp="1"/>
-          </p:cNvSpPr>
-          <p:nvPr/>
-        </p:nvSpPr>
-        <p:spPr>
-          <a:xfrm xmlns:a="http://schemas.openxmlformats.org/drawingml/2006/main">
-            <a:off x="7010400" y="2781300"/>
-            <a:ext cx="4419600" cy="781050"/>
-          </a:xfrm>
-          <a:prstGeom xmlns:a="http://schemas.openxmlformats.org/drawingml/2006/main" prst="rect">
-            <a:avLst/>
-          </a:prstGeom>
-          <a:noFill xmlns:a="http://schemas.openxmlformats.org/drawingml/2006/main"/>
-          <a:ln xmlns:a="http://schemas.openxmlformats.org/drawingml/2006/main" w="0">
-            <a:noFill/>
-            <a:prstDash val="solid"/>
-          </a:ln>
-        </p:spPr>
-        <p:txBody>
-          <a:bodyPr xmlns:a="http://schemas.openxmlformats.org/drawingml/2006/main" lIns="0" tIns="0" rIns="0" bIns="0" anchor="t">
-            <a:normAutofit fontScale="100000"/>
-          </a:bodyPr>
-          <a:lstStyle xmlns:a="http://schemas.openxmlformats.org/drawingml/2006/main"/>
-          <a:p xmlns:a="http://schemas.openxmlformats.org/drawingml/2006/main">
-            <a:pPr>
-              <a:lnSpc>
-                <a:spcPct val="115000"/>
-              </a:lnSpc>
-              <a:buNone/>
-              <a:defRPr sz="1500">
-                <a:solidFill>
-                  <a:srgbClr val="5C6577"/>
-                </a:solidFill>
-                <a:latin typeface="Avenir Next"/>
-                <a:ea typeface="Avenir Next"/>
-                <a:cs typeface="Avenir Next"/>
-              </a:defRPr>
-            </a:pPr>
-            <a:r>
-              <a:rPr sz="1500">
-                <a:solidFill>
-                  <a:srgbClr val="5C6577"/>
-                </a:solidFill>
-                <a:latin typeface="Avenir Next"/>
-                <a:ea typeface="Avenir Next"/>
-                <a:cs typeface="Avenir Next"/>
-              </a:rPr>
-              <a:t>Dashboard · managed infrastructure · API services · authentication · logs · configuration</a:t>
-            </a:r>
-          </a:p>
-        </p:txBody>
-      </p:sp>
-      <p:sp>
-        <p:nvSpPr>
-          <p:cNvPr id="11" name="">
-            <a:extLst xmlns:a="http://schemas.openxmlformats.org/drawingml/2006/main">
-              <a:ext uri="{FF2B5EF4-FFF2-40B4-BE49-F238E27FC236}">
-                <a16:creationId xmlns:a16="http://schemas.microsoft.com/office/drawing/2014/main" id="{EF0B558B-4286-42B8-8EF5-A7CA375CA847}"/>
-              </a:ext>
-            </a:extLst>
-          </p:cNvPr>
-          <p:cNvSpPr>
-            <a:spLocks xmlns:a="http://schemas.openxmlformats.org/drawingml/2006/main" noGrp="1"/>
-          </p:cNvSpPr>
-          <p:nvPr/>
-        </p:nvSpPr>
-        <p:spPr>
-          <a:xfrm xmlns:a="http://schemas.openxmlformats.org/drawingml/2006/main">
-            <a:off x="6762750" y="4048125"/>
-            <a:ext cx="4876800" cy="1619250"/>
-          </a:xfrm>
-          <a:prstGeom xmlns:a="http://schemas.openxmlformats.org/drawingml/2006/main" prst="roundRect">
-            <a:avLst>
-              <a:gd name="adj" fmla="val 10588"/>
-            </a:avLst>
-          </a:prstGeom>
-          <a:solidFill xmlns:a="http://schemas.openxmlformats.org/drawingml/2006/main">
-            <a:srgbClr val="F1FBF8"/>
-          </a:solidFill>
-          <a:ln xmlns:a="http://schemas.openxmlformats.org/drawingml/2006/main" w="9525">
-            <a:solidFill>
-              <a:srgbClr val="E9E4D8"/>
-            </a:solidFill>
-            <a:prstDash val="solid"/>
-          </a:ln>
-        </p:spPr>
-        <p:style>
-          <a:lnRef xmlns:a="http://schemas.openxmlformats.org/drawingml/2006/main" idx="0"/>
-          <a:fillRef xmlns:a="http://schemas.openxmlformats.org/drawingml/2006/main" idx="0"/>
-          <a:effectRef xmlns:a="http://schemas.openxmlformats.org/drawingml/2006/main" idx="4"/>
-          <a:fontRef xmlns:a="http://schemas.openxmlformats.org/drawingml/2006/main" idx="major"/>
-        </p:style>
-      </p:sp>
-      <p:sp>
-        <p:nvSpPr>
-          <p:cNvPr id="12" name="">
-            <a:extLst xmlns:a="http://schemas.openxmlformats.org/drawingml/2006/main">
-              <a:ext uri="{FF2B5EF4-FFF2-40B4-BE49-F238E27FC236}">
-                <a16:creationId xmlns:a16="http://schemas.microsoft.com/office/drawing/2014/main" id="{6A6C8486-5FCB-447A-AE68-6776F77A6DDC}"/>
-              </a:ext>
-            </a:extLst>
-          </p:cNvPr>
-          <p:cNvSpPr>
-            <a:spLocks xmlns:a="http://schemas.openxmlformats.org/drawingml/2006/main" noGrp="1"/>
-          </p:cNvSpPr>
-          <p:nvPr/>
-        </p:nvSpPr>
-        <p:spPr>
-          <a:xfrm xmlns:a="http://schemas.openxmlformats.org/drawingml/2006/main">
-            <a:off x="6762750" y="4048125"/>
-            <a:ext cx="76200" cy="1619250"/>
-          </a:xfrm>
-          <a:prstGeom xmlns:a="http://schemas.openxmlformats.org/drawingml/2006/main" prst="rect">
-            <a:avLst/>
-          </a:prstGeom>
-          <a:solidFill xmlns:a="http://schemas.openxmlformats.org/drawingml/2006/main">
-            <a:srgbClr val="007C77"/>
-          </a:solidFill>
-          <a:ln xmlns:a="http://schemas.openxmlformats.org/drawingml/2006/main" w="0">
-            <a:solidFill>
-              <a:srgbClr val="007C77"/>
-            </a:solidFill>
-            <a:prstDash val="solid"/>
-          </a:ln>
-        </p:spPr>
-      </p:sp>
-      <p:sp>
-        <p:nvSpPr>
-          <p:cNvPr id="13" name="">
-            <a:extLst xmlns:a="http://schemas.openxmlformats.org/drawingml/2006/main">
-              <a:ext uri="{FF2B5EF4-FFF2-40B4-BE49-F238E27FC236}">
-                <a16:creationId xmlns:a16="http://schemas.microsoft.com/office/drawing/2014/main" id="{641C6C60-CA5A-4B2B-9245-B18491BCA480}"/>
-              </a:ext>
-            </a:extLst>
-          </p:cNvPr>
-          <p:cNvSpPr>
-            <a:spLocks xmlns:a="http://schemas.openxmlformats.org/drawingml/2006/main" noGrp="1"/>
-          </p:cNvSpPr>
-          <p:nvPr/>
-        </p:nvSpPr>
-        <p:spPr>
-          <a:xfrm xmlns:a="http://schemas.openxmlformats.org/drawingml/2006/main">
-            <a:off x="7010400" y="4238625"/>
-            <a:ext cx="4419600" cy="361950"/>
-          </a:xfrm>
-          <a:prstGeom xmlns:a="http://schemas.openxmlformats.org/drawingml/2006/main" prst="rect">
-            <a:avLst/>
-          </a:prstGeom>
-          <a:noFill xmlns:a="http://schemas.openxmlformats.org/drawingml/2006/main"/>
-          <a:ln xmlns:a="http://schemas.openxmlformats.org/drawingml/2006/main" w="0">
-            <a:noFill/>
-            <a:prstDash val="solid"/>
-          </a:ln>
-        </p:spPr>
-        <p:txBody>
-          <a:bodyPr xmlns:a="http://schemas.openxmlformats.org/drawingml/2006/main" lIns="0" tIns="0" rIns="0" bIns="0" anchor="t">
-            <a:normAutofit fontScale="100000"/>
-          </a:bodyPr>
-          <a:lstStyle xmlns:a="http://schemas.openxmlformats.org/drawingml/2006/main"/>
-          <a:p xmlns:a="http://schemas.openxmlformats.org/drawingml/2006/main">
-            <a:pPr>
-              <a:buNone/>
-              <a:defRPr sz="1725" b="1">
-                <a:solidFill>
-                  <a:srgbClr val="14213D"/>
-                </a:solidFill>
-                <a:latin typeface="Georgia"/>
-                <a:ea typeface="Georgia"/>
-                <a:cs typeface="Georgia"/>
-              </a:defRPr>
-            </a:pPr>
-            <a:r>
-              <a:rPr sz="1725" b="1">
-                <a:solidFill>
-                  <a:srgbClr val="14213D"/>
-                </a:solidFill>
-                <a:latin typeface="Georgia"/>
-                <a:ea typeface="Georgia"/>
-                <a:cs typeface="Georgia"/>
-              </a:rPr>
-              <a:t>What PostgreSQL still does</a:t>
-            </a:r>
-          </a:p>
-        </p:txBody>
-      </p:sp>
-      <p:sp>
-        <p:nvSpPr>
-          <p:cNvPr id="14" name="">
-            <a:extLst xmlns:a="http://schemas.openxmlformats.org/drawingml/2006/main">
-              <a:ext uri="{FF2B5EF4-FFF2-40B4-BE49-F238E27FC236}">
-                <a16:creationId xmlns:a16="http://schemas.microsoft.com/office/drawing/2014/main" id="{FD370C2A-FD96-4619-8A67-FD46797A4FD2}"/>
-              </a:ext>
-            </a:extLst>
-          </p:cNvPr>
-          <p:cNvSpPr>
-            <a:spLocks xmlns:a="http://schemas.openxmlformats.org/drawingml/2006/main" noGrp="1"/>
-          </p:cNvSpPr>
-          <p:nvPr/>
-        </p:nvSpPr>
-        <p:spPr>
-          <a:xfrm xmlns:a="http://schemas.openxmlformats.org/drawingml/2006/main">
-            <a:off x="7010400" y="4686300"/>
-            <a:ext cx="4419600" cy="781050"/>
-          </a:xfrm>
-          <a:prstGeom xmlns:a="http://schemas.openxmlformats.org/drawingml/2006/main" prst="rect">
-            <a:avLst/>
-          </a:prstGeom>
-          <a:noFill xmlns:a="http://schemas.openxmlformats.org/drawingml/2006/main"/>
-          <a:ln xmlns:a="http://schemas.openxmlformats.org/drawingml/2006/main" w="0">
-            <a:noFill/>
-            <a:prstDash val="solid"/>
-          </a:ln>
-        </p:spPr>
-        <p:txBody>
-          <a:bodyPr xmlns:a="http://schemas.openxmlformats.org/drawingml/2006/main" lIns="0" tIns="0" rIns="0" bIns="0" anchor="t">
-            <a:normAutofit fontScale="100000"/>
-          </a:bodyPr>
-          <a:lstStyle xmlns:a="http://schemas.openxmlformats.org/drawingml/2006/main"/>
-          <a:p xmlns:a="http://schemas.openxmlformats.org/drawingml/2006/main">
-            <a:pPr>
-              <a:lnSpc>
-                <a:spcPct val="115000"/>
-              </a:lnSpc>
-              <a:buNone/>
-              <a:defRPr sz="1500">
-                <a:solidFill>
-                  <a:srgbClr val="5C6577"/>
-                </a:solidFill>
-                <a:latin typeface="Avenir Next"/>
-                <a:ea typeface="Avenir Next"/>
-                <a:cs typeface="Avenir Next"/>
-              </a:defRPr>
-            </a:pPr>
-            <a:r>
-              <a:rPr sz="1500">
-                <a:solidFill>
-                  <a:srgbClr val="5C6577"/>
-                </a:solidFill>
-                <a:latin typeface="Avenir Next"/>
-                <a:ea typeface="Avenir Next"/>
-                <a:cs typeface="Avenir Next"/>
-              </a:rPr>
-              <a:t>Tables · SQL · constraints · transactions · query planning · indexes · roles</a:t>
-            </a:r>
-          </a:p>
-        </p:txBody>
-      </p:sp>
-    </p:spTree>
-    <p:extLst>
-      <p:ext uri="{BB962C8B-B14F-4D97-AF65-F5344CB8AC3E}">
-        <p14:creationId xmlns:p14="http://schemas.microsoft.com/office/powerpoint/2010/main" val="279149357"/>
-      </p:ext>
-    </p:extLst>
-  </p:cSld>
-</p:sld>
+<ns0:sld xmlns:ns0="http://schemas.openxmlformats.org/presentationml/2006/main" xmlns:ns1="http://schemas.openxmlformats.org/drawingml/2006/main" xmlns:ns2="http://schemas.microsoft.com/office/drawing/2014/main" xmlns:ns3="http://schemas.openxmlformats.org/officeDocument/2006/relationships" xmlns:ns4="http://schemas.microsoft.com/office/powerpoint/2010/main">
+  <ns0:cSld>
+    <ns0:bg>
+      <ns0:bgPr>
+        <ns1:solidFill>
+          <ns1:srgbClr val="F7F3EA"/>
+        </ns1:solidFill>
+      </ns0:bgPr>
+    </ns0:bg>
+    <ns0:spTree>
+      <ns0:nvGrpSpPr>
+        <ns0:cNvPr id="1" name=""/>
+        <ns0:cNvGrpSpPr/>
+        <ns0:nvPr/>
+      </ns0:nvGrpSpPr>
+      <ns0:grpSpPr>
+        <ns1:xfrm/>
+      </ns0:grpSpPr>
+      <ns0:sp>
+        <ns0:nvSpPr>
+          <ns0:cNvPr id="15" name="">
+            <ns1:extLst>
+              <ns1:ext uri="{FF2B5EF4-FFF2-40B4-BE49-F238E27FC236}">
+                <ns2:creationId id="{ECE5B4E2-067F-4DCA-8105-FE99E439C22C}"/>
+              </ns1:ext>
+            </ns1:extLst>
+          </ns0:cNvPr>
+          <ns0:cNvSpPr>
+            <ns1:spLocks noGrp="1"/>
+          </ns0:cNvSpPr>
+          <ns0:nvPr/>
+        </ns0:nvSpPr>
+        <ns0:spPr>
+          <ns1:xfrm>
+            <ns1:off x="552450" y="400050"/>
+            <ns1:ext cx="1447800" cy="323850"/>
+          </ns1:xfrm>
+          <ns1:prstGeom prst="roundRect">
+            <ns1:avLst>
+              <ns1:gd name="adj" fmla="val 50000"/>
+            </ns1:avLst>
+          </ns1:prstGeom>
+          <ns1:solidFill>
+            <ns1:srgbClr val="14213D"/>
+          </ns1:solidFill>
+          <ns1:ln w="9525">
+            <ns1:solidFill>
+              <ns1:srgbClr val="14213D"/>
+            </ns1:solidFill>
+            <ns1:prstDash val="solid"/>
+          </ns1:ln>
+        </ns0:spPr>
+        <ns0:txBody>
+          <ns1:bodyPr lIns="76200" tIns="0" rIns="76200" bIns="0" anchor="ctr">
+            <ns1:normAutofit fontScale="96996"/>
+          </ns1:bodyPr>
+          <ns1:lstStyle/>
+          <ns1:p>
+            <ns1:pPr algn="ctr">
+              <ns1:buNone/>
+              <ns1:defRPr sz="1050" b="1">
+                <ns1:solidFill>
+                  <ns1:srgbClr val="FFFFFF"/>
+                </ns1:solidFill>
+                <ns1:latin typeface="Avenir Next"/>
+                <ns1:ea typeface="Avenir Next"/>
+                <ns1:cs typeface="Avenir Next"/>
+              </ns1:defRPr>
+            </ns1:pPr>
+            <ns1:r>
+              <ns1:rPr sz="1050" b="1">
+                <ns1:solidFill>
+                  <ns1:srgbClr val="FFFFFF"/>
+                </ns1:solidFill>
+                <ns1:latin typeface="Avenir Next"/>
+                <ns1:ea typeface="Avenir Next"/>
+                <ns1:cs typeface="Avenir Next"/>
+              </ns1:rPr>
+              <ns1:t>CLOUD INTERFACE</ns1:t>
+            </ns1:r>
+          </ns1:p>
+        </ns0:txBody>
+      </ns0:sp>
+      <ns0:sp>
+        <ns0:nvSpPr>
+          <ns0:cNvPr id="2" name="slide-title">
+            <ns1:extLst>
+              <ns1:ext uri="{FF2B5EF4-FFF2-40B4-BE49-F238E27FC236}">
+                <ns2:creationId id="{4EE0B915-1960-47EC-9286-DC4133E09536}"/>
+              </ns1:ext>
+            </ns1:extLst>
+          </ns0:cNvPr>
+          <ns0:cNvSpPr>
+            <ns1:spLocks noGrp="1"/>
+          </ns0:cNvSpPr>
+          <ns0:nvPr/>
+        </ns0:nvSpPr>
+        <ns0:spPr>
+          <ns1:xfrm>
+            <ns1:off x="552450" y="876300"/>
+            <ns1:ext cx="11087100" cy="704850"/>
+          </ns1:xfrm>
+          <ns1:prstGeom prst="rect">
+            <ns1:avLst/>
+          </ns1:prstGeom>
+          <ns1:noFill/>
+          <ns1:ln w="0">
+            <ns1:noFill/>
+            <ns1:prstDash val="solid"/>
+          </ns1:ln>
+        </ns0:spPr>
+        <ns0:txBody>
+          <ns1:bodyPr lIns="0" tIns="0" rIns="0" bIns="0" anchor="t">
+            <ns1:normAutofit fontScale="100000"/>
+          </ns1:bodyPr>
+          <ns1:lstStyle/>
+          <ns1:p>
+            <ns1:pPr>
+              <ns1:lnSpc>
+                <ns1:spcPct val="95000"/>
+              </ns1:lnSpc>
+              <ns1:buNone/>
+              <ns1:defRPr sz="3000" b="1">
+                <ns1:solidFill>
+                  <ns1:srgbClr val="14213D"/>
+                </ns1:solidFill>
+                <ns1:latin typeface="Georgia"/>
+                <ns1:ea typeface="Georgia"/>
+                <ns1:cs typeface="Georgia"/>
+              </ns1:defRPr>
+            </ns1:pPr>
+            <ns1:r>
+              <ns1:rPr sz="3000" b="1">
+                <ns1:solidFill>
+                  <ns1:srgbClr val="14213D"/>
+                </ns1:solidFill>
+                <ns1:latin typeface="Georgia"/>
+                <ns1:ea typeface="Georgia"/>
+                <ns1:cs typeface="Georgia"/>
+              </ns1:rPr>
+              <ns1:t>Supabase is a platform built around PostgreSQL</ns1:t>
+            </ns1:r>
+          </ns1:p>
+        </ns0:txBody>
+      </ns0:sp>
+      <ns0:sp>
+        <ns0:nvSpPr>
+          <ns0:cNvPr id="3" name="">
+            <ns1:extLst>
+              <ns1:ext uri="{FF2B5EF4-FFF2-40B4-BE49-F238E27FC236}">
+                <ns2:creationId id="{9C69D724-C471-40F9-BE5A-7CF3D5C1EC8C}"/>
+              </ns1:ext>
+            </ns1:extLst>
+          </ns0:cNvPr>
+          <ns0:cNvSpPr>
+            <ns1:spLocks noGrp="1"/>
+          </ns0:cNvSpPr>
+          <ns0:nvPr/>
+        </ns0:nvSpPr>
+        <ns0:spPr>
+          <ns1:xfrm>
+            <ns1:off x="571500" y="1562100"/>
+            <ns1:ext cx="10477500" cy="381000"/>
+          </ns1:xfrm>
+          <ns1:prstGeom prst="rect">
+            <ns1:avLst/>
+          </ns1:prstGeom>
+          <ns1:noFill/>
+          <ns1:ln w="0">
+            <ns1:noFill/>
+            <ns1:prstDash val="solid"/>
+          </ns1:ln>
+        </ns0:spPr>
+        <ns0:txBody>
+          <ns1:bodyPr lIns="0" tIns="0" rIns="0" bIns="0" anchor="t">
+            <ns1:normAutofit fontScale="100000"/>
+          </ns1:bodyPr>
+          <ns1:lstStyle/>
+          <ns1:p>
+            <ns1:pPr>
+              <ns1:buNone/>
+              <ns1:defRPr sz="1425">
+                <ns1:solidFill>
+                  <ns1:srgbClr val="5C6577"/>
+                </ns1:solidFill>
+                <ns1:latin typeface="Avenir Next"/>
+                <ns1:ea typeface="Avenir Next"/>
+                <ns1:cs typeface="Avenir Next"/>
+              </ns1:defRPr>
+            </ns1:pPr>
+            <ns1:r>
+              <ns1:rPr sz="1425">
+                <ns1:solidFill>
+                  <ns1:srgbClr val="5C6577"/>
+                </ns1:solidFill>
+                <ns1:latin typeface="Avenir Next"/>
+                <ns1:ea typeface="Avenir Next"/>
+                <ns1:cs typeface="Avenir Next"/>
+              </ns1:rPr>
+              <ns1:t>The dashboard exposes projects and services; PostgreSQL remains the database engine.</ns1:t>
+            </ns1:r>
+          </ns1:p>
+        </ns0:txBody>
+      </ns0:sp>
+      <ns0:sp>
+        <ns0:nvSpPr>
+          <ns0:cNvPr id="4" name="">
+            <ns1:extLst>
+              <ns1:ext uri="{FF2B5EF4-FFF2-40B4-BE49-F238E27FC236}">
+                <ns2:creationId id="{EC90CB12-698B-49BA-8F98-BAD9E65B7181}"/>
+              </ns1:ext>
+            </ns1:extLst>
+          </ns0:cNvPr>
+          <ns0:cNvSpPr>
+            <ns1:spLocks noGrp="1"/>
+          </ns0:cNvSpPr>
+          <ns0:nvPr/>
+        </ns0:nvSpPr>
+        <ns0:spPr>
+          <ns1:xfrm>
+            <ns1:off x="11144250" y="6334125"/>
+            <ns1:ext cx="495300" cy="228600"/>
+          </ns1:xfrm>
+          <ns1:prstGeom prst="rect">
+            <ns1:avLst/>
+          </ns1:prstGeom>
+          <ns1:noFill/>
+          <ns1:ln w="0">
+            <ns1:noFill/>
+            <ns1:prstDash val="solid"/>
+          </ns1:ln>
+        </ns0:spPr>
+        <ns0:txBody>
+          <ns1:bodyPr wrap="square" lIns="0" tIns="0" rIns="0" bIns="0" anchor="t">
+            <ns1:noAutofit/>
+          </ns1:bodyPr>
+          <ns1:lstStyle/>
+          <ns1:p>
+            <ns1:pPr algn="r">
+              <ns1:buNone/>
+              <ns1:defRPr sz="1050" b="1">
+                <ns1:solidFill>
+                  <ns1:srgbClr val="5C6577"/>
+                </ns1:solidFill>
+                <ns1:latin typeface="Menlo"/>
+                <ns1:ea typeface="Menlo"/>
+                <ns1:cs typeface="Menlo"/>
+              </ns1:defRPr>
+            </ns1:pPr>
+            <ns1:r>
+              <ns1:rPr sz="1050" b="1">
+                <ns1:solidFill>
+                  <ns1:srgbClr val="5C6577"/>
+                </ns1:solidFill>
+                <ns1:latin typeface="Menlo"/>
+                <ns1:ea typeface="Menlo"/>
+                <ns1:cs typeface="Menlo"/>
+              </ns1:rPr>
+              <ns1:t>05</ns1:t>
+            </ns1:r>
+          </ns1:p>
+        </ns0:txBody>
+      </ns0:sp>
+      <ns0:sp>
+        <ns0:nvSpPr>
+          <ns0:cNvPr id="5" name="">
+            <ns1:extLst>
+              <ns1:ext uri="{FF2B5EF4-FFF2-40B4-BE49-F238E27FC236}">
+                <ns2:creationId id="{A420DB7B-3F95-4CE2-B782-695A52096B0F}"/>
+              </ns1:ext>
+            </ns1:extLst>
+          </ns0:cNvPr>
+          <ns0:cNvSpPr>
+            <ns1:spLocks noGrp="1"/>
+          </ns0:cNvSpPr>
+          <ns0:nvPr/>
+        </ns0:nvSpPr>
+        <ns0:spPr>
+          <ns1:xfrm>
+            <ns1:off x="552450" y="2038350"/>
+            <ns1:ext cx="5810250" cy="4095750"/>
+          </ns1:xfrm>
+          <ns1:prstGeom prst="roundRect">
+            <ns1:avLst>
+              <ns1:gd name="adj" fmla="val 4186"/>
+            </ns1:avLst>
+          </ns1:prstGeom>
+          <ns1:solidFill>
+            <ns1:srgbClr val="FFFFFF"/>
+          </ns1:solidFill>
+          <ns1:ln w="9525">
+            <ns1:solidFill>
+              <ns1:srgbClr val="E9E4D8"/>
+            </ns1:solidFill>
+            <ns1:prstDash val="solid"/>
+          </ns1:ln>
+        </ns0:spPr>
+      </ns0:sp>
+      <ns0:pic>
+        <ns0:nvPicPr>
+          <ns0:cNvPr id="22" name="" descr="Supabase project overview, captured August 25, 2026 with account details redacted. The visible dashboard reports Healthy status, Nano compute, no connected GitHub repository, and No backups. A Primary Database panel displays CPU, disk, RAM, and connection usage. These management controls surround the PostgreSQL database engine."/>
+          <ns0:cNvPicPr>
+            <ns1:picLocks noChangeAspect="1"/>
+          </ns0:cNvPicPr>
+          <ns0:nvPr/>
+        </ns0:nvPicPr>
+        <ns0:blipFill>
+          <ns1:blip ns3:embed="Ra9a661b4d442464f"/>
+          <ns1:srcRect l="0" t="21016" r="0" b="21016"/>
+          <ns1:stretch>
+            <ns1:fillRect l="0" t="0" r="0" b="0"/>
+          </ns1:stretch>
+        </ns0:blipFill>
+        <ns0:spPr>
+          <ns1:xfrm>
+            <ns1:off x="714375" y="2181225"/>
+            <ns1:ext cx="5486400" cy="3810000"/>
+          </ns1:xfrm>
+          <ns1:prstGeom prst="roundRect">
+            <ns1:avLst>
+              <ns1:gd name="adj" fmla="val 3000"/>
+            </ns1:avLst>
+          </ns1:prstGeom>
+        </ns0:spPr>
+      </ns0:pic>
+      <ns0:sp>
+        <ns0:nvSpPr>
+          <ns0:cNvPr id="7" name="">
+            <ns1:extLst>
+              <ns1:ext uri="{FF2B5EF4-FFF2-40B4-BE49-F238E27FC236}">
+                <ns2:creationId id="{2E7E305D-5ADE-42FC-9B30-AD0427C6DC83}"/>
+              </ns1:ext>
+            </ns1:extLst>
+          </ns0:cNvPr>
+          <ns0:cNvSpPr>
+            <ns1:spLocks noGrp="1"/>
+          </ns0:cNvSpPr>
+          <ns0:nvPr/>
+        </ns0:nvSpPr>
+        <ns0:spPr>
+          <ns1:xfrm>
+            <ns1:off x="6762750" y="2143125"/>
+            <ns1:ext cx="4876800" cy="1619250"/>
+          </ns1:xfrm>
+          <ns1:prstGeom prst="roundRect">
+            <ns1:avLst>
+              <ns1:gd name="adj" fmla="val 10588"/>
+            </ns1:avLst>
+          </ns1:prstGeom>
+          <ns1:solidFill>
+            <ns1:srgbClr val="F4F8FF"/>
+          </ns1:solidFill>
+          <ns1:ln w="9525">
+            <ns1:solidFill>
+              <ns1:srgbClr val="E9E4D8"/>
+            </ns1:solidFill>
+            <ns1:prstDash val="solid"/>
+          </ns1:ln>
+        </ns0:spPr>
+        <ns0:style>
+          <ns1:lnRef idx="0"/>
+          <ns1:fillRef idx="0"/>
+          <ns1:effectRef idx="4"/>
+          <ns1:fontRef idx="major"/>
+        </ns0:style>
+      </ns0:sp>
+      <ns0:sp>
+        <ns0:nvSpPr>
+          <ns0:cNvPr id="8" name="">
+            <ns1:extLst>
+              <ns1:ext uri="{FF2B5EF4-FFF2-40B4-BE49-F238E27FC236}">
+                <ns2:creationId id="{A2DC7162-A4DE-4D19-AF39-7A86DC8D6B78}"/>
+              </ns1:ext>
+            </ns1:extLst>
+          </ns0:cNvPr>
+          <ns0:cNvSpPr>
+            <ns1:spLocks noGrp="1"/>
+          </ns0:cNvSpPr>
+          <ns0:nvPr/>
+        </ns0:nvSpPr>
+        <ns0:spPr>
+          <ns1:xfrm>
+            <ns1:off x="6762750" y="2143125"/>
+            <ns1:ext cx="76200" cy="1619250"/>
+          </ns1:xfrm>
+          <ns1:prstGeom prst="rect">
+            <ns1:avLst/>
+          </ns1:prstGeom>
+          <ns1:solidFill>
+            <ns1:srgbClr val="0B5FFF"/>
+          </ns1:solidFill>
+          <ns1:ln w="0">
+            <ns1:solidFill>
+              <ns1:srgbClr val="0B5FFF"/>
+            </ns1:solidFill>
+            <ns1:prstDash val="solid"/>
+          </ns1:ln>
+        </ns0:spPr>
+      </ns0:sp>
+      <ns0:sp>
+        <ns0:nvSpPr>
+          <ns0:cNvPr id="9" name="">
+            <ns1:extLst>
+              <ns1:ext uri="{FF2B5EF4-FFF2-40B4-BE49-F238E27FC236}">
+                <ns2:creationId id="{44E97D5F-4372-4193-A08D-E443E636BCC3}"/>
+              </ns1:ext>
+            </ns1:extLst>
+          </ns0:cNvPr>
+          <ns0:cNvSpPr>
+            <ns1:spLocks noGrp="1"/>
+          </ns0:cNvSpPr>
+          <ns0:nvPr/>
+        </ns0:nvSpPr>
+        <ns0:spPr>
+          <ns1:xfrm>
+            <ns1:off x="7010400" y="2333625"/>
+            <ns1:ext cx="4419600" cy="361950"/>
+          </ns1:xfrm>
+          <ns1:prstGeom prst="rect">
+            <ns1:avLst/>
+          </ns1:prstGeom>
+          <ns1:noFill/>
+          <ns1:ln w="0">
+            <ns1:noFill/>
+            <ns1:prstDash val="solid"/>
+          </ns1:ln>
+        </ns0:spPr>
+        <ns0:txBody>
+          <ns1:bodyPr lIns="0" tIns="0" rIns="0" bIns="0" anchor="t">
+            <ns1:normAutofit fontScale="100000"/>
+          </ns1:bodyPr>
+          <ns1:lstStyle/>
+          <ns1:p>
+            <ns1:pPr>
+              <ns1:buNone/>
+              <ns1:defRPr sz="1725" b="1">
+                <ns1:solidFill>
+                  <ns1:srgbClr val="14213D"/>
+                </ns1:solidFill>
+                <ns1:latin typeface="Georgia"/>
+                <ns1:ea typeface="Georgia"/>
+                <ns1:cs typeface="Georgia"/>
+              </ns1:defRPr>
+            </ns1:pPr>
+            <ns1:r>
+              <ns1:rPr sz="1725" b="1">
+                <ns1:solidFill>
+                  <ns1:srgbClr val="14213D"/>
+                </ns1:solidFill>
+                <ns1:latin typeface="Georgia"/>
+                <ns1:ea typeface="Georgia"/>
+                <ns1:cs typeface="Georgia"/>
+              </ns1:rPr>
+              <ns1:t>What the platform adds</ns1:t>
+            </ns1:r>
+          </ns1:p>
+        </ns0:txBody>
+      </ns0:sp>
+      <ns0:sp>
+        <ns0:nvSpPr>
+          <ns0:cNvPr id="10" name="">
+            <ns1:extLst>
+              <ns1:ext uri="{FF2B5EF4-FFF2-40B4-BE49-F238E27FC236}">
+                <ns2:creationId id="{A4A2429C-939D-4C2C-8727-F53BA3D9C158}"/>
+              </ns1:ext>
+            </ns1:extLst>
+          </ns0:cNvPr>
+          <ns0:cNvSpPr>
+            <ns1:spLocks noGrp="1"/>
+          </ns0:cNvSpPr>
+          <ns0:nvPr/>
+        </ns0:nvSpPr>
+        <ns0:spPr>
+          <ns1:xfrm>
+            <ns1:off x="7010400" y="2781300"/>
+            <ns1:ext cx="4419600" cy="781050"/>
+          </ns1:xfrm>
+          <ns1:prstGeom prst="rect">
+            <ns1:avLst/>
+          </ns1:prstGeom>
+          <ns1:noFill/>
+          <ns1:ln w="0">
+            <ns1:noFill/>
+            <ns1:prstDash val="solid"/>
+          </ns1:ln>
+        </ns0:spPr>
+        <ns0:txBody>
+          <ns1:bodyPr lIns="0" tIns="0" rIns="0" bIns="0" anchor="t">
+            <ns1:normAutofit fontScale="100000"/>
+          </ns1:bodyPr>
+          <ns1:lstStyle/>
+          <ns1:p>
+            <ns1:pPr>
+              <ns1:lnSpc>
+                <ns1:spcPct val="115000"/>
+              </ns1:lnSpc>
+              <ns1:buNone/>
+              <ns1:defRPr sz="1500">
+                <ns1:solidFill>
+                  <ns1:srgbClr val="5C6577"/>
+                </ns1:solidFill>
+                <ns1:latin typeface="Avenir Next"/>
+                <ns1:ea typeface="Avenir Next"/>
+                <ns1:cs typeface="Avenir Next"/>
+              </ns1:defRPr>
+            </ns1:pPr>
+            <ns1:r>
+              <ns1:rPr sz="1500">
+                <ns1:solidFill>
+                  <ns1:srgbClr val="5C6577"/>
+                </ns1:solidFill>
+                <ns1:latin typeface="Avenir Next"/>
+                <ns1:ea typeface="Avenir Next"/>
+                <ns1:cs typeface="Avenir Next"/>
+              </ns1:rPr>
+              <ns1:t>Dashboard · managed infrastructure · API services · authentication · logs · configuration</ns1:t>
+            </ns1:r>
+          </ns1:p>
+        </ns0:txBody>
+      </ns0:sp>
+      <ns0:sp>
+        <ns0:nvSpPr>
+          <ns0:cNvPr id="11" name="">
+            <ns1:extLst>
+              <ns1:ext uri="{FF2B5EF4-FFF2-40B4-BE49-F238E27FC236}">
+                <ns2:creationId id="{EF0B558B-4286-42B8-8EF5-A7CA375CA847}"/>
+              </ns1:ext>
+            </ns1:extLst>
+          </ns0:cNvPr>
+          <ns0:cNvSpPr>
+            <ns1:spLocks noGrp="1"/>
+          </ns0:cNvSpPr>
+          <ns0:nvPr/>
+        </ns0:nvSpPr>
+        <ns0:spPr>
+          <ns1:xfrm>
+            <ns1:off x="6762750" y="4048125"/>
+            <ns1:ext cx="4876800" cy="1619250"/>
+          </ns1:xfrm>
+          <ns1:prstGeom prst="roundRect">
+            <ns1:avLst>
+              <ns1:gd name="adj" fmla="val 10588"/>
+            </ns1:avLst>
+          </ns1:prstGeom>
+          <ns1:solidFill>
+            <ns1:srgbClr val="F1FBF8"/>
+          </ns1:solidFill>
+          <ns1:ln w="9525">
+            <ns1:solidFill>
+              <ns1:srgbClr val="E9E4D8"/>
+            </ns1:solidFill>
+            <ns1:prstDash val="solid"/>
+          </ns1:ln>
+        </ns0:spPr>
+        <ns0:style>
+          <ns1:lnRef idx="0"/>
+          <ns1:fillRef idx="0"/>
+          <ns1:effectRef idx="4"/>
+          <ns1:fontRef idx="major"/>
+        </ns0:style>
+      </ns0:sp>
+      <ns0:sp>
+        <ns0:nvSpPr>
+          <ns0:cNvPr id="12" name="">
+            <ns1:extLst>
+              <ns1:ext uri="{FF2B5EF4-FFF2-40B4-BE49-F238E27FC236}">
+                <ns2:creationId id="{6A6C8486-5FCB-447A-AE68-6776F77A6DDC}"/>
+              </ns1:ext>
+            </ns1:extLst>
+          </ns0:cNvPr>
+          <ns0:cNvSpPr>
+            <ns1:spLocks noGrp="1"/>
+          </ns0:cNvSpPr>
+          <ns0:nvPr/>
+        </ns0:nvSpPr>
+        <ns0:spPr>
+          <ns1:xfrm>
+            <ns1:off x="6762750" y="4048125"/>
+            <ns1:ext cx="76200" cy="1619250"/>
+          </ns1:xfrm>
+          <ns1:prstGeom prst="rect">
+            <ns1:avLst/>
+          </ns1:prstGeom>
+          <ns1:solidFill>
+            <ns1:srgbClr val="007C77"/>
+          </ns1:solidFill>
+          <ns1:ln w="0">
+            <ns1:solidFill>
+              <ns1:srgbClr val="007C77"/>
+            </ns1:solidFill>
+            <ns1:prstDash val="solid"/>
+          </ns1:ln>
+        </ns0:spPr>
+      </ns0:sp>
+      <ns0:sp>
+        <ns0:nvSpPr>
+          <ns0:cNvPr id="13" name="">
+            <ns1:extLst>
+              <ns1:ext uri="{FF2B5EF4-FFF2-40B4-BE49-F238E27FC236}">
+                <ns2:creationId id="{641C6C60-CA5A-4B2B-9245-B18491BCA480}"/>
+              </ns1:ext>
+            </ns1:extLst>
+          </ns0:cNvPr>
+          <ns0:cNvSpPr>
+            <ns1:spLocks noGrp="1"/>
+          </ns0:cNvSpPr>
+          <ns0:nvPr/>
+        </ns0:nvSpPr>
+        <ns0:spPr>
+          <ns1:xfrm>
+            <ns1:off x="7010400" y="4238625"/>
+            <ns1:ext cx="4419600" cy="361950"/>
+          </ns1:xfrm>
+          <ns1:prstGeom prst="rect">
+            <ns1:avLst/>
+          </ns1:prstGeom>
+          <ns1:noFill/>
+          <ns1:ln w="0">
+            <ns1:noFill/>
+            <ns1:prstDash val="solid"/>
+          </ns1:ln>
+        </ns0:spPr>
+        <ns0:txBody>
+          <ns1:bodyPr lIns="0" tIns="0" rIns="0" bIns="0" anchor="t">
+            <ns1:normAutofit fontScale="100000"/>
+          </ns1:bodyPr>
+          <ns1:lstStyle/>
+          <ns1:p>
+            <ns1:pPr>
+              <ns1:buNone/>
+              <ns1:defRPr sz="1725" b="1">
+                <ns1:solidFill>
+                  <ns1:srgbClr val="14213D"/>
+                </ns1:solidFill>
+                <ns1:latin typeface="Georgia"/>
+                <ns1:ea typeface="Georgia"/>
+                <ns1:cs typeface="Georgia"/>
+              </ns1:defRPr>
+            </ns1:pPr>
+            <ns1:r>
+              <ns1:rPr sz="1725" b="1">
+                <ns1:solidFill>
+                  <ns1:srgbClr val="14213D"/>
+                </ns1:solidFill>
+                <ns1:latin typeface="Georgia"/>
+                <ns1:ea typeface="Georgia"/>
+                <ns1:cs typeface="Georgia"/>
+              </ns1:rPr>
+              <ns1:t>What PostgreSQL still does</ns1:t>
+            </ns1:r>
+          </ns1:p>
+        </ns0:txBody>
+      </ns0:sp>
+      <ns0:sp>
+        <ns0:nvSpPr>
+          <ns0:cNvPr id="14" name="">
+            <ns1:extLst>
+              <ns1:ext uri="{FF2B5EF4-FFF2-40B4-BE49-F238E27FC236}">
+                <ns2:creationId id="{FD370C2A-FD96-4619-8A67-FD46797A4FD2}"/>
+              </ns1:ext>
+            </ns1:extLst>
+          </ns0:cNvPr>
+          <ns0:cNvSpPr>
+            <ns1:spLocks noGrp="1"/>
+          </ns0:cNvSpPr>
+          <ns0:nvPr/>
+        </ns0:nvSpPr>
+        <ns0:spPr>
+          <ns1:xfrm>
+            <ns1:off x="7010400" y="4686300"/>
+            <ns1:ext cx="4419600" cy="781050"/>
+          </ns1:xfrm>
+          <ns1:prstGeom prst="rect">
+            <ns1:avLst/>
+          </ns1:prstGeom>
+          <ns1:noFill/>
+          <ns1:ln w="0">
+            <ns1:noFill/>
+            <ns1:prstDash val="solid"/>
+          </ns1:ln>
+        </ns0:spPr>
+        <ns0:txBody>
+          <ns1:bodyPr lIns="0" tIns="0" rIns="0" bIns="0" anchor="t">
+            <ns1:normAutofit fontScale="100000"/>
+          </ns1:bodyPr>
+          <ns1:lstStyle/>
+          <ns1:p>
+            <ns1:pPr>
+              <ns1:lnSpc>
+                <ns1:spcPct val="115000"/>
+              </ns1:lnSpc>
+              <ns1:buNone/>
+              <ns1:defRPr sz="1500">
+                <ns1:solidFill>
+                  <ns1:srgbClr val="5C6577"/>
+                </ns1:solidFill>
+                <ns1:latin typeface="Avenir Next"/>
+                <ns1:ea typeface="Avenir Next"/>
+                <ns1:cs typeface="Avenir Next"/>
+              </ns1:defRPr>
+            </ns1:pPr>
+            <ns1:r>
+              <ns1:rPr sz="1500">
+                <ns1:solidFill>
+                  <ns1:srgbClr val="5C6577"/>
+                </ns1:solidFill>
+                <ns1:latin typeface="Avenir Next"/>
+                <ns1:ea typeface="Avenir Next"/>
+                <ns1:cs typeface="Avenir Next"/>
+              </ns1:rPr>
+              <ns1:t>Tables · SQL · constraints · transactions · query planning · indexes · roles</ns1:t>
+            </ns1:r>
+          </ns1:p>
+        </ns0:txBody>
+      </ns0:sp>
+    </ns0:spTree>
+    <ns0:extLst>
+      <ns0:ext uri="{BB962C8B-B14F-4D97-AF65-F5344CB8AC3E}">
+        <ns4:creationId val="279149357"/>
+      </ns0:ext>
+    </ns0:extLst>
+  </ns0:cSld>
+</ns0:sld>
 </file>
 
 <file path=ppt/slides/slide6.xml><?xml version="1.0" encoding="utf-8"?>
-<p:sld xmlns:p="http://schemas.openxmlformats.org/presentationml/2006/main">
-  <p:cSld>
-    <p:bg>
-      <p:bgPr>
-        <a:solidFill xmlns:a="http://schemas.openxmlformats.org/drawingml/2006/main">
-          <a:srgbClr val="F7F3EA"/>
-        </a:solidFill>
-      </p:bgPr>
-    </p:bg>
-    <p:spTree>
-      <p:nvGrpSpPr>
-        <p:cNvPr id="1" name=""/>
-        <p:cNvGrpSpPr/>
-        <p:nvPr/>
-      </p:nvGrpSpPr>
-      <p:grpSpPr>
-        <a:xfrm xmlns:a="http://schemas.openxmlformats.org/drawingml/2006/main"/>
-      </p:grpSpPr>
-      <p:sp>
-        <p:nvSpPr>
-          <p:cNvPr id="16" name="">
-            <a:extLst xmlns:a="http://schemas.openxmlformats.org/drawingml/2006/main">
-              <a:ext uri="{FF2B5EF4-FFF2-40B4-BE49-F238E27FC236}">
-                <a16:creationId xmlns:a16="http://schemas.microsoft.com/office/drawing/2014/main" id="{31896894-5F88-4FA0-B8F7-A3B9556AC8AA}"/>
-              </a:ext>
-            </a:extLst>
-          </p:cNvPr>
-          <p:cNvSpPr>
-            <a:spLocks xmlns:a="http://schemas.openxmlformats.org/drawingml/2006/main" noGrp="1"/>
-          </p:cNvSpPr>
-          <p:nvPr/>
-        </p:nvSpPr>
-        <p:spPr>
-          <a:xfrm xmlns:a="http://schemas.openxmlformats.org/drawingml/2006/main">
-            <a:off x="552450" y="400050"/>
-            <a:ext cx="1447800" cy="323850"/>
-          </a:xfrm>
-          <a:prstGeom xmlns:a="http://schemas.openxmlformats.org/drawingml/2006/main" prst="roundRect">
-            <a:avLst>
-              <a:gd name="adj" fmla="val 50000"/>
-            </a:avLst>
-          </a:prstGeom>
-          <a:solidFill xmlns:a="http://schemas.openxmlformats.org/drawingml/2006/main">
-            <a:srgbClr val="14213D"/>
-          </a:solidFill>
-          <a:ln xmlns:a="http://schemas.openxmlformats.org/drawingml/2006/main" w="9525">
-            <a:solidFill>
-              <a:srgbClr val="14213D"/>
-            </a:solidFill>
-            <a:prstDash val="solid"/>
-          </a:ln>
-        </p:spPr>
-        <p:txBody>
-          <a:bodyPr xmlns:a="http://schemas.openxmlformats.org/drawingml/2006/main" lIns="76200" tIns="0" rIns="76200" bIns="0" anchor="ctr">
-            <a:normAutofit fontScale="96996"/>
-          </a:bodyPr>
-          <a:lstStyle xmlns:a="http://schemas.openxmlformats.org/drawingml/2006/main"/>
-          <a:p xmlns:a="http://schemas.openxmlformats.org/drawingml/2006/main">
-            <a:pPr algn="ctr">
-              <a:buNone/>
-              <a:defRPr sz="1050" b="1">
-                <a:solidFill>
-                  <a:srgbClr val="FFFFFF"/>
-                </a:solidFill>
-                <a:latin typeface="Avenir Next"/>
-                <a:ea typeface="Avenir Next"/>
-                <a:cs typeface="Avenir Next"/>
-              </a:defRPr>
-            </a:pPr>
-            <a:r>
-              <a:rPr sz="1050" b="1">
-                <a:solidFill>
-                  <a:srgbClr val="FFFFFF"/>
-                </a:solidFill>
-                <a:latin typeface="Avenir Next"/>
-                <a:ea typeface="Avenir Next"/>
-                <a:cs typeface="Avenir Next"/>
-              </a:rPr>
-              <a:t>CLOUD INTERFACE</a:t>
-            </a:r>
-          </a:p>
-        </p:txBody>
-      </p:sp>
-      <p:sp>
-        <p:nvSpPr>
-          <p:cNvPr id="2" name="slide-title">
-            <a:extLst xmlns:a="http://schemas.openxmlformats.org/drawingml/2006/main">
-              <a:ext uri="{FF2B5EF4-FFF2-40B4-BE49-F238E27FC236}">
-                <a16:creationId xmlns:a16="http://schemas.microsoft.com/office/drawing/2014/main" id="{88388ED0-F419-4FDC-A263-1289F17C48A1}"/>
-              </a:ext>
-            </a:extLst>
-          </p:cNvPr>
-          <p:cNvSpPr>
-            <a:spLocks xmlns:a="http://schemas.openxmlformats.org/drawingml/2006/main" noGrp="1"/>
-          </p:cNvSpPr>
-          <p:nvPr/>
-        </p:nvSpPr>
-        <p:spPr>
-          <a:xfrm xmlns:a="http://schemas.openxmlformats.org/drawingml/2006/main">
-            <a:off x="552450" y="876300"/>
-            <a:ext cx="11087100" cy="704850"/>
-          </a:xfrm>
-          <a:prstGeom xmlns:a="http://schemas.openxmlformats.org/drawingml/2006/main" prst="rect">
-            <a:avLst/>
-          </a:prstGeom>
-          <a:noFill xmlns:a="http://schemas.openxmlformats.org/drawingml/2006/main"/>
-          <a:ln xmlns:a="http://schemas.openxmlformats.org/drawingml/2006/main" w="0">
-            <a:noFill/>
-            <a:prstDash val="solid"/>
-          </a:ln>
-        </p:spPr>
-        <p:txBody>
-          <a:bodyPr xmlns:a="http://schemas.openxmlformats.org/drawingml/2006/main" lIns="0" tIns="0" rIns="0" bIns="0" anchor="t">
-            <a:normAutofit fontScale="100000"/>
-          </a:bodyPr>
-          <a:lstStyle xmlns:a="http://schemas.openxmlformats.org/drawingml/2006/main"/>
-          <a:p xmlns:a="http://schemas.openxmlformats.org/drawingml/2006/main">
-            <a:pPr>
-              <a:lnSpc>
-                <a:spcPct val="95000"/>
-              </a:lnSpc>
-              <a:buNone/>
-              <a:defRPr sz="3000" b="1">
-                <a:solidFill>
-                  <a:srgbClr val="14213D"/>
-                </a:solidFill>
-                <a:latin typeface="Georgia"/>
-                <a:ea typeface="Georgia"/>
-                <a:cs typeface="Georgia"/>
-              </a:defRPr>
-            </a:pPr>
-            <a:r>
-              <a:rPr sz="3000" b="1">
-                <a:solidFill>
-                  <a:srgbClr val="14213D"/>
-                </a:solidFill>
-                <a:latin typeface="Georgia"/>
-                <a:ea typeface="Georgia"/>
-                <a:cs typeface="Georgia"/>
-              </a:rPr>
-              <a:t>MongoDB Atlas operates MongoDB in the cloud</a:t>
-            </a:r>
-          </a:p>
-        </p:txBody>
-      </p:sp>
-      <p:sp>
-        <p:nvSpPr>
-          <p:cNvPr id="3" name="">
-            <a:extLst xmlns:a="http://schemas.openxmlformats.org/drawingml/2006/main">
-              <a:ext uri="{FF2B5EF4-FFF2-40B4-BE49-F238E27FC236}">
-                <a16:creationId xmlns:a16="http://schemas.microsoft.com/office/drawing/2014/main" id="{D26C06D8-0780-4513-AB3F-492DC56C46AA}"/>
-              </a:ext>
-            </a:extLst>
-          </p:cNvPr>
-          <p:cNvSpPr>
-            <a:spLocks xmlns:a="http://schemas.openxmlformats.org/drawingml/2006/main" noGrp="1"/>
-          </p:cNvSpPr>
-          <p:nvPr/>
-        </p:nvSpPr>
-        <p:spPr>
-          <a:xfrm xmlns:a="http://schemas.openxmlformats.org/drawingml/2006/main">
-            <a:off x="571500" y="1562100"/>
-            <a:ext cx="10477500" cy="381000"/>
-          </a:xfrm>
-          <a:prstGeom xmlns:a="http://schemas.openxmlformats.org/drawingml/2006/main" prst="rect">
-            <a:avLst/>
-          </a:prstGeom>
-          <a:noFill xmlns:a="http://schemas.openxmlformats.org/drawingml/2006/main"/>
-          <a:ln xmlns:a="http://schemas.openxmlformats.org/drawingml/2006/main" w="0">
-            <a:noFill/>
-            <a:prstDash val="solid"/>
-          </a:ln>
-        </p:spPr>
-        <p:txBody>
-          <a:bodyPr xmlns:a="http://schemas.openxmlformats.org/drawingml/2006/main" lIns="0" tIns="0" rIns="0" bIns="0" anchor="t">
-            <a:normAutofit fontScale="100000"/>
-          </a:bodyPr>
-          <a:lstStyle xmlns:a="http://schemas.openxmlformats.org/drawingml/2006/main"/>
-          <a:p xmlns:a="http://schemas.openxmlformats.org/drawingml/2006/main">
-            <a:pPr>
-              <a:buNone/>
-              <a:defRPr sz="1425">
-                <a:solidFill>
-                  <a:srgbClr val="5C6577"/>
-                </a:solidFill>
-                <a:latin typeface="Avenir Next"/>
-                <a:ea typeface="Avenir Next"/>
-                <a:cs typeface="Avenir Next"/>
-              </a:defRPr>
-            </a:pPr>
-            <a:r>
-              <a:rPr sz="1425">
-                <a:solidFill>
-                  <a:srgbClr val="5C6577"/>
-                </a:solidFill>
-                <a:latin typeface="Avenir Next"/>
-                <a:ea typeface="Avenir Next"/>
-                <a:cs typeface="Avenir Next"/>
-              </a:rPr>
-              <a:t>Projects, clusters, users, network rules, and data tools surround the document database.</a:t>
-            </a:r>
-          </a:p>
-        </p:txBody>
-      </p:sp>
-      <p:sp>
-        <p:nvSpPr>
-          <p:cNvPr id="4" name="">
-            <a:extLst xmlns:a="http://schemas.openxmlformats.org/drawingml/2006/main">
-              <a:ext uri="{FF2B5EF4-FFF2-40B4-BE49-F238E27FC236}">
-                <a16:creationId xmlns:a16="http://schemas.microsoft.com/office/drawing/2014/main" id="{4D4F6477-AD3C-41DA-A4AD-841179DE5AE4}"/>
-              </a:ext>
-            </a:extLst>
-          </p:cNvPr>
-          <p:cNvSpPr>
-            <a:spLocks xmlns:a="http://schemas.openxmlformats.org/drawingml/2006/main" noGrp="1"/>
-          </p:cNvSpPr>
-          <p:nvPr/>
-        </p:nvSpPr>
-        <p:spPr>
-          <a:xfrm xmlns:a="http://schemas.openxmlformats.org/drawingml/2006/main">
-            <a:off x="11144250" y="6334125"/>
-            <a:ext cx="495300" cy="228600"/>
-          </a:xfrm>
-          <a:prstGeom xmlns:a="http://schemas.openxmlformats.org/drawingml/2006/main" prst="rect">
-            <a:avLst/>
-          </a:prstGeom>
-          <a:noFill xmlns:a="http://schemas.openxmlformats.org/drawingml/2006/main"/>
-          <a:ln xmlns:a="http://schemas.openxmlformats.org/drawingml/2006/main" w="0">
-            <a:noFill/>
-            <a:prstDash val="solid"/>
-          </a:ln>
-        </p:spPr>
-        <p:txBody>
-          <a:bodyPr xmlns:a="http://schemas.openxmlformats.org/drawingml/2006/main" wrap="square" lIns="0" tIns="0" rIns="0" bIns="0" anchor="t">
-            <a:noAutofit/>
-          </a:bodyPr>
-          <a:lstStyle xmlns:a="http://schemas.openxmlformats.org/drawingml/2006/main"/>
-          <a:p xmlns:a="http://schemas.openxmlformats.org/drawingml/2006/main">
-            <a:pPr algn="r">
-              <a:buNone/>
-              <a:defRPr sz="1050" b="1">
-                <a:solidFill>
-                  <a:srgbClr val="5C6577"/>
-                </a:solidFill>
-                <a:latin typeface="Menlo"/>
-                <a:ea typeface="Menlo"/>
-                <a:cs typeface="Menlo"/>
-              </a:defRPr>
-            </a:pPr>
-            <a:r>
-              <a:rPr sz="1050" b="1">
-                <a:solidFill>
-                  <a:srgbClr val="5C6577"/>
-                </a:solidFill>
-                <a:latin typeface="Menlo"/>
-                <a:ea typeface="Menlo"/>
-                <a:cs typeface="Menlo"/>
-              </a:rPr>
-              <a:t>06</a:t>
-            </a:r>
-          </a:p>
-        </p:txBody>
-      </p:sp>
-      <p:sp>
-        <p:nvSpPr>
-          <p:cNvPr id="5" name="">
-            <a:extLst xmlns:a="http://schemas.openxmlformats.org/drawingml/2006/main">
-              <a:ext uri="{FF2B5EF4-FFF2-40B4-BE49-F238E27FC236}">
-                <a16:creationId xmlns:a16="http://schemas.microsoft.com/office/drawing/2014/main" id="{FCB0DB75-0A32-4F59-AF0F-4B76736744AB}"/>
-              </a:ext>
-            </a:extLst>
-          </p:cNvPr>
-          <p:cNvSpPr>
-            <a:spLocks xmlns:a="http://schemas.openxmlformats.org/drawingml/2006/main" noGrp="1"/>
-          </p:cNvSpPr>
-          <p:nvPr/>
-        </p:nvSpPr>
-        <p:spPr>
-          <a:xfrm xmlns:a="http://schemas.openxmlformats.org/drawingml/2006/main">
-            <a:off x="552450" y="2038350"/>
-            <a:ext cx="6858000" cy="4095750"/>
-          </a:xfrm>
-          <a:prstGeom xmlns:a="http://schemas.openxmlformats.org/drawingml/2006/main" prst="roundRect">
-            <a:avLst>
-              <a:gd name="adj" fmla="val 4186"/>
-            </a:avLst>
-          </a:prstGeom>
-          <a:solidFill xmlns:a="http://schemas.openxmlformats.org/drawingml/2006/main">
-            <a:srgbClr val="FFFFFF"/>
-          </a:solidFill>
-          <a:ln xmlns:a="http://schemas.openxmlformats.org/drawingml/2006/main" w="9525">
-            <a:solidFill>
-              <a:srgbClr val="E9E4D8"/>
-            </a:solidFill>
-            <a:prstDash val="solid"/>
-          </a:ln>
-        </p:spPr>
-      </p:sp>
-      <p:pic>
-        <p:nvPicPr>
-          <p:cNvPr id="23" name=""/>
-          <p:cNvPicPr>
-            <a:picLocks xmlns:a="http://schemas.openxmlformats.org/drawingml/2006/main" noChangeAspect="1"/>
-          </p:cNvPicPr>
-          <p:nvPr/>
-        </p:nvPicPr>
-        <p:blipFill>
-          <a:blip xmlns:r="http://schemas.openxmlformats.org/officeDocument/2006/relationships" xmlns:a="http://schemas.openxmlformats.org/drawingml/2006/main" r:embed="R0487ba9696264a22"/>
-          <a:srcRect xmlns:a="http://schemas.openxmlformats.org/drawingml/2006/main" l="0" t="10087" r="0" b="10087"/>
-          <a:stretch xmlns:a="http://schemas.openxmlformats.org/drawingml/2006/main">
-            <a:fillRect l="0" t="0" r="0" b="0"/>
-          </a:stretch>
-        </p:blipFill>
-        <p:spPr>
-          <a:xfrm xmlns:a="http://schemas.openxmlformats.org/drawingml/2006/main">
-            <a:off x="695325" y="2171700"/>
-            <a:ext cx="6572250" cy="3810000"/>
-          </a:xfrm>
-          <a:prstGeom xmlns:a="http://schemas.openxmlformats.org/drawingml/2006/main" prst="roundRect">
-            <a:avLst>
-              <a:gd name="adj" fmla="val 3000"/>
-            </a:avLst>
-          </a:prstGeom>
-        </p:spPr>
-      </p:pic>
-      <p:sp>
-        <p:nvSpPr>
-          <p:cNvPr id="7" name="">
-            <a:extLst xmlns:a="http://schemas.openxmlformats.org/drawingml/2006/main">
-              <a:ext uri="{FF2B5EF4-FFF2-40B4-BE49-F238E27FC236}">
-                <a16:creationId xmlns:a16="http://schemas.microsoft.com/office/drawing/2014/main" id="{A91DD7FA-F4F5-4AC9-A03E-97B14698C09B}"/>
-              </a:ext>
-            </a:extLst>
-          </p:cNvPr>
-          <p:cNvSpPr>
-            <a:spLocks xmlns:a="http://schemas.openxmlformats.org/drawingml/2006/main" noGrp="1"/>
-          </p:cNvSpPr>
-          <p:nvPr/>
-        </p:nvSpPr>
-        <p:spPr>
-          <a:xfrm xmlns:a="http://schemas.openxmlformats.org/drawingml/2006/main">
-            <a:off x="7810500" y="2181225"/>
-            <a:ext cx="3829050" cy="1485900"/>
-          </a:xfrm>
-          <a:prstGeom xmlns:a="http://schemas.openxmlformats.org/drawingml/2006/main" prst="roundRect">
-            <a:avLst>
-              <a:gd name="adj" fmla="val 11538"/>
-            </a:avLst>
-          </a:prstGeom>
-          <a:solidFill xmlns:a="http://schemas.openxmlformats.org/drawingml/2006/main">
-            <a:srgbClr val="F1FBF8"/>
-          </a:solidFill>
-          <a:ln xmlns:a="http://schemas.openxmlformats.org/drawingml/2006/main" w="9525">
-            <a:solidFill>
-              <a:srgbClr val="E9E4D8"/>
-            </a:solidFill>
-            <a:prstDash val="solid"/>
-          </a:ln>
-        </p:spPr>
-        <p:style>
-          <a:lnRef xmlns:a="http://schemas.openxmlformats.org/drawingml/2006/main" idx="0"/>
-          <a:fillRef xmlns:a="http://schemas.openxmlformats.org/drawingml/2006/main" idx="0"/>
-          <a:effectRef xmlns:a="http://schemas.openxmlformats.org/drawingml/2006/main" idx="4"/>
-          <a:fontRef xmlns:a="http://schemas.openxmlformats.org/drawingml/2006/main" idx="major"/>
-        </p:style>
-      </p:sp>
-      <p:sp>
-        <p:nvSpPr>
-          <p:cNvPr id="8" name="">
-            <a:extLst xmlns:a="http://schemas.openxmlformats.org/drawingml/2006/main">
-              <a:ext uri="{FF2B5EF4-FFF2-40B4-BE49-F238E27FC236}">
-                <a16:creationId xmlns:a16="http://schemas.microsoft.com/office/drawing/2014/main" id="{4442AD6D-37AA-477F-AD03-081344F794F3}"/>
-              </a:ext>
-            </a:extLst>
-          </p:cNvPr>
-          <p:cNvSpPr>
-            <a:spLocks xmlns:a="http://schemas.openxmlformats.org/drawingml/2006/main" noGrp="1"/>
-          </p:cNvSpPr>
-          <p:nvPr/>
-        </p:nvSpPr>
-        <p:spPr>
-          <a:xfrm xmlns:a="http://schemas.openxmlformats.org/drawingml/2006/main">
-            <a:off x="7810500" y="2181225"/>
-            <a:ext cx="76200" cy="1485900"/>
-          </a:xfrm>
-          <a:prstGeom xmlns:a="http://schemas.openxmlformats.org/drawingml/2006/main" prst="rect">
-            <a:avLst/>
-          </a:prstGeom>
-          <a:solidFill xmlns:a="http://schemas.openxmlformats.org/drawingml/2006/main">
-            <a:srgbClr val="007C77"/>
-          </a:solidFill>
-          <a:ln xmlns:a="http://schemas.openxmlformats.org/drawingml/2006/main" w="0">
-            <a:solidFill>
-              <a:srgbClr val="007C77"/>
-            </a:solidFill>
-            <a:prstDash val="solid"/>
-          </a:ln>
-        </p:spPr>
-      </p:sp>
-      <p:sp>
-        <p:nvSpPr>
-          <p:cNvPr id="9" name="">
-            <a:extLst xmlns:a="http://schemas.openxmlformats.org/drawingml/2006/main">
-              <a:ext uri="{FF2B5EF4-FFF2-40B4-BE49-F238E27FC236}">
-                <a16:creationId xmlns:a16="http://schemas.microsoft.com/office/drawing/2014/main" id="{556FA892-446F-461D-9550-614CF4C19631}"/>
-              </a:ext>
-            </a:extLst>
-          </p:cNvPr>
-          <p:cNvSpPr>
-            <a:spLocks xmlns:a="http://schemas.openxmlformats.org/drawingml/2006/main" noGrp="1"/>
-          </p:cNvSpPr>
-          <p:nvPr/>
-        </p:nvSpPr>
-        <p:spPr>
-          <a:xfrm xmlns:a="http://schemas.openxmlformats.org/drawingml/2006/main">
-            <a:off x="8058150" y="2371725"/>
-            <a:ext cx="3371850" cy="361950"/>
-          </a:xfrm>
-          <a:prstGeom xmlns:a="http://schemas.openxmlformats.org/drawingml/2006/main" prst="rect">
-            <a:avLst/>
-          </a:prstGeom>
-          <a:noFill xmlns:a="http://schemas.openxmlformats.org/drawingml/2006/main"/>
-          <a:ln xmlns:a="http://schemas.openxmlformats.org/drawingml/2006/main" w="0">
-            <a:noFill/>
-            <a:prstDash val="solid"/>
-          </a:ln>
-        </p:spPr>
-        <p:txBody>
-          <a:bodyPr xmlns:a="http://schemas.openxmlformats.org/drawingml/2006/main" lIns="0" tIns="0" rIns="0" bIns="0" anchor="t">
-            <a:normAutofit fontScale="100000"/>
-          </a:bodyPr>
-          <a:lstStyle xmlns:a="http://schemas.openxmlformats.org/drawingml/2006/main"/>
-          <a:p xmlns:a="http://schemas.openxmlformats.org/drawingml/2006/main">
-            <a:pPr>
-              <a:buNone/>
-              <a:defRPr sz="1725" b="1">
-                <a:solidFill>
-                  <a:srgbClr val="14213D"/>
-                </a:solidFill>
-                <a:latin typeface="Georgia"/>
-                <a:ea typeface="Georgia"/>
-                <a:cs typeface="Georgia"/>
-              </a:defRPr>
-            </a:pPr>
-            <a:r>
-              <a:rPr sz="1725" b="1">
-                <a:solidFill>
-                  <a:srgbClr val="14213D"/>
-                </a:solidFill>
-                <a:latin typeface="Georgia"/>
-                <a:ea typeface="Georgia"/>
-                <a:cs typeface="Georgia"/>
-              </a:rPr>
-              <a:t>Atlas layer</a:t>
-            </a:r>
-          </a:p>
-        </p:txBody>
-      </p:sp>
-      <p:sp>
-        <p:nvSpPr>
-          <p:cNvPr id="10" name="">
-            <a:extLst xmlns:a="http://schemas.openxmlformats.org/drawingml/2006/main">
-              <a:ext uri="{FF2B5EF4-FFF2-40B4-BE49-F238E27FC236}">
-                <a16:creationId xmlns:a16="http://schemas.microsoft.com/office/drawing/2014/main" id="{F86B820A-35C1-4678-B006-C74EBAC48107}"/>
-              </a:ext>
-            </a:extLst>
-          </p:cNvPr>
-          <p:cNvSpPr>
-            <a:spLocks xmlns:a="http://schemas.openxmlformats.org/drawingml/2006/main" noGrp="1"/>
-          </p:cNvSpPr>
-          <p:nvPr/>
-        </p:nvSpPr>
-        <p:spPr>
-          <a:xfrm xmlns:a="http://schemas.openxmlformats.org/drawingml/2006/main">
-            <a:off x="8058150" y="2819400"/>
-            <a:ext cx="3371850" cy="647700"/>
-          </a:xfrm>
-          <a:prstGeom xmlns:a="http://schemas.openxmlformats.org/drawingml/2006/main" prst="rect">
-            <a:avLst/>
-          </a:prstGeom>
-          <a:noFill xmlns:a="http://schemas.openxmlformats.org/drawingml/2006/main"/>
-          <a:ln xmlns:a="http://schemas.openxmlformats.org/drawingml/2006/main" w="0">
-            <a:noFill/>
-            <a:prstDash val="solid"/>
-          </a:ln>
-        </p:spPr>
-        <p:txBody>
-          <a:bodyPr xmlns:a="http://schemas.openxmlformats.org/drawingml/2006/main" lIns="0" tIns="0" rIns="0" bIns="0" anchor="t">
-            <a:normAutofit fontScale="100000"/>
-          </a:bodyPr>
-          <a:lstStyle xmlns:a="http://schemas.openxmlformats.org/drawingml/2006/main"/>
-          <a:p xmlns:a="http://schemas.openxmlformats.org/drawingml/2006/main">
-            <a:pPr>
-              <a:lnSpc>
-                <a:spcPct val="115000"/>
-              </a:lnSpc>
-              <a:buNone/>
-              <a:defRPr sz="1425">
-                <a:solidFill>
-                  <a:srgbClr val="5C6577"/>
-                </a:solidFill>
-                <a:latin typeface="Avenir Next"/>
-                <a:ea typeface="Avenir Next"/>
-                <a:cs typeface="Avenir Next"/>
-              </a:defRPr>
-            </a:pPr>
-            <a:r>
-              <a:rPr sz="1425">
-                <a:solidFill>
-                  <a:srgbClr val="5C6577"/>
-                </a:solidFill>
-                <a:latin typeface="Avenir Next"/>
-                <a:ea typeface="Avenir Next"/>
-                <a:cs typeface="Avenir Next"/>
-              </a:rPr>
-              <a:t>Project · cluster · network access · database users · logs</a:t>
-            </a:r>
-          </a:p>
-        </p:txBody>
-      </p:sp>
-      <p:sp>
-        <p:nvSpPr>
-          <p:cNvPr id="11" name="">
-            <a:extLst xmlns:a="http://schemas.openxmlformats.org/drawingml/2006/main">
-              <a:ext uri="{FF2B5EF4-FFF2-40B4-BE49-F238E27FC236}">
-                <a16:creationId xmlns:a16="http://schemas.microsoft.com/office/drawing/2014/main" id="{647E7C82-8C55-4563-A917-2628102B5569}"/>
-              </a:ext>
-            </a:extLst>
-          </p:cNvPr>
-          <p:cNvSpPr>
-            <a:spLocks xmlns:a="http://schemas.openxmlformats.org/drawingml/2006/main" noGrp="1"/>
-          </p:cNvSpPr>
-          <p:nvPr/>
-        </p:nvSpPr>
-        <p:spPr>
-          <a:xfrm xmlns:a="http://schemas.openxmlformats.org/drawingml/2006/main">
-            <a:off x="7810500" y="4000500"/>
-            <a:ext cx="3829050" cy="1485900"/>
-          </a:xfrm>
-          <a:prstGeom xmlns:a="http://schemas.openxmlformats.org/drawingml/2006/main" prst="roundRect">
-            <a:avLst>
-              <a:gd name="adj" fmla="val 11538"/>
-            </a:avLst>
-          </a:prstGeom>
-          <a:solidFill xmlns:a="http://schemas.openxmlformats.org/drawingml/2006/main">
-            <a:srgbClr val="FFF8EE"/>
-          </a:solidFill>
-          <a:ln xmlns:a="http://schemas.openxmlformats.org/drawingml/2006/main" w="9525">
-            <a:solidFill>
-              <a:srgbClr val="E9E4D8"/>
-            </a:solidFill>
-            <a:prstDash val="solid"/>
-          </a:ln>
-        </p:spPr>
-        <p:style>
-          <a:lnRef xmlns:a="http://schemas.openxmlformats.org/drawingml/2006/main" idx="0"/>
-          <a:fillRef xmlns:a="http://schemas.openxmlformats.org/drawingml/2006/main" idx="0"/>
-          <a:effectRef xmlns:a="http://schemas.openxmlformats.org/drawingml/2006/main" idx="4"/>
-          <a:fontRef xmlns:a="http://schemas.openxmlformats.org/drawingml/2006/main" idx="major"/>
-        </p:style>
-      </p:sp>
-      <p:sp>
-        <p:nvSpPr>
-          <p:cNvPr id="12" name="">
-            <a:extLst xmlns:a="http://schemas.openxmlformats.org/drawingml/2006/main">
-              <a:ext uri="{FF2B5EF4-FFF2-40B4-BE49-F238E27FC236}">
-                <a16:creationId xmlns:a16="http://schemas.microsoft.com/office/drawing/2014/main" id="{3DEFC58E-7651-4407-85B2-30C17A8CEE88}"/>
-              </a:ext>
-            </a:extLst>
-          </p:cNvPr>
-          <p:cNvSpPr>
-            <a:spLocks xmlns:a="http://schemas.openxmlformats.org/drawingml/2006/main" noGrp="1"/>
-          </p:cNvSpPr>
-          <p:nvPr/>
-        </p:nvSpPr>
-        <p:spPr>
-          <a:xfrm xmlns:a="http://schemas.openxmlformats.org/drawingml/2006/main">
-            <a:off x="7810500" y="4000500"/>
-            <a:ext cx="76200" cy="1485900"/>
-          </a:xfrm>
-          <a:prstGeom xmlns:a="http://schemas.openxmlformats.org/drawingml/2006/main" prst="rect">
-            <a:avLst/>
-          </a:prstGeom>
-          <a:solidFill xmlns:a="http://schemas.openxmlformats.org/drawingml/2006/main">
-            <a:srgbClr val="F4A261"/>
-          </a:solidFill>
-          <a:ln xmlns:a="http://schemas.openxmlformats.org/drawingml/2006/main" w="0">
-            <a:solidFill>
-              <a:srgbClr val="F4A261"/>
-            </a:solidFill>
-            <a:prstDash val="solid"/>
-          </a:ln>
-        </p:spPr>
-      </p:sp>
-      <p:sp>
-        <p:nvSpPr>
-          <p:cNvPr id="13" name="">
-            <a:extLst xmlns:a="http://schemas.openxmlformats.org/drawingml/2006/main">
-              <a:ext uri="{FF2B5EF4-FFF2-40B4-BE49-F238E27FC236}">
-                <a16:creationId xmlns:a16="http://schemas.microsoft.com/office/drawing/2014/main" id="{D4548902-7F7A-45BB-AA68-CB7E2EC852FB}"/>
-              </a:ext>
-            </a:extLst>
-          </p:cNvPr>
-          <p:cNvSpPr>
-            <a:spLocks xmlns:a="http://schemas.openxmlformats.org/drawingml/2006/main" noGrp="1"/>
-          </p:cNvSpPr>
-          <p:nvPr/>
-        </p:nvSpPr>
-        <p:spPr>
-          <a:xfrm xmlns:a="http://schemas.openxmlformats.org/drawingml/2006/main">
-            <a:off x="8058150" y="4191000"/>
-            <a:ext cx="3371850" cy="361950"/>
-          </a:xfrm>
-          <a:prstGeom xmlns:a="http://schemas.openxmlformats.org/drawingml/2006/main" prst="rect">
-            <a:avLst/>
-          </a:prstGeom>
-          <a:noFill xmlns:a="http://schemas.openxmlformats.org/drawingml/2006/main"/>
-          <a:ln xmlns:a="http://schemas.openxmlformats.org/drawingml/2006/main" w="0">
-            <a:noFill/>
-            <a:prstDash val="solid"/>
-          </a:ln>
-        </p:spPr>
-        <p:txBody>
-          <a:bodyPr xmlns:a="http://schemas.openxmlformats.org/drawingml/2006/main" lIns="0" tIns="0" rIns="0" bIns="0" anchor="t">
-            <a:normAutofit fontScale="100000"/>
-          </a:bodyPr>
-          <a:lstStyle xmlns:a="http://schemas.openxmlformats.org/drawingml/2006/main"/>
-          <a:p xmlns:a="http://schemas.openxmlformats.org/drawingml/2006/main">
-            <a:pPr>
-              <a:buNone/>
-              <a:defRPr sz="1725" b="1">
-                <a:solidFill>
-                  <a:srgbClr val="14213D"/>
-                </a:solidFill>
-                <a:latin typeface="Georgia"/>
-                <a:ea typeface="Georgia"/>
-                <a:cs typeface="Georgia"/>
-              </a:defRPr>
-            </a:pPr>
-            <a:r>
-              <a:rPr sz="1725" b="1">
-                <a:solidFill>
-                  <a:srgbClr val="14213D"/>
-                </a:solidFill>
-                <a:latin typeface="Georgia"/>
-                <a:ea typeface="Georgia"/>
-                <a:cs typeface="Georgia"/>
-              </a:rPr>
-              <a:t>MongoDB layer</a:t>
-            </a:r>
-          </a:p>
-        </p:txBody>
-      </p:sp>
-      <p:sp>
-        <p:nvSpPr>
-          <p:cNvPr id="14" name="">
-            <a:extLst xmlns:a="http://schemas.openxmlformats.org/drawingml/2006/main">
-              <a:ext uri="{FF2B5EF4-FFF2-40B4-BE49-F238E27FC236}">
-                <a16:creationId xmlns:a16="http://schemas.microsoft.com/office/drawing/2014/main" id="{E2801D96-4D9E-44A5-B7C6-661E9F9A05A9}"/>
-              </a:ext>
-            </a:extLst>
-          </p:cNvPr>
-          <p:cNvSpPr>
-            <a:spLocks xmlns:a="http://schemas.openxmlformats.org/drawingml/2006/main" noGrp="1"/>
-          </p:cNvSpPr>
-          <p:nvPr/>
-        </p:nvSpPr>
-        <p:spPr>
-          <a:xfrm xmlns:a="http://schemas.openxmlformats.org/drawingml/2006/main">
-            <a:off x="8058150" y="4638675"/>
-            <a:ext cx="3371850" cy="647700"/>
-          </a:xfrm>
-          <a:prstGeom xmlns:a="http://schemas.openxmlformats.org/drawingml/2006/main" prst="rect">
-            <a:avLst/>
-          </a:prstGeom>
-          <a:noFill xmlns:a="http://schemas.openxmlformats.org/drawingml/2006/main"/>
-          <a:ln xmlns:a="http://schemas.openxmlformats.org/drawingml/2006/main" w="0">
-            <a:noFill/>
-            <a:prstDash val="solid"/>
-          </a:ln>
-        </p:spPr>
-        <p:txBody>
-          <a:bodyPr xmlns:a="http://schemas.openxmlformats.org/drawingml/2006/main" lIns="0" tIns="0" rIns="0" bIns="0" anchor="t">
-            <a:normAutofit fontScale="100000"/>
-          </a:bodyPr>
-          <a:lstStyle xmlns:a="http://schemas.openxmlformats.org/drawingml/2006/main"/>
-          <a:p xmlns:a="http://schemas.openxmlformats.org/drawingml/2006/main">
-            <a:pPr>
-              <a:lnSpc>
-                <a:spcPct val="115000"/>
-              </a:lnSpc>
-              <a:buNone/>
-              <a:defRPr sz="1425">
-                <a:solidFill>
-                  <a:srgbClr val="5C6577"/>
-                </a:solidFill>
-                <a:latin typeface="Avenir Next"/>
-                <a:ea typeface="Avenir Next"/>
-                <a:cs typeface="Avenir Next"/>
-              </a:defRPr>
-            </a:pPr>
-            <a:r>
-              <a:rPr sz="1425">
-                <a:solidFill>
-                  <a:srgbClr val="5C6577"/>
-                </a:solidFill>
-                <a:latin typeface="Avenir Next"/>
-                <a:ea typeface="Avenir Next"/>
-                <a:cs typeface="Avenir Next"/>
-              </a:rPr>
-              <a:t>Databases · collections · BSON documents · queries · indexes</a:t>
-            </a:r>
-          </a:p>
-        </p:txBody>
-      </p:sp>
-      <p:sp>
-        <p:nvSpPr>
-          <p:cNvPr id="15" name="">
-            <a:extLst xmlns:a="http://schemas.openxmlformats.org/drawingml/2006/main">
-              <a:ext uri="{FF2B5EF4-FFF2-40B4-BE49-F238E27FC236}">
-                <a16:creationId xmlns:a16="http://schemas.microsoft.com/office/drawing/2014/main" id="{9A1E3507-E43F-4957-B019-5419EE166FAC}"/>
-              </a:ext>
-            </a:extLst>
-          </p:cNvPr>
-          <p:cNvSpPr>
-            <a:spLocks xmlns:a="http://schemas.openxmlformats.org/drawingml/2006/main" noGrp="1"/>
-          </p:cNvSpPr>
-          <p:nvPr/>
-        </p:nvSpPr>
-        <p:spPr>
-          <a:xfrm xmlns:a="http://schemas.openxmlformats.org/drawingml/2006/main">
-            <a:off x="7943850" y="5772150"/>
-            <a:ext cx="3429000" cy="400050"/>
-          </a:xfrm>
-          <a:prstGeom xmlns:a="http://schemas.openxmlformats.org/drawingml/2006/main" prst="rect">
-            <a:avLst/>
-          </a:prstGeom>
-          <a:noFill xmlns:a="http://schemas.openxmlformats.org/drawingml/2006/main"/>
-          <a:ln xmlns:a="http://schemas.openxmlformats.org/drawingml/2006/main" w="0">
-            <a:noFill/>
-            <a:prstDash val="solid"/>
-          </a:ln>
-        </p:spPr>
-        <p:txBody>
-          <a:bodyPr xmlns:a="http://schemas.openxmlformats.org/drawingml/2006/main" wrap="square" lIns="0" tIns="0" rIns="0" bIns="0" anchor="t">
-            <a:noAutofit/>
-          </a:bodyPr>
-          <a:lstStyle xmlns:a="http://schemas.openxmlformats.org/drawingml/2006/main"/>
-          <a:p xmlns:a="http://schemas.openxmlformats.org/drawingml/2006/main">
-            <a:pPr algn="ctr">
-              <a:buNone/>
-              <a:defRPr sz="1275" b="0">
-                <a:solidFill>
-                  <a:srgbClr val="5C6577"/>
-                </a:solidFill>
-                <a:latin typeface="Avenir Next"/>
-                <a:ea typeface="Avenir Next"/>
-                <a:cs typeface="Avenir Next"/>
-              </a:defRPr>
-            </a:pPr>
-            <a:r>
-              <a:rPr sz="1275" b="0">
-                <a:solidFill>
-                  <a:srgbClr val="5C6577"/>
-                </a:solidFill>
-                <a:latin typeface="Avenir Next"/>
-                <a:ea typeface="Avenir Next"/>
-                <a:cs typeface="Avenir Next"/>
-              </a:rPr>
-              <a:t>Dated interface example. No cloud account is needed for this week's lab.</a:t>
-            </a:r>
-          </a:p>
-        </p:txBody>
-      </p:sp>
-    </p:spTree>
-    <p:extLst>
-      <p:ext uri="{BB962C8B-B14F-4D97-AF65-F5344CB8AC3E}">
-        <p14:creationId xmlns:p14="http://schemas.microsoft.com/office/powerpoint/2010/main" val="507522520"/>
-      </p:ext>
-    </p:extLst>
-  </p:cSld>
-</p:sld>
+<ns0:sld xmlns:ns0="http://schemas.openxmlformats.org/presentationml/2006/main" xmlns:ns1="http://schemas.openxmlformats.org/drawingml/2006/main" xmlns:ns2="http://schemas.microsoft.com/office/drawing/2014/main" xmlns:ns3="http://schemas.openxmlformats.org/officeDocument/2006/relationships" xmlns:ns4="http://schemas.microsoft.com/office/powerpoint/2010/main">
+  <ns0:cSld>
+    <ns0:bg>
+      <ns0:bgPr>
+        <ns1:solidFill>
+          <ns1:srgbClr val="F7F3EA"/>
+        </ns1:solidFill>
+      </ns0:bgPr>
+    </ns0:bg>
+    <ns0:spTree>
+      <ns0:nvGrpSpPr>
+        <ns0:cNvPr id="1" name=""/>
+        <ns0:cNvGrpSpPr/>
+        <ns0:nvPr/>
+      </ns0:nvGrpSpPr>
+      <ns0:grpSpPr>
+        <ns1:xfrm/>
+      </ns0:grpSpPr>
+      <ns0:sp>
+        <ns0:nvSpPr>
+          <ns0:cNvPr id="16" name="">
+            <ns1:extLst>
+              <ns1:ext uri="{FF2B5EF4-FFF2-40B4-BE49-F238E27FC236}">
+                <ns2:creationId id="{31896894-5F88-4FA0-B8F7-A3B9556AC8AA}"/>
+              </ns1:ext>
+            </ns1:extLst>
+          </ns0:cNvPr>
+          <ns0:cNvSpPr>
+            <ns1:spLocks noGrp="1"/>
+          </ns0:cNvSpPr>
+          <ns0:nvPr/>
+        </ns0:nvSpPr>
+        <ns0:spPr>
+          <ns1:xfrm>
+            <ns1:off x="552450" y="400050"/>
+            <ns1:ext cx="1447800" cy="323850"/>
+          </ns1:xfrm>
+          <ns1:prstGeom prst="roundRect">
+            <ns1:avLst>
+              <ns1:gd name="adj" fmla="val 50000"/>
+            </ns1:avLst>
+          </ns1:prstGeom>
+          <ns1:solidFill>
+            <ns1:srgbClr val="14213D"/>
+          </ns1:solidFill>
+          <ns1:ln w="9525">
+            <ns1:solidFill>
+              <ns1:srgbClr val="14213D"/>
+            </ns1:solidFill>
+            <ns1:prstDash val="solid"/>
+          </ns1:ln>
+        </ns0:spPr>
+        <ns0:txBody>
+          <ns1:bodyPr lIns="76200" tIns="0" rIns="76200" bIns="0" anchor="ctr">
+            <ns1:normAutofit fontScale="96996"/>
+          </ns1:bodyPr>
+          <ns1:lstStyle/>
+          <ns1:p>
+            <ns1:pPr algn="ctr">
+              <ns1:buNone/>
+              <ns1:defRPr sz="1050" b="1">
+                <ns1:solidFill>
+                  <ns1:srgbClr val="FFFFFF"/>
+                </ns1:solidFill>
+                <ns1:latin typeface="Avenir Next"/>
+                <ns1:ea typeface="Avenir Next"/>
+                <ns1:cs typeface="Avenir Next"/>
+              </ns1:defRPr>
+            </ns1:pPr>
+            <ns1:r>
+              <ns1:rPr sz="1050" b="1">
+                <ns1:solidFill>
+                  <ns1:srgbClr val="FFFFFF"/>
+                </ns1:solidFill>
+                <ns1:latin typeface="Avenir Next"/>
+                <ns1:ea typeface="Avenir Next"/>
+                <ns1:cs typeface="Avenir Next"/>
+              </ns1:rPr>
+              <ns1:t>CLOUD INTERFACE</ns1:t>
+            </ns1:r>
+          </ns1:p>
+        </ns0:txBody>
+      </ns0:sp>
+      <ns0:sp>
+        <ns0:nvSpPr>
+          <ns0:cNvPr id="2" name="slide-title">
+            <ns1:extLst>
+              <ns1:ext uri="{FF2B5EF4-FFF2-40B4-BE49-F238E27FC236}">
+                <ns2:creationId id="{88388ED0-F419-4FDC-A263-1289F17C48A1}"/>
+              </ns1:ext>
+            </ns1:extLst>
+          </ns0:cNvPr>
+          <ns0:cNvSpPr>
+            <ns1:spLocks noGrp="1"/>
+          </ns0:cNvSpPr>
+          <ns0:nvPr/>
+        </ns0:nvSpPr>
+        <ns0:spPr>
+          <ns1:xfrm>
+            <ns1:off x="552450" y="876300"/>
+            <ns1:ext cx="11087100" cy="704850"/>
+          </ns1:xfrm>
+          <ns1:prstGeom prst="rect">
+            <ns1:avLst/>
+          </ns1:prstGeom>
+          <ns1:noFill/>
+          <ns1:ln w="0">
+            <ns1:noFill/>
+            <ns1:prstDash val="solid"/>
+          </ns1:ln>
+        </ns0:spPr>
+        <ns0:txBody>
+          <ns1:bodyPr lIns="0" tIns="0" rIns="0" bIns="0" anchor="t">
+            <ns1:normAutofit fontScale="100000"/>
+          </ns1:bodyPr>
+          <ns1:lstStyle/>
+          <ns1:p>
+            <ns1:pPr>
+              <ns1:lnSpc>
+                <ns1:spcPct val="95000"/>
+              </ns1:lnSpc>
+              <ns1:buNone/>
+              <ns1:defRPr sz="3000" b="1">
+                <ns1:solidFill>
+                  <ns1:srgbClr val="14213D"/>
+                </ns1:solidFill>
+                <ns1:latin typeface="Georgia"/>
+                <ns1:ea typeface="Georgia"/>
+                <ns1:cs typeface="Georgia"/>
+              </ns1:defRPr>
+            </ns1:pPr>
+            <ns1:r>
+              <ns1:rPr sz="3000" b="1">
+                <ns1:solidFill>
+                  <ns1:srgbClr val="14213D"/>
+                </ns1:solidFill>
+                <ns1:latin typeface="Georgia"/>
+                <ns1:ea typeface="Georgia"/>
+                <ns1:cs typeface="Georgia"/>
+              </ns1:rPr>
+              <ns1:t>MongoDB Atlas operates MongoDB in the cloud</ns1:t>
+            </ns1:r>
+          </ns1:p>
+        </ns0:txBody>
+      </ns0:sp>
+      <ns0:sp>
+        <ns0:nvSpPr>
+          <ns0:cNvPr id="3" name="">
+            <ns1:extLst>
+              <ns1:ext uri="{FF2B5EF4-FFF2-40B4-BE49-F238E27FC236}">
+                <ns2:creationId id="{D26C06D8-0780-4513-AB3F-492DC56C46AA}"/>
+              </ns1:ext>
+            </ns1:extLst>
+          </ns0:cNvPr>
+          <ns0:cNvSpPr>
+            <ns1:spLocks noGrp="1"/>
+          </ns0:cNvSpPr>
+          <ns0:nvPr/>
+        </ns0:nvSpPr>
+        <ns0:spPr>
+          <ns1:xfrm>
+            <ns1:off x="571500" y="1562100"/>
+            <ns1:ext cx="10477500" cy="381000"/>
+          </ns1:xfrm>
+          <ns1:prstGeom prst="rect">
+            <ns1:avLst/>
+          </ns1:prstGeom>
+          <ns1:noFill/>
+          <ns1:ln w="0">
+            <ns1:noFill/>
+            <ns1:prstDash val="solid"/>
+          </ns1:ln>
+        </ns0:spPr>
+        <ns0:txBody>
+          <ns1:bodyPr lIns="0" tIns="0" rIns="0" bIns="0" anchor="t">
+            <ns1:normAutofit fontScale="100000"/>
+          </ns1:bodyPr>
+          <ns1:lstStyle/>
+          <ns1:p>
+            <ns1:pPr>
+              <ns1:buNone/>
+              <ns1:defRPr sz="1425">
+                <ns1:solidFill>
+                  <ns1:srgbClr val="5C6577"/>
+                </ns1:solidFill>
+                <ns1:latin typeface="Avenir Next"/>
+                <ns1:ea typeface="Avenir Next"/>
+                <ns1:cs typeface="Avenir Next"/>
+              </ns1:defRPr>
+            </ns1:pPr>
+            <ns1:r>
+              <ns1:rPr sz="1425">
+                <ns1:solidFill>
+                  <ns1:srgbClr val="5C6577"/>
+                </ns1:solidFill>
+                <ns1:latin typeface="Avenir Next"/>
+                <ns1:ea typeface="Avenir Next"/>
+                <ns1:cs typeface="Avenir Next"/>
+              </ns1:rPr>
+              <ns1:t>Projects, clusters, users, network rules, and data tools surround the document database.</ns1:t>
+            </ns1:r>
+          </ns1:p>
+        </ns0:txBody>
+      </ns0:sp>
+      <ns0:sp>
+        <ns0:nvSpPr>
+          <ns0:cNvPr id="4" name="">
+            <ns1:extLst>
+              <ns1:ext uri="{FF2B5EF4-FFF2-40B4-BE49-F238E27FC236}">
+                <ns2:creationId id="{4D4F6477-AD3C-41DA-A4AD-841179DE5AE4}"/>
+              </ns1:ext>
+            </ns1:extLst>
+          </ns0:cNvPr>
+          <ns0:cNvSpPr>
+            <ns1:spLocks noGrp="1"/>
+          </ns0:cNvSpPr>
+          <ns0:nvPr/>
+        </ns0:nvSpPr>
+        <ns0:spPr>
+          <ns1:xfrm>
+            <ns1:off x="11144250" y="6334125"/>
+            <ns1:ext cx="495300" cy="228600"/>
+          </ns1:xfrm>
+          <ns1:prstGeom prst="rect">
+            <ns1:avLst/>
+          </ns1:prstGeom>
+          <ns1:noFill/>
+          <ns1:ln w="0">
+            <ns1:noFill/>
+            <ns1:prstDash val="solid"/>
+          </ns1:ln>
+        </ns0:spPr>
+        <ns0:txBody>
+          <ns1:bodyPr wrap="square" lIns="0" tIns="0" rIns="0" bIns="0" anchor="t">
+            <ns1:noAutofit/>
+          </ns1:bodyPr>
+          <ns1:lstStyle/>
+          <ns1:p>
+            <ns1:pPr algn="r">
+              <ns1:buNone/>
+              <ns1:defRPr sz="1050" b="1">
+                <ns1:solidFill>
+                  <ns1:srgbClr val="5C6577"/>
+                </ns1:solidFill>
+                <ns1:latin typeface="Menlo"/>
+                <ns1:ea typeface="Menlo"/>
+                <ns1:cs typeface="Menlo"/>
+              </ns1:defRPr>
+            </ns1:pPr>
+            <ns1:r>
+              <ns1:rPr sz="1050" b="1">
+                <ns1:solidFill>
+                  <ns1:srgbClr val="5C6577"/>
+                </ns1:solidFill>
+                <ns1:latin typeface="Menlo"/>
+                <ns1:ea typeface="Menlo"/>
+                <ns1:cs typeface="Menlo"/>
+              </ns1:rPr>
+              <ns1:t>06</ns1:t>
+            </ns1:r>
+          </ns1:p>
+        </ns0:txBody>
+      </ns0:sp>
+      <ns0:sp>
+        <ns0:nvSpPr>
+          <ns0:cNvPr id="5" name="">
+            <ns1:extLst>
+              <ns1:ext uri="{FF2B5EF4-FFF2-40B4-BE49-F238E27FC236}">
+                <ns2:creationId id="{FCB0DB75-0A32-4F59-AF0F-4B76736744AB}"/>
+              </ns1:ext>
+            </ns1:extLst>
+          </ns0:cNvPr>
+          <ns0:cNvSpPr>
+            <ns1:spLocks noGrp="1"/>
+          </ns0:cNvSpPr>
+          <ns0:nvPr/>
+        </ns0:nvSpPr>
+        <ns0:spPr>
+          <ns1:xfrm>
+            <ns1:off x="552450" y="2038350"/>
+            <ns1:ext cx="6858000" cy="4095750"/>
+          </ns1:xfrm>
+          <ns1:prstGeom prst="roundRect">
+            <ns1:avLst>
+              <ns1:gd name="adj" fmla="val 4186"/>
+            </ns1:avLst>
+          </ns1:prstGeom>
+          <ns1:solidFill>
+            <ns1:srgbClr val="FFFFFF"/>
+          </ns1:solidFill>
+          <ns1:ln w="9525">
+            <ns1:solidFill>
+              <ns1:srgbClr val="E9E4D8"/>
+            </ns1:solidFill>
+            <ns1:prstDash val="solid"/>
+          </ns1:ln>
+        </ns0:spPr>
+      </ns0:sp>
+      <ns0:pic>
+        <ns0:nvPicPr>
+          <ns0:cNvPr id="23" name="" descr="MongoDB Atlas project overview, captured August 25, 2026 with account details redacted. A free cluster has Connect, Add data, and Load sample data controls. The left navigation includes Data Explorer and Database and Network Access. This dashboard manages the deployment; opening it does not establish a database-client connection."/>
+          <ns0:cNvPicPr>
+            <ns1:picLocks noChangeAspect="1"/>
+          </ns0:cNvPicPr>
+          <ns0:nvPr/>
+        </ns0:nvPicPr>
+        <ns0:blipFill>
+          <ns1:blip ns3:embed="R0487ba9696264a22"/>
+          <ns1:srcRect l="0" t="10087" r="0" b="10087"/>
+          <ns1:stretch>
+            <ns1:fillRect l="0" t="0" r="0" b="0"/>
+          </ns1:stretch>
+        </ns0:blipFill>
+        <ns0:spPr>
+          <ns1:xfrm>
+            <ns1:off x="695325" y="2171700"/>
+            <ns1:ext cx="6572250" cy="3810000"/>
+          </ns1:xfrm>
+          <ns1:prstGeom prst="roundRect">
+            <ns1:avLst>
+              <ns1:gd name="adj" fmla="val 3000"/>
+            </ns1:avLst>
+          </ns1:prstGeom>
+        </ns0:spPr>
+      </ns0:pic>
+      <ns0:sp>
+        <ns0:nvSpPr>
+          <ns0:cNvPr id="7" name="">
+            <ns1:extLst>
+              <ns1:ext uri="{FF2B5EF4-FFF2-40B4-BE49-F238E27FC236}">
+                <ns2:creationId id="{A91DD7FA-F4F5-4AC9-A03E-97B14698C09B}"/>
+              </ns1:ext>
+            </ns1:extLst>
+          </ns0:cNvPr>
+          <ns0:cNvSpPr>
+            <ns1:spLocks noGrp="1"/>
+          </ns0:cNvSpPr>
+          <ns0:nvPr/>
+        </ns0:nvSpPr>
+        <ns0:spPr>
+          <ns1:xfrm>
+            <ns1:off x="7810500" y="2181225"/>
+            <ns1:ext cx="3829050" cy="1485900"/>
+          </ns1:xfrm>
+          <ns1:prstGeom prst="roundRect">
+            <ns1:avLst>
+              <ns1:gd name="adj" fmla="val 11538"/>
+            </ns1:avLst>
+          </ns1:prstGeom>
+          <ns1:solidFill>
+            <ns1:srgbClr val="F1FBF8"/>
+          </ns1:solidFill>
+          <ns1:ln w="9525">
+            <ns1:solidFill>
+              <ns1:srgbClr val="E9E4D8"/>
+            </ns1:solidFill>
+            <ns1:prstDash val="solid"/>
+          </ns1:ln>
+        </ns0:spPr>
+        <ns0:style>
+          <ns1:lnRef idx="0"/>
+          <ns1:fillRef idx="0"/>
+          <ns1:effectRef idx="4"/>
+          <ns1:fontRef idx="major"/>
+        </ns0:style>
+      </ns0:sp>
+      <ns0:sp>
+        <ns0:nvSpPr>
+          <ns0:cNvPr id="8" name="">
+            <ns1:extLst>
+              <ns1:ext uri="{FF2B5EF4-FFF2-40B4-BE49-F238E27FC236}">
+                <ns2:creationId id="{4442AD6D-37AA-477F-AD03-081344F794F3}"/>
+              </ns1:ext>
+            </ns1:extLst>
+          </ns0:cNvPr>
+          <ns0:cNvSpPr>
+            <ns1:spLocks noGrp="1"/>
+          </ns0:cNvSpPr>
+          <ns0:nvPr/>
+        </ns0:nvSpPr>
+        <ns0:spPr>
+          <ns1:xfrm>
+            <ns1:off x="7810500" y="2181225"/>
+            <ns1:ext cx="76200" cy="1485900"/>
+          </ns1:xfrm>
+          <ns1:prstGeom prst="rect">
+            <ns1:avLst/>
+          </ns1:prstGeom>
+          <ns1:solidFill>
+            <ns1:srgbClr val="007C77"/>
+          </ns1:solidFill>
+          <ns1:ln w="0">
+            <ns1:solidFill>
+              <ns1:srgbClr val="007C77"/>
+            </ns1:solidFill>
+            <ns1:prstDash val="solid"/>
+          </ns1:ln>
+        </ns0:spPr>
+      </ns0:sp>
+      <ns0:sp>
+        <ns0:nvSpPr>
+          <ns0:cNvPr id="9" name="">
+            <ns1:extLst>
+              <ns1:ext uri="{FF2B5EF4-FFF2-40B4-BE49-F238E27FC236}">
+                <ns2:creationId id="{556FA892-446F-461D-9550-614CF4C19631}"/>
+              </ns1:ext>
+            </ns1:extLst>
+          </ns0:cNvPr>
+          <ns0:cNvSpPr>
+            <ns1:spLocks noGrp="1"/>
+          </ns0:cNvSpPr>
+          <ns0:nvPr/>
+        </ns0:nvSpPr>
+        <ns0:spPr>
+          <ns1:xfrm>
+            <ns1:off x="8058150" y="2371725"/>
+            <ns1:ext cx="3371850" cy="361950"/>
+          </ns1:xfrm>
+          <ns1:prstGeom prst="rect">
+            <ns1:avLst/>
+          </ns1:prstGeom>
+          <ns1:noFill/>
+          <ns1:ln w="0">
+            <ns1:noFill/>
+            <ns1:prstDash val="solid"/>
+          </ns1:ln>
+        </ns0:spPr>
+        <ns0:txBody>
+          <ns1:bodyPr lIns="0" tIns="0" rIns="0" bIns="0" anchor="t">
+            <ns1:normAutofit fontScale="100000"/>
+          </ns1:bodyPr>
+          <ns1:lstStyle/>
+          <ns1:p>
+            <ns1:pPr>
+              <ns1:buNone/>
+              <ns1:defRPr sz="1725" b="1">
+                <ns1:solidFill>
+                  <ns1:srgbClr val="14213D"/>
+                </ns1:solidFill>
+                <ns1:latin typeface="Georgia"/>
+                <ns1:ea typeface="Georgia"/>
+                <ns1:cs typeface="Georgia"/>
+              </ns1:defRPr>
+            </ns1:pPr>
+            <ns1:r>
+              <ns1:rPr sz="1725" b="1">
+                <ns1:solidFill>
+                  <ns1:srgbClr val="14213D"/>
+                </ns1:solidFill>
+                <ns1:latin typeface="Georgia"/>
+                <ns1:ea typeface="Georgia"/>
+                <ns1:cs typeface="Georgia"/>
+              </ns1:rPr>
+              <ns1:t>Atlas layer</ns1:t>
+            </ns1:r>
+          </ns1:p>
+        </ns0:txBody>
+      </ns0:sp>
+      <ns0:sp>
+        <ns0:nvSpPr>
+          <ns0:cNvPr id="10" name="">
+            <ns1:extLst>
+              <ns1:ext uri="{FF2B5EF4-FFF2-40B4-BE49-F238E27FC236}">
+                <ns2:creationId id="{F86B820A-35C1-4678-B006-C74EBAC48107}"/>
+              </ns1:ext>
+            </ns1:extLst>
+          </ns0:cNvPr>
+          <ns0:cNvSpPr>
+            <ns1:spLocks noGrp="1"/>
+          </ns0:cNvSpPr>
+          <ns0:nvPr/>
+        </ns0:nvSpPr>
+        <ns0:spPr>
+          <ns1:xfrm>
+            <ns1:off x="8058150" y="2819400"/>
+            <ns1:ext cx="3371850" cy="647700"/>
+          </ns1:xfrm>
+          <ns1:prstGeom prst="rect">
+            <ns1:avLst/>
+          </ns1:prstGeom>
+          <ns1:noFill/>
+          <ns1:ln w="0">
+            <ns1:noFill/>
+            <ns1:prstDash val="solid"/>
+          </ns1:ln>
+        </ns0:spPr>
+        <ns0:txBody>
+          <ns1:bodyPr lIns="0" tIns="0" rIns="0" bIns="0" anchor="t">
+            <ns1:normAutofit fontScale="100000"/>
+          </ns1:bodyPr>
+          <ns1:lstStyle/>
+          <ns1:p>
+            <ns1:pPr>
+              <ns1:lnSpc>
+                <ns1:spcPct val="115000"/>
+              </ns1:lnSpc>
+              <ns1:buNone/>
+              <ns1:defRPr sz="1425">
+                <ns1:solidFill>
+                  <ns1:srgbClr val="5C6577"/>
+                </ns1:solidFill>
+                <ns1:latin typeface="Avenir Next"/>
+                <ns1:ea typeface="Avenir Next"/>
+                <ns1:cs typeface="Avenir Next"/>
+              </ns1:defRPr>
+            </ns1:pPr>
+            <ns1:r>
+              <ns1:rPr sz="1425">
+                <ns1:solidFill>
+                  <ns1:srgbClr val="5C6577"/>
+                </ns1:solidFill>
+                <ns1:latin typeface="Avenir Next"/>
+                <ns1:ea typeface="Avenir Next"/>
+                <ns1:cs typeface="Avenir Next"/>
+              </ns1:rPr>
+              <ns1:t>Project · cluster · network access · database users · logs</ns1:t>
+            </ns1:r>
+          </ns1:p>
+        </ns0:txBody>
+      </ns0:sp>
+      <ns0:sp>
+        <ns0:nvSpPr>
+          <ns0:cNvPr id="11" name="">
+            <ns1:extLst>
+              <ns1:ext uri="{FF2B5EF4-FFF2-40B4-BE49-F238E27FC236}">
+                <ns2:creationId id="{647E7C82-8C55-4563-A917-2628102B5569}"/>
+              </ns1:ext>
+            </ns1:extLst>
+          </ns0:cNvPr>
+          <ns0:cNvSpPr>
+            <ns1:spLocks noGrp="1"/>
+          </ns0:cNvSpPr>
+          <ns0:nvPr/>
+        </ns0:nvSpPr>
+        <ns0:spPr>
+          <ns1:xfrm>
+            <ns1:off x="7810500" y="4000500"/>
+            <ns1:ext cx="3829050" cy="1485900"/>
+          </ns1:xfrm>
+          <ns1:prstGeom prst="roundRect">
+            <ns1:avLst>
+              <ns1:gd name="adj" fmla="val 11538"/>
+            </ns1:avLst>
+          </ns1:prstGeom>
+          <ns1:solidFill>
+            <ns1:srgbClr val="FFF8EE"/>
+          </ns1:solidFill>
+          <ns1:ln w="9525">
+            <ns1:solidFill>
+              <ns1:srgbClr val="E9E4D8"/>
+            </ns1:solidFill>
+            <ns1:prstDash val="solid"/>
+          </ns1:ln>
+        </ns0:spPr>
+        <ns0:style>
+          <ns1:lnRef idx="0"/>
+          <ns1:fillRef idx="0"/>
+          <ns1:effectRef idx="4"/>
+          <ns1:fontRef idx="major"/>
+        </ns0:style>
+      </ns0:sp>
+      <ns0:sp>
+        <ns0:nvSpPr>
+          <ns0:cNvPr id="12" name="">
+            <ns1:extLst>
+              <ns1:ext uri="{FF2B5EF4-FFF2-40B4-BE49-F238E27FC236}">
+                <ns2:creationId id="{3DEFC58E-7651-4407-85B2-30C17A8CEE88}"/>
+              </ns1:ext>
+            </ns1:extLst>
+          </ns0:cNvPr>
+          <ns0:cNvSpPr>
+            <ns1:spLocks noGrp="1"/>
+          </ns0:cNvSpPr>
+          <ns0:nvPr/>
+        </ns0:nvSpPr>
+        <ns0:spPr>
+          <ns1:xfrm>
+            <ns1:off x="7810500" y="4000500"/>
+            <ns1:ext cx="76200" cy="1485900"/>
+          </ns1:xfrm>
+          <ns1:prstGeom prst="rect">
+            <ns1:avLst/>
+          </ns1:prstGeom>
+          <ns1:solidFill>
+            <ns1:srgbClr val="F4A261"/>
+          </ns1:solidFill>
+          <ns1:ln w="0">
+            <ns1:solidFill>
+              <ns1:srgbClr val="F4A261"/>
+            </ns1:solidFill>
+            <ns1:prstDash val="solid"/>
+          </ns1:ln>
+        </ns0:spPr>
+      </ns0:sp>
+      <ns0:sp>
+        <ns0:nvSpPr>
+          <ns0:cNvPr id="13" name="">
+            <ns1:extLst>
+              <ns1:ext uri="{FF2B5EF4-FFF2-40B4-BE49-F238E27FC236}">
+                <ns2:creationId id="{D4548902-7F7A-45BB-AA68-CB7E2EC852FB}"/>
+              </ns1:ext>
+            </ns1:extLst>
+          </ns0:cNvPr>
+          <ns0:cNvSpPr>
+            <ns1:spLocks noGrp="1"/>
+          </ns0:cNvSpPr>
+          <ns0:nvPr/>
+        </ns0:nvSpPr>
+        <ns0:spPr>
+          <ns1:xfrm>
+            <ns1:off x="8058150" y="4191000"/>
+            <ns1:ext cx="3371850" cy="361950"/>
+          </ns1:xfrm>
+          <ns1:prstGeom prst="rect">
+            <ns1:avLst/>
+          </ns1:prstGeom>
+          <ns1:noFill/>
+          <ns1:ln w="0">
+            <ns1:noFill/>
+            <ns1:prstDash val="solid"/>
+          </ns1:ln>
+        </ns0:spPr>
+        <ns0:txBody>
+          <ns1:bodyPr lIns="0" tIns="0" rIns="0" bIns="0" anchor="t">
+            <ns1:normAutofit fontScale="100000"/>
+          </ns1:bodyPr>
+          <ns1:lstStyle/>
+          <ns1:p>
+            <ns1:pPr>
+              <ns1:buNone/>
+              <ns1:defRPr sz="1725" b="1">
+                <ns1:solidFill>
+                  <ns1:srgbClr val="14213D"/>
+                </ns1:solidFill>
+                <ns1:latin typeface="Georgia"/>
+                <ns1:ea typeface="Georgia"/>
+                <ns1:cs typeface="Georgia"/>
+              </ns1:defRPr>
+            </ns1:pPr>
+            <ns1:r>
+              <ns1:rPr sz="1725" b="1">
+                <ns1:solidFill>
+                  <ns1:srgbClr val="14213D"/>
+                </ns1:solidFill>
+                <ns1:latin typeface="Georgia"/>
+                <ns1:ea typeface="Georgia"/>
+                <ns1:cs typeface="Georgia"/>
+              </ns1:rPr>
+              <ns1:t>MongoDB layer</ns1:t>
+            </ns1:r>
+          </ns1:p>
+        </ns0:txBody>
+      </ns0:sp>
+      <ns0:sp>
+        <ns0:nvSpPr>
+          <ns0:cNvPr id="14" name="">
+            <ns1:extLst>
+              <ns1:ext uri="{FF2B5EF4-FFF2-40B4-BE49-F238E27FC236}">
+                <ns2:creationId id="{E2801D96-4D9E-44A5-B7C6-661E9F9A05A9}"/>
+              </ns1:ext>
+            </ns1:extLst>
+          </ns0:cNvPr>
+          <ns0:cNvSpPr>
+            <ns1:spLocks noGrp="1"/>
+          </ns0:cNvSpPr>
+          <ns0:nvPr/>
+        </ns0:nvSpPr>
+        <ns0:spPr>
+          <ns1:xfrm>
+            <ns1:off x="8058150" y="4638675"/>
+            <ns1:ext cx="3371850" cy="647700"/>
+          </ns1:xfrm>
+          <ns1:prstGeom prst="rect">
+            <ns1:avLst/>
+          </ns1:prstGeom>
+          <ns1:noFill/>
+          <ns1:ln w="0">
+            <ns1:noFill/>
+            <ns1:prstDash val="solid"/>
+          </ns1:ln>
+        </ns0:spPr>
+        <ns0:txBody>
+          <ns1:bodyPr lIns="0" tIns="0" rIns="0" bIns="0" anchor="t">
+            <ns1:normAutofit fontScale="100000"/>
+          </ns1:bodyPr>
+          <ns1:lstStyle/>
+          <ns1:p>
+            <ns1:pPr>
+              <ns1:lnSpc>
+                <ns1:spcPct val="115000"/>
+              </ns1:lnSpc>
+              <ns1:buNone/>
+              <ns1:defRPr sz="1425">
+                <ns1:solidFill>
+                  <ns1:srgbClr val="5C6577"/>
+                </ns1:solidFill>
+                <ns1:latin typeface="Avenir Next"/>
+                <ns1:ea typeface="Avenir Next"/>
+                <ns1:cs typeface="Avenir Next"/>
+              </ns1:defRPr>
+            </ns1:pPr>
+            <ns1:r>
+              <ns1:rPr sz="1425">
+                <ns1:solidFill>
+                  <ns1:srgbClr val="5C6577"/>
+                </ns1:solidFill>
+                <ns1:latin typeface="Avenir Next"/>
+                <ns1:ea typeface="Avenir Next"/>
+                <ns1:cs typeface="Avenir Next"/>
+              </ns1:rPr>
+              <ns1:t>Databases · collections · BSON documents · queries · indexes</ns1:t>
+            </ns1:r>
+          </ns1:p>
+        </ns0:txBody>
+      </ns0:sp>
+      <ns0:sp>
+        <ns0:nvSpPr>
+          <ns0:cNvPr id="15" name="">
+            <ns1:extLst>
+              <ns1:ext uri="{FF2B5EF4-FFF2-40B4-BE49-F238E27FC236}">
+                <ns2:creationId id="{9A1E3507-E43F-4957-B019-5419EE166FAC}"/>
+              </ns1:ext>
+            </ns1:extLst>
+          </ns0:cNvPr>
+          <ns0:cNvSpPr>
+            <ns1:spLocks noGrp="1"/>
+          </ns0:cNvSpPr>
+          <ns0:nvPr/>
+        </ns0:nvSpPr>
+        <ns0:spPr>
+          <ns1:xfrm>
+            <ns1:off x="7943850" y="5772150"/>
+            <ns1:ext cx="3429000" cy="400050"/>
+          </ns1:xfrm>
+          <ns1:prstGeom prst="rect">
+            <ns1:avLst/>
+          </ns1:prstGeom>
+          <ns1:noFill/>
+          <ns1:ln w="0">
+            <ns1:noFill/>
+            <ns1:prstDash val="solid"/>
+          </ns1:ln>
+        </ns0:spPr>
+        <ns0:txBody>
+          <ns1:bodyPr wrap="square" lIns="0" tIns="0" rIns="0" bIns="0" anchor="t">
+            <ns1:noAutofit/>
+          </ns1:bodyPr>
+          <ns1:lstStyle/>
+          <ns1:p>
+            <ns1:pPr algn="ctr">
+              <ns1:buNone/>
+              <ns1:defRPr sz="1275" b="0">
+                <ns1:solidFill>
+                  <ns1:srgbClr val="5C6577"/>
+                </ns1:solidFill>
+                <ns1:latin typeface="Avenir Next"/>
+                <ns1:ea typeface="Avenir Next"/>
+                <ns1:cs typeface="Avenir Next"/>
+              </ns1:defRPr>
+            </ns1:pPr>
+            <ns1:r>
+              <ns1:rPr sz="1275" b="0">
+                <ns1:solidFill>
+                  <ns1:srgbClr val="5C6577"/>
+                </ns1:solidFill>
+                <ns1:latin typeface="Avenir Next"/>
+                <ns1:ea typeface="Avenir Next"/>
+                <ns1:cs typeface="Avenir Next"/>
+              </ns1:rPr>
+              <ns1:t>Dated interface example. No cloud account is needed for this week's lab.</ns1:t>
+            </ns1:r>
+          </ns1:p>
+        </ns0:txBody>
+      </ns0:sp>
+    </ns0:spTree>
+    <ns0:extLst>
+      <ns0:ext uri="{BB962C8B-B14F-4D97-AF65-F5344CB8AC3E}">
+        <ns4:creationId val="507522520"/>
+      </ns0:ext>
+    </ns0:extLst>
+  </ns0:cSld>
+</ns0:sld>
 </file>
 
 <file path=ppt/slides/slide7.xml><?xml version="1.0" encoding="utf-8"?>

</xml_diff>

<commit_message>
Add captioned animation videos to every week
Each week gets a videos/ folder (MP4, .srt subtitles, poster) and a Videos
section in its README, plus a final "This week's videos" slide in its deck
with clickable thumbnails, matching speaker notes, transcript section, and
PDF handout page. Weeks 3 and 4 use the videos that fit this semester's
topics (safe change; reliable reports).

Co-Authored-By: Claude Opus 5.5 <noreply@anthropic.com>
</commit_message>
<xml_diff>
--- a/week_01/week_01_responsibility_relational_thinking.pptx
+++ b/week_01/week_01_responsibility_relational_thinking.pptx
@@ -25,6 +25,7 @@
     <p:sldId xmlns:r="http://schemas.openxmlformats.org/officeDocument/2006/relationships" id="270" r:id="Rca7f4ba6571c4a20"/>
     <p:sldId xmlns:r="http://schemas.openxmlformats.org/officeDocument/2006/relationships" id="271" r:id="R4b125dba9a394587"/>
     <p:sldId xmlns:r="http://schemas.openxmlformats.org/officeDocument/2006/relationships" id="272" r:id="R91b2a754c71f4972"/>
+    <p:sldId xmlns:ns0="http://schemas.openxmlformats.org/officeDocument/2006/relationships" id="273" ns0:id="rId23"/>
   </p:sldIdLst>
   <p:sldSz cx="12192000" cy="6858000"/>
   <p:notesSz cx="6858000" cy="9144000"/>
@@ -1494,6 +1495,76 @@
   </p:cSld>
   <p:clrMapOvr>
     <a:masterClrMapping xmlns:a="http://schemas.openxmlformats.org/drawingml/2006/main"/>
+  </p:clrMapOvr>
+</p:notes>
+</file>
+
+<file path=ppt/notesSlides/notesSlide18.xml><?xml version="1.0" encoding="utf-8"?>
+<p:notes xmlns:a="http://schemas.openxmlformats.org/drawingml/2006/main" xmlns:p="http://schemas.openxmlformats.org/presentationml/2006/main" xmlns:r="http://schemas.openxmlformats.org/officeDocument/2006/relationships">
+  <p:cSld>
+    <p:spTree>
+      <p:nvGrpSpPr>
+        <p:cNvPr id="1" name=""/>
+        <p:cNvGrpSpPr/>
+        <p:nvPr/>
+      </p:nvGrpSpPr>
+      <p:grpSpPr>
+        <a:xfrm>
+          <a:off x="0" y="0"/>
+          <a:ext cx="0" cy="0"/>
+          <a:chOff x="0" y="0"/>
+          <a:chExt cx="0" cy="0"/>
+        </a:xfrm>
+      </p:grpSpPr>
+      <p:sp>
+        <p:nvSpPr>
+          <p:cNvPr id="2" name="Slide Image Placeholder 1"/>
+          <p:cNvSpPr>
+            <a:spLocks noGrp="1"/>
+          </p:cNvSpPr>
+          <p:nvPr>
+            <p:ph type="sldImg" idx="2"/>
+          </p:nvPr>
+        </p:nvSpPr>
+        <p:spPr/>
+      </p:sp>
+      <p:sp>
+        <p:nvSpPr>
+          <p:cNvPr id="3" name="Notes Placeholder 2"/>
+          <p:cNvSpPr>
+            <a:spLocks noGrp="1"/>
+          </p:cNvSpPr>
+          <p:nvPr>
+            <p:ph type="body" idx="3" sz="quarter"/>
+          </p:nvPr>
+        </p:nvSpPr>
+        <p:spPr/>
+        <p:txBody>
+          <a:bodyPr/>
+          <a:lstStyle/>
+          <a:p>
+            <a:r>
+              <a:t>These short animations go with this week's reading. Students can watch them before class to preview the mechanisms, or afterwards to review: Following one request (1:24); Selection and projection (1:34); Where did the requests go? (1:18). Each video is silent with on-screen captions and a subtitle file, and is linked from the Week 1 README. The diagrams are schematic illustrations, not benchmarks.</a:t>
+            </a:r>
+          </a:p>
+        </p:txBody>
+      </p:sp>
+      <p:sp>
+        <p:nvSpPr>
+          <p:cNvPr id="4" name="Slide Number Placeholder 3"/>
+          <p:cNvSpPr>
+            <a:spLocks noGrp="1"/>
+          </p:cNvSpPr>
+          <p:nvPr>
+            <p:ph type="sldNum" idx="5" sz="quarter"/>
+          </p:nvPr>
+        </p:nvSpPr>
+        <p:spPr/>
+      </p:sp>
+    </p:spTree>
+  </p:cSld>
+  <p:clrMapOvr>
+    <a:masterClrMapping/>
   </p:clrMapOvr>
 </p:notes>
 </file>
@@ -12556,6 +12627,451 @@
       </p:ext>
     </p:extLst>
   </p:cSld>
+</p:sld>
+</file>
+
+<file path=ppt/slides/slide18.xml><?xml version="1.0" encoding="utf-8"?>
+<p:sld xmlns:a="http://schemas.openxmlformats.org/drawingml/2006/main" xmlns:p="http://schemas.openxmlformats.org/presentationml/2006/main" xmlns:r="http://schemas.openxmlformats.org/officeDocument/2006/relationships">
+  <p:cSld>
+    <p:bg>
+      <p:bgPr>
+        <a:solidFill>
+          <a:srgbClr val="FCFCFA"/>
+        </a:solidFill>
+        <a:effectLst/>
+      </p:bgPr>
+    </p:bg>
+    <p:spTree>
+      <p:nvGrpSpPr>
+        <p:cNvPr id="1" name=""/>
+        <p:cNvGrpSpPr/>
+        <p:nvPr/>
+      </p:nvGrpSpPr>
+      <p:grpSpPr/>
+      <p:sp>
+        <p:nvSpPr>
+          <p:cNvPr id="2" name="cst4714-videos"/>
+          <p:cNvSpPr txBox="1"/>
+          <p:nvPr/>
+        </p:nvSpPr>
+        <p:spPr>
+          <a:xfrm>
+            <a:off x="0" y="0"/>
+            <a:ext cx="10" cy="10"/>
+          </a:xfrm>
+          <a:prstGeom prst="rect">
+            <a:avLst/>
+          </a:prstGeom>
+          <a:noFill/>
+        </p:spPr>
+        <p:txBody>
+          <a:bodyPr wrap="square" lIns="0" rIns="0" tIns="0" bIns="0" anchor="t">
+            <a:spAutoFit/>
+          </a:bodyPr>
+          <a:lstStyle/>
+          <a:p>
+            <a:pPr algn="l"/>
+            <a:r>
+              <a:rPr sz="1800" b="0">
+                <a:solidFill>
+                  <a:srgbClr val="111827"/>
+                </a:solidFill>
+                <a:latin typeface="Helvetica Neue"/>
+              </a:rPr>
+              <a:t/>
+            </a:r>
+          </a:p>
+        </p:txBody>
+      </p:sp>
+      <p:sp>
+        <p:nvSpPr>
+          <p:cNvPr id="3" name="eyebrow"/>
+          <p:cNvSpPr txBox="1"/>
+          <p:nvPr/>
+        </p:nvSpPr>
+        <p:spPr>
+          <a:xfrm>
+            <a:off x="609600" y="295275"/>
+            <a:ext cx="5715000" cy="228600"/>
+          </a:xfrm>
+          <a:prstGeom prst="rect">
+            <a:avLst/>
+          </a:prstGeom>
+          <a:noFill/>
+        </p:spPr>
+        <p:txBody>
+          <a:bodyPr wrap="square" lIns="0" rIns="0" tIns="0" bIns="0" anchor="t">
+            <a:spAutoFit/>
+          </a:bodyPr>
+          <a:lstStyle/>
+          <a:p>
+            <a:pPr algn="l"/>
+            <a:r>
+              <a:rPr sz="1400" b="1">
+                <a:solidFill>
+                  <a:srgbClr val="BF3E05"/>
+                </a:solidFill>
+                <a:latin typeface="Helvetica Neue"/>
+              </a:rPr>
+              <a:t>WEEK 01  /  CST4714</a:t>
+            </a:r>
+          </a:p>
+        </p:txBody>
+      </p:sp>
+      <p:sp>
+        <p:nvSpPr>
+          <p:cNvPr id="4" name="slide-title"/>
+          <p:cNvSpPr txBox="1"/>
+          <p:nvPr/>
+        </p:nvSpPr>
+        <p:spPr>
+          <a:xfrm>
+            <a:off x="609600" y="619125"/>
+            <a:ext cx="10972800" cy="628650"/>
+          </a:xfrm>
+          <a:prstGeom prst="rect">
+            <a:avLst/>
+          </a:prstGeom>
+          <a:noFill/>
+        </p:spPr>
+        <p:txBody>
+          <a:bodyPr wrap="square" lIns="0" rIns="0" tIns="0" bIns="0" anchor="t">
+            <a:spAutoFit/>
+          </a:bodyPr>
+          <a:lstStyle/>
+          <a:p>
+            <a:pPr algn="l"/>
+            <a:r>
+              <a:rPr sz="3600" b="1">
+                <a:solidFill>
+                  <a:srgbClr val="111827"/>
+                </a:solidFill>
+                <a:latin typeface="Helvetica Neue"/>
+              </a:rPr>
+              <a:t>This week's videos</a:t>
+            </a:r>
+          </a:p>
+        </p:txBody>
+      </p:sp>
+      <p:sp>
+        <p:nvSpPr>
+          <p:cNvPr id="5" name="Rectangle 4"/>
+          <p:cNvSpPr/>
+          <p:nvPr/>
+        </p:nvSpPr>
+        <p:spPr>
+          <a:xfrm>
+            <a:off x="609600" y="1295400"/>
+            <a:ext cx="10972800" cy="9525"/>
+          </a:xfrm>
+          <a:prstGeom prst="rect">
+            <a:avLst/>
+          </a:prstGeom>
+          <a:solidFill>
+            <a:srgbClr val="CBD5E1"/>
+          </a:solidFill>
+          <a:ln>
+            <a:noFill/>
+          </a:ln>
+        </p:spPr>
+        <p:style>
+          <a:lnRef idx="1">
+            <a:schemeClr val="accent1"/>
+          </a:lnRef>
+          <a:fillRef idx="3">
+            <a:schemeClr val="accent1"/>
+          </a:fillRef>
+          <a:effectRef idx="2">
+            <a:schemeClr val="accent1"/>
+          </a:effectRef>
+          <a:fontRef idx="minor">
+            <a:schemeClr val="lt1"/>
+          </a:fontRef>
+        </p:style>
+        <p:txBody>
+          <a:bodyPr rtlCol="0" anchor="ctr"/>
+          <a:lstStyle/>
+          <a:p>
+            <a:pPr algn="ctr"/>
+          </a:p>
+        </p:txBody>
+      </p:sp>
+      <p:sp>
+        <p:nvSpPr>
+          <p:cNvPr id="6" name="slide-number"/>
+          <p:cNvSpPr txBox="1"/>
+          <p:nvPr/>
+        </p:nvSpPr>
+        <p:spPr>
+          <a:xfrm>
+            <a:off x="11125200" y="6467475"/>
+            <a:ext cx="457200" cy="190500"/>
+          </a:xfrm>
+          <a:prstGeom prst="rect">
+            <a:avLst/>
+          </a:prstGeom>
+          <a:noFill/>
+        </p:spPr>
+        <p:txBody>
+          <a:bodyPr wrap="square" lIns="0" rIns="0" tIns="0" bIns="0" anchor="t">
+            <a:spAutoFit/>
+          </a:bodyPr>
+          <a:lstStyle/>
+          <a:p>
+            <a:pPr algn="r"/>
+            <a:r>
+              <a:rPr sz="1200" b="0">
+                <a:solidFill>
+                  <a:srgbClr val="475569"/>
+                </a:solidFill>
+                <a:latin typeface="Helvetica Neue"/>
+              </a:rPr>
+              <a:t>18</a:t>
+            </a:r>
+          </a:p>
+        </p:txBody>
+      </p:sp>
+      <p:pic>
+        <p:nvPicPr>
+          <p:cNvPr id="7" name="video-thumb-1" descr="01_request_path.png">
+            <a:hlinkClick r:id="rId3"/>
+          </p:cNvPr>
+          <p:cNvPicPr>
+            <a:picLocks noChangeAspect="1"/>
+          </p:cNvPicPr>
+          <p:nvPr/>
+        </p:nvPicPr>
+        <p:blipFill>
+          <a:blip r:embed="rId2"/>
+          <a:stretch>
+            <a:fillRect/>
+          </a:stretch>
+        </p:blipFill>
+        <p:spPr>
+          <a:xfrm>
+            <a:off x="609600" y="1600200"/>
+            <a:ext cx="3454400" cy="1943100"/>
+          </a:xfrm>
+          <a:prstGeom prst="rect">
+            <a:avLst/>
+          </a:prstGeom>
+          <a:ln>
+            <a:solidFill>
+              <a:srgbClr val="CBD5E1"/>
+            </a:solidFill>
+          </a:ln>
+        </p:spPr>
+      </p:pic>
+      <p:sp>
+        <p:nvSpPr>
+          <p:cNvPr id="8" name="video-title-1"/>
+          <p:cNvSpPr txBox="1"/>
+          <p:nvPr/>
+        </p:nvSpPr>
+        <p:spPr>
+          <a:xfrm>
+            <a:off x="609600" y="3623300"/>
+            <a:ext cx="3454400" cy="520000"/>
+          </a:xfrm>
+          <a:prstGeom prst="rect">
+            <a:avLst/>
+          </a:prstGeom>
+          <a:noFill/>
+        </p:spPr>
+        <p:txBody>
+          <a:bodyPr wrap="square" lIns="0" rIns="0" tIns="0" bIns="0" anchor="t">
+            <a:spAutoFit/>
+          </a:bodyPr>
+          <a:lstStyle/>
+          <a:p>
+            <a:pPr algn="l"/>
+            <a:r>
+              <a:rPr sz="1500" b="1">
+                <a:solidFill>
+                  <a:srgbClr val="111827"/>
+                </a:solidFill>
+                <a:latin typeface="Helvetica Neue"/>
+                <a:hlinkClick r:id="rId3"/>
+              </a:rPr>
+              <a:t>▶ Following one request  (1:24)</a:t>
+            </a:r>
+          </a:p>
+        </p:txBody>
+      </p:sp>
+      <p:pic>
+        <p:nvPicPr>
+          <p:cNvPr id="9" name="video-thumb-2" descr="02_selection_projection.png">
+            <a:hlinkClick r:id="rId5"/>
+          </p:cNvPr>
+          <p:cNvPicPr>
+            <a:picLocks noChangeAspect="1"/>
+          </p:cNvPicPr>
+          <p:nvPr/>
+        </p:nvPicPr>
+        <p:blipFill>
+          <a:blip r:embed="rId4"/>
+          <a:stretch>
+            <a:fillRect/>
+          </a:stretch>
+        </p:blipFill>
+        <p:spPr>
+          <a:xfrm>
+            <a:off x="4368800" y="1600200"/>
+            <a:ext cx="3454400" cy="1943100"/>
+          </a:xfrm>
+          <a:prstGeom prst="rect">
+            <a:avLst/>
+          </a:prstGeom>
+          <a:ln>
+            <a:solidFill>
+              <a:srgbClr val="CBD5E1"/>
+            </a:solidFill>
+          </a:ln>
+        </p:spPr>
+      </p:pic>
+      <p:sp>
+        <p:nvSpPr>
+          <p:cNvPr id="10" name="video-title-2"/>
+          <p:cNvSpPr txBox="1"/>
+          <p:nvPr/>
+        </p:nvSpPr>
+        <p:spPr>
+          <a:xfrm>
+            <a:off x="4368800" y="3623300"/>
+            <a:ext cx="3454400" cy="520000"/>
+          </a:xfrm>
+          <a:prstGeom prst="rect">
+            <a:avLst/>
+          </a:prstGeom>
+          <a:noFill/>
+        </p:spPr>
+        <p:txBody>
+          <a:bodyPr wrap="square" lIns="0" rIns="0" tIns="0" bIns="0" anchor="t">
+            <a:spAutoFit/>
+          </a:bodyPr>
+          <a:lstStyle/>
+          <a:p>
+            <a:pPr algn="l"/>
+            <a:r>
+              <a:rPr sz="1500" b="1">
+                <a:solidFill>
+                  <a:srgbClr val="111827"/>
+                </a:solidFill>
+                <a:latin typeface="Helvetica Neue"/>
+                <a:hlinkClick r:id="rId5"/>
+              </a:rPr>
+              <a:t>▶ Selection and projection  (1:34)</a:t>
+            </a:r>
+          </a:p>
+        </p:txBody>
+      </p:sp>
+      <p:pic>
+        <p:nvPicPr>
+          <p:cNvPr id="11" name="video-thumb-3" descr="03_missing_requests.png">
+            <a:hlinkClick r:id="rId7"/>
+          </p:cNvPr>
+          <p:cNvPicPr>
+            <a:picLocks noChangeAspect="1"/>
+          </p:cNvPicPr>
+          <p:nvPr/>
+        </p:nvPicPr>
+        <p:blipFill>
+          <a:blip r:embed="rId6"/>
+          <a:stretch>
+            <a:fillRect/>
+          </a:stretch>
+        </p:blipFill>
+        <p:spPr>
+          <a:xfrm>
+            <a:off x="8128000" y="1600200"/>
+            <a:ext cx="3454400" cy="1943100"/>
+          </a:xfrm>
+          <a:prstGeom prst="rect">
+            <a:avLst/>
+          </a:prstGeom>
+          <a:ln>
+            <a:solidFill>
+              <a:srgbClr val="CBD5E1"/>
+            </a:solidFill>
+          </a:ln>
+        </p:spPr>
+      </p:pic>
+      <p:sp>
+        <p:nvSpPr>
+          <p:cNvPr id="12" name="video-title-3"/>
+          <p:cNvSpPr txBox="1"/>
+          <p:nvPr/>
+        </p:nvSpPr>
+        <p:spPr>
+          <a:xfrm>
+            <a:off x="8128000" y="3623300"/>
+            <a:ext cx="3454400" cy="520000"/>
+          </a:xfrm>
+          <a:prstGeom prst="rect">
+            <a:avLst/>
+          </a:prstGeom>
+          <a:noFill/>
+        </p:spPr>
+        <p:txBody>
+          <a:bodyPr wrap="square" lIns="0" rIns="0" tIns="0" bIns="0" anchor="t">
+            <a:spAutoFit/>
+          </a:bodyPr>
+          <a:lstStyle/>
+          <a:p>
+            <a:pPr algn="l"/>
+            <a:r>
+              <a:rPr sz="1500" b="1">
+                <a:solidFill>
+                  <a:srgbClr val="111827"/>
+                </a:solidFill>
+                <a:latin typeface="Helvetica Neue"/>
+                <a:hlinkClick r:id="rId7"/>
+              </a:rPr>
+              <a:t>▶ Where did the requests go?  (1:18)</a:t>
+            </a:r>
+          </a:p>
+        </p:txBody>
+      </p:sp>
+      <p:sp>
+        <p:nvSpPr>
+          <p:cNvPr id="13" name="videos-note"/>
+          <p:cNvSpPr txBox="1"/>
+          <p:nvPr/>
+        </p:nvSpPr>
+        <p:spPr>
+          <a:xfrm>
+            <a:off x="609600" y="4243300"/>
+            <a:ext cx="10372800" cy="300000"/>
+          </a:xfrm>
+          <a:prstGeom prst="rect">
+            <a:avLst/>
+          </a:prstGeom>
+          <a:noFill/>
+        </p:spPr>
+        <p:txBody>
+          <a:bodyPr wrap="square" lIns="0" rIns="0" tIns="0" bIns="0" anchor="t">
+            <a:spAutoFit/>
+          </a:bodyPr>
+          <a:lstStyle/>
+          <a:p>
+            <a:pPr algn="l"/>
+            <a:r>
+              <a:rPr sz="1200" b="0">
+                <a:solidFill>
+                  <a:srgbClr val="475569"/>
+                </a:solidFill>
+                <a:latin typeface="Helvetica Neue"/>
+              </a:rPr>
+              <a:t>Click a thumbnail to play on GitHub. Silent, with captions and .srt subtitles; diagrams are schematic.</a:t>
+            </a:r>
+          </a:p>
+        </p:txBody>
+      </p:sp>
+    </p:spTree>
+  </p:cSld>
+  <p:clrMapOvr>
+    <a:masterClrMapping/>
+  </p:clrMapOvr>
 </p:sld>
 </file>
 

</xml_diff>

<commit_message>
Sync weekly materials with the current course source
Brings the repackaged weekly materials up to date: revised slide decks,
handouts and transcripts, updated labs and READMEs, the holiday-week plan,
final-project and midterm wording, the refreshed syllabus and textbook PDFs,
the course corrections page, and the Week 1 and 2 transcripts.

Co-Authored-By: Claude Opus 5.5 <noreply@anthropic.com>
</commit_message>
<xml_diff>
--- a/week_01/week_01_responsibility_relational_thinking.pptx
+++ b/week_01/week_01_responsibility_relational_thinking.pptx
@@ -459,34 +459,28 @@
           <a:lstStyle xmlns:a="http://schemas.openxmlformats.org/drawingml/2006/main"/>
           <a:p xmlns:a="http://schemas.openxmlformats.org/drawingml/2006/main">
             <a:r>
-              <a:t>A student reports a broken bench. The website gives the student a confirmation number, but the repair desk cannot find the request on its dashboard. We will use that discrepancy to study how an application uses a database. The question is concrete: did the system lose the request, or did the dashboard leave it out? Those possibilities require different repairs.</a:t>
-            </a:r>
-          </a:p>
-          <a:p xmlns:a="http://schemas.openxmlformats.org/drawingml/2006/main">
-            <a:r>
-              <a:t/>
-            </a:r>
-          </a:p>
-          <a:p xmlns:a="http://schemas.openxmlformats.org/drawingml/2006/main">
-            <a:r>
-              <a:t>A database stores organized facts that an application needs to retain. A database management system, or DBMS, is the software that processes requests to read or change those facts. An application usually reaches the DBMS through other software, including a service that checks permissions and handles requests. The arrows here show that relationship. API means application programming interface. In our example, it is the agreed way for the browser to ask the application for an operation.</a:t>
-            </a:r>
-          </a:p>
-          <a:p xmlns:a="http://schemas.openxmlformats.org/drawingml/2006/main">
-            <a:r>
-              <a:t/>
-            </a:r>
-          </a:p>
-          <a:p xmlns:a="http://schemas.openxmlformats.org/drawingml/2006/main">
-            <a:r>
-              <a:t>Our first meeting follows a request through those components. Our second meeting examines the rows and the rule that creates the dashboard. We will introduce relational vocabulary and a few SQL examples, but the lab does not require you to remember SQL or create a cloud account. You will read a small supplied dataset and explain a result. Later, we will execute these ideas in SQL and then compare them with document databases. The same reasoning will help us distinguish a missing record from a missing query result.</a:t>
-            </a:r>
-          </a:p>
-          <a:p xmlns:a="http://schemas.openxmlformats.org/drawingml/2006/main">
-            <a:r>
-              <a:t/>
-            </a:r>
-          </a:p>
+              <a:t>Welcome to Week 1. Let me start with a small mystery, because it carries the whole week. A student reports a broken bench through a website. The website gives them a confirmation number. Then the repair desk opens its dashboard, and the request is not there.</a:t>
+            </a:r>
+          </a:p>
+          <a:p xmlns:a="http://schemas.openxmlformats.org/drawingml/2006/main"/>
+          <a:p xmlns:a="http://schemas.openxmlformats.org/drawingml/2006/main">
+            <a:r>
+              <a:t>So which is it? Did the system lose the request, or did the dashboard leave it out? Those sound similar, but they need completely different repairs. If the data is gone, we have a storage problem. If the data is there and the screen does not show it, we have a problem with the question the screen is asking. The line on the slide gives away where we are headed: the stored rows explain it.</a:t>
+            </a:r>
+          </a:p>
+          <a:p xmlns:a="http://schemas.openxmlformats.org/drawingml/2006/main"/>
+          <a:p xmlns:a="http://schemas.openxmlformats.org/drawingml/2006/main">
+            <a:r>
+              <a:t>Look at the three boxes: client, API, database. A database holds the organized facts an application needs to keep. A database management system, a DBMS, is the software that reads and changes those facts. The API, the application programming interface, is the agreed way for the browser to ask the application to do something. The browser almost never talks to the database directly.</a:t>
+            </a:r>
+          </a:p>
+          <a:p xmlns:a="http://schemas.openxmlformats.org/drawingml/2006/main"/>
+          <a:p xmlns:a="http://schemas.openxmlformats.org/drawingml/2006/main">
+            <a:r>
+              <a:t>Today we follow one request through those boxes. Next meeting we look at the rows and the rule behind the dashboard. You will see a little SQL, but the lab does not require you to remember SQL or create a cloud account. You will read a small dataset and explain a result.</a:t>
+            </a:r>
+          </a:p>
+          <a:p xmlns:a="http://schemas.openxmlformats.org/drawingml/2006/main"/>
           <a:p xmlns:a="http://schemas.openxmlformats.org/drawingml/2006/main">
             <a:r>
               <a:t>[Sources]</a:t>
@@ -569,44 +563,34 @@
           <a:lstStyle xmlns:a="http://schemas.openxmlformats.org/drawingml/2006/main"/>
           <a:p xmlns:a="http://schemas.openxmlformats.org/drawingml/2006/main">
             <a:r>
-              <a:t>This table shows three of the tickets used in our lab. The subjects are shortened on the slide so the fields remain readable. The lab handout contains the complete four-row example, including ticket 1009. Here we have four attributes: ticket identifier, subject, status, and assignee identifier. Each row describes one request.</a:t>
-            </a:r>
-          </a:p>
-          <a:p xmlns:a="http://schemas.openxmlformats.org/drawingml/2006/main">
-            <a:r>
-              <a:t/>
-            </a:r>
-          </a:p>
-          <a:p xmlns:a="http://schemas.openxmlformats.org/drawingml/2006/main">
-            <a:r>
-              <a:t>A tuple means one complete row of attribute values. Ticket 1001 is open and assigned to agent 201. Ticket 1003 is resolved and also assigned to agent 201. Ticket 1004 is new and has NULL in its assignee field. In this application, that NULL records the absence of an assignment. It is not the number zero and not the text word NULL. The ticket row itself still exists.</a:t>
-            </a:r>
-          </a:p>
-          <a:p xmlns:a="http://schemas.openxmlformats.org/drawingml/2006/main">
-            <a:r>
-              <a:t/>
-            </a:r>
-          </a:p>
-          <a:p xmlns:a="http://schemas.openxmlformats.org/drawingml/2006/main">
-            <a:r>
-              <a:t>A schema describes the permitted structure, including attribute names, types, and rules. A key identifies a row. We choose ticket_id as the primary key for this example, meaning it must be unique and cannot be NULL. Two requests might have the same subject, so the subject is not a dependable substitute for the identifier.</a:t>
-            </a:r>
-          </a:p>
-          <a:p xmlns:a="http://schemas.openxmlformats.org/drawingml/2006/main">
-            <a:r>
-              <a:t/>
-            </a:r>
-          </a:p>
-          <a:p xmlns:a="http://schemas.openxmlformats.org/drawingml/2006/main">
-            <a:r>
-              <a:t>The table's displayed row order is just a presentation choice. Relational reasoning does not treat the first displayed row as inherently first in the data. SQL similarly requires an explicit ordering rule when the result order matters. We will add ORDER BY in the SQL review. For now, follow identifiers rather than positions. That habit lets us track the same request through filters, joins, and later changes.</a:t>
-            </a:r>
-          </a:p>
-          <a:p xmlns:a="http://schemas.openxmlformats.org/drawingml/2006/main">
-            <a:r>
-              <a:t/>
-            </a:r>
-          </a:p>
+              <a:t>Here are three tickets from the lab. The subjects are shortened so they fit. The lab has a fourth ticket, 1009, that is not on this slide.</a:t>
+            </a:r>
+          </a:p>
+          <a:p xmlns:a="http://schemas.openxmlformats.org/drawingml/2006/main"/>
+          <a:p xmlns:a="http://schemas.openxmlformats.org/drawingml/2006/main">
+            <a:r>
+              <a:t>Look across the header: ticket_id, subject, status, assignee_id. Four attributes. Now read down the rows. Each one is a tuple, one complete row of values. Ticket 1001 is open and assigned to agent 201. Ticket 1003 is resolved and also assigned to agent 201. Ticket 1004 is new, and its assignee is NULL.</a:t>
+            </a:r>
+          </a:p>
+          <a:p xmlns:a="http://schemas.openxmlformats.org/drawingml/2006/main"/>
+          <a:p xmlns:a="http://schemas.openxmlformats.org/drawingml/2006/main">
+            <a:r>
+              <a:t>In this application, that NULL means nobody has been assigned yet. It is not the number zero, and it is not the word NULL typed into a box. And notice that the row is still there. A missing assignee is not a missing ticket. That distinction is going to solve our mystery.</a:t>
+            </a:r>
+          </a:p>
+          <a:p xmlns:a="http://schemas.openxmlformats.org/drawingml/2006/main"/>
+          <a:p xmlns:a="http://schemas.openxmlformats.org/drawingml/2006/main">
+            <a:r>
+              <a:t>Now the three labels on the right. The schema is the structure: attribute names, types, and rules. The key is stable identity. We make ticket_id the primary key, which means it must be unique and can never be NULL. Why not use the subject? Because two people can report a broken bench, and two requests can share a subject.</a:t>
+            </a:r>
+          </a:p>
+          <a:p xmlns:a="http://schemas.openxmlformats.org/drawingml/2006/main"/>
+          <a:p xmlns:a="http://schemas.openxmlformats.org/drawingml/2006/main">
+            <a:r>
+              <a:t>Last point. The order of the rows on the slide means nothing. A table has no built-in first row. If order matters, SQL makes you ask for it with ORDER BY, which we add next week. So follow IDs, not positions. That is how you track one request through filters, joins, and changes.</a:t>
+            </a:r>
+          </a:p>
+          <a:p xmlns:a="http://schemas.openxmlformats.org/drawingml/2006/main"/>
           <a:p xmlns:a="http://schemas.openxmlformats.org/drawingml/2006/main">
             <a:r>
               <a:t>[Sources]</a:t>
@@ -694,44 +678,34 @@
           <a:lstStyle xmlns:a="http://schemas.openxmlformats.org/drawingml/2006/main"/>
           <a:p xmlns:a="http://schemas.openxmlformats.org/drawingml/2006/main">
             <a:r>
-              <a:t>Schema and instance distinguish a rule from the facts currently governed by that rule. The schema on the left says tickets have identifiers, subjects, statuses, and assignee identifiers. The notation is a compact description, not a complete SQL CREATE TABLE command. Integer indicates a whole-number type. Text indicates a character string. A full SQL declaration would also state keys, nullability, and any additional constraints.</a:t>
-            </a:r>
-          </a:p>
-          <a:p xmlns:a="http://schemas.openxmlformats.org/drawingml/2006/main">
-            <a:r>
-              <a:t/>
-            </a:r>
-          </a:p>
-          <a:p xmlns:a="http://schemas.openxmlformats.org/drawingml/2006/main">
-            <a:r>
-              <a:t>The instance on the right means the rows present at one moment. Inserting a fourth ticket changes the instance without necessarily changing the schema. Renaming a column or adding a constraint changes the schema and may affect application code. We will study how to make such changes safely after rebuilding SQL fluency.</a:t>
-            </a:r>
-          </a:p>
-          <a:p xmlns:a="http://schemas.openxmlformats.org/drawingml/2006/main">
-            <a:r>
-              <a:t/>
-            </a:r>
-          </a:p>
-          <a:p xmlns:a="http://schemas.openxmlformats.org/drawingml/2006/main">
-            <a:r>
-              <a:t>A domain is the set of values permitted for an attribute. An integer type rules out ordinary words, but a type alone may be too broad for an application's meaning. Status is text, yet our course case uses a specific vocabulary: new, open, resolved, and closed. The application considers only new and open active. A database constraint can reject misspellings, but it cannot choose the organization's intended vocabulary for us.</a:t>
-            </a:r>
-          </a:p>
-          <a:p xmlns:a="http://schemas.openxmlformats.org/drawingml/2006/main">
-            <a:r>
-              <a:t/>
-            </a:r>
-          </a:p>
-          <a:p xmlns:a="http://schemas.openxmlformats.org/drawingml/2006/main">
-            <a:r>
-              <a:t>A separate nullability rule decides whether a value must be present. Ticket identifiers must be present. An assignee can be absent until someone takes the work. Treating every missing value as an error would prevent us from representing a valid unassigned request. The correct rule depends on what the attribute means. This distinction becomes important in the lab because an unassigned ticket can be active and still deserve a place on the staff dashboard.</a:t>
-            </a:r>
-          </a:p>
-          <a:p xmlns:a="http://schemas.openxmlformats.org/drawingml/2006/main">
-            <a:r>
-              <a:t/>
-            </a:r>
-          </a:p>
+              <a:t>The schema is the rule. The instance is the rows that exist right now under that rule.</a:t>
+            </a:r>
+          </a:p>
+          <a:p xmlns:a="http://schemas.openxmlformats.org/drawingml/2006/main"/>
+          <a:p xmlns:a="http://schemas.openxmlformats.org/drawingml/2006/main">
+            <a:r>
+              <a:t>On the left, tickets has a ticket_id that is an integer, a subject that is text, a status that is text, and an assignee_id that is an integer. That is shorthand notation, not a full SQL command. A real CREATE TABLE would also declare keys, nullability, and other constraints.</a:t>
+            </a:r>
+          </a:p>
+          <a:p xmlns:a="http://schemas.openxmlformats.org/drawingml/2006/main"/>
+          <a:p xmlns:a="http://schemas.openxmlformats.org/drawingml/2006/main">
+            <a:r>
+              <a:t>Now the instance. At 10:00 there are 3 tickets. At 10:05 there are 4. A row was inserted, and the schema did not change. The instance changes every time rows are inserted, updated, or deleted. Renaming a column, by contrast, changes the schema and can break application code.</a:t>
+            </a:r>
+          </a:p>
+          <a:p xmlns:a="http://schemas.openxmlformats.org/drawingml/2006/main"/>
+          <a:p xmlns:a="http://schemas.openxmlformats.org/drawingml/2006/main">
+            <a:r>
+              <a:t>Look at the right box, status values: new, open, resolved, closed. Those are the four values in this week's small case. A domain is the set of values an attribute is allowed to have. The type says text, but text is far too broad. A constraint can reject a misspelling like "opne," but it cannot decide what the vocabulary should be. When you meet the full Metro Support data next week, you will see a fifth status, in_progress, which is exactly why the meaning of active has to be written down.</a:t>
+            </a:r>
+          </a:p>
+          <a:p xmlns:a="http://schemas.openxmlformats.org/drawingml/2006/main"/>
+          <a:p xmlns:a="http://schemas.openxmlformats.org/drawingml/2006/main">
+            <a:r>
+              <a:t>Nullability is a separate decision. A ticket ID must be present. An assignee can be missing until someone takes the job. If we required it, we could not record a valid unassigned request, and that request still belongs on the dashboard.</a:t>
+            </a:r>
+          </a:p>
+          <a:p xmlns:a="http://schemas.openxmlformats.org/drawingml/2006/main"/>
           <a:p xmlns:a="http://schemas.openxmlformats.org/drawingml/2006/main">
             <a:r>
               <a:t>[Sources]</a:t>
@@ -814,44 +788,28 @@
           <a:lstStyle xmlns:a="http://schemas.openxmlformats.org/drawingml/2006/main"/>
           <a:p xmlns:a="http://schemas.openxmlformats.org/drawingml/2006/main">
             <a:r>
-              <a:t>The agents table records staff identities. Agent 201 is Priya Shah, and agent 202 is Noah Williams. In this example, agent_id is the primary key. A ticket's assignee_id can refer to that key. The arrow points from the reference in tickets toward the identified agent.</a:t>
-            </a:r>
-          </a:p>
-          <a:p xmlns:a="http://schemas.openxmlformats.org/drawingml/2006/main">
-            <a:r>
-              <a:t/>
-            </a:r>
-          </a:p>
-          <a:p xmlns:a="http://schemas.openxmlformats.org/drawingml/2006/main">
-            <a:r>
-              <a:t>Ticket 1001 stores 201 rather than repeating Priya's full staff record. Ticket 1003 refers to the same agent. This is a many-to-one relationship: several tickets can refer to one agent. The reference does not require an agent to have a ticket. Noah can exist in the agents table even when no displayed ticket is assigned to Noah.</a:t>
-            </a:r>
-          </a:p>
-          <a:p xmlns:a="http://schemas.openxmlformats.org/drawingml/2006/main">
-            <a:r>
-              <a:t/>
-            </a:r>
-          </a:p>
-          <a:p xmlns:a="http://schemas.openxmlformats.org/drawingml/2006/main">
-            <a:r>
-              <a:t>A declared foreign key constraint checks that a non-NULL reference has an allowed matching key. If a ticket refers to nonexistent agent 999, the database can reject that value. A nullable foreign key also permits the unassigned state shown for ticket 1004. NULL does not create an imaginary agent, and it does not identify a matching agent record.</a:t>
-            </a:r>
-          </a:p>
-          <a:p xmlns:a="http://schemas.openxmlformats.org/drawingml/2006/main">
-            <a:r>
-              <a:t/>
-            </a:r>
-          </a:p>
-          <a:p xmlns:a="http://schemas.openxmlformats.org/drawingml/2006/main">
-            <a:r>
-              <a:t>Storing an identifier and combining records are different operations. The foreign key constrains a relationship. A join uses a matching condition to produce a query result that can include both the ticket subject and the agent name. SQL can perform a join even without a declared foreign key, but then we must be especially careful about what matches and whether the data satisfies the relationship we assume. Our next examples show how those matching decisions change a report.</a:t>
-            </a:r>
-          </a:p>
-          <a:p xmlns:a="http://schemas.openxmlformats.org/drawingml/2006/main">
-            <a:r>
-              <a:t/>
-            </a:r>
-          </a:p>
+              <a:t>Look at the agents table: two staff rows, agent IDs 201 and 202. The names are deliberately plain labels, Agent 201 and Agent 202, so you can keep your eyes on the IDs. In this table agent_id is the primary key. The assignee_id column in tickets refers to that key, and the arrow on the slide, PK from FK, points from the reference in tickets to the agent it identifies.</a:t>
+            </a:r>
+          </a:p>
+          <a:p xmlns:a="http://schemas.openxmlformats.org/drawingml/2006/main"/>
+          <a:p xmlns:a="http://schemas.openxmlformats.org/drawingml/2006/main">
+            <a:r>
+              <a:t>Ticket 1001 stores just the number 201. It does not copy the agent's whole record into the ticket. Why? Because if the agent's details change, we want to change them in one place, not in every ticket. Ticket 1003 points at the same agent. That is a many-to-one relationship: many tickets can refer to one agent. It does not work the other way. Agent 202 exists even though no ticket on this slide points to them.</a:t>
+            </a:r>
+          </a:p>
+          <a:p xmlns:a="http://schemas.openxmlformats.org/drawingml/2006/main"/>
+          <a:p xmlns:a="http://schemas.openxmlformats.org/drawingml/2006/main">
+            <a:r>
+              <a:t>A declared foreign key constraint checks every non-NULL reference. If someone tries to assign a ticket to agent 999, the database can refuse. And because this foreign key allows NULL, ticket 1004 can say "no agent yet." NULL does not invent an agent, and it does not match one either.</a:t>
+            </a:r>
+          </a:p>
+          <a:p xmlns:a="http://schemas.openxmlformats.org/drawingml/2006/main"/>
+          <a:p xmlns:a="http://schemas.openxmlformats.org/drawingml/2006/main">
+            <a:r>
+              <a:t>A foreign key constrains a relationship. A join is a query that combines the rows. SQL will happily join tables with no declared foreign key, but then nothing has checked that the matches you assume are really there. Next we see how matching decisions change a report.</a:t>
+            </a:r>
+          </a:p>
+          <a:p xmlns:a="http://schemas.openxmlformats.org/drawingml/2006/main"/>
           <a:p xmlns:a="http://schemas.openxmlformats.org/drawingml/2006/main">
             <a:r>
               <a:t>[Sources]</a:t>
@@ -934,44 +892,34 @@
           <a:lstStyle xmlns:a="http://schemas.openxmlformats.org/drawingml/2006/main"/>
           <a:p xmlns:a="http://schemas.openxmlformats.org/drawingml/2006/main">
             <a:r>
-              <a:t>Selection keeps rows satisfying a condition. The Greek letter sigma names this operation. In this example the condition is status equals open. Apply it to each row in the displayed ticket excerpt. Ticket 1001 satisfies it. Ticket 1003 is resolved, and ticket 1004 is new, so neither satisfies this particular condition. Only the highlighted row remains.</a:t>
-            </a:r>
-          </a:p>
-          <a:p xmlns:a="http://schemas.openxmlformats.org/drawingml/2006/main">
-            <a:r>
-              <a:t/>
-            </a:r>
-          </a:p>
-          <a:p xmlns:a="http://schemas.openxmlformats.org/drawingml/2006/main">
-            <a:r>
-              <a:t>The SQL statement expresses the same filtering idea. FROM tickets names the input table. WHERE status equals open supplies the condition. SELECT star requests every column of the qualifying row. Selection therefore changes which rows remain while retaining the input attributes. It does not change the status value in any stored row, and it does not delete the excluded tickets.</a:t>
-            </a:r>
-          </a:p>
-          <a:p xmlns:a="http://schemas.openxmlformats.org/drawingml/2006/main">
-            <a:r>
-              <a:t/>
-            </a:r>
-          </a:p>
-          <a:p xmlns:a="http://schemas.openxmlformats.org/drawingml/2006/main">
-            <a:r>
-              <a:t>Notice the difference between open and active. Our lab defines active as either new or open. This example deliberately selects only open tickets so we can see one equality test clearly. If we used this condition for a dashboard promising every active ticket, it would omit new requests. A syntactically valid condition can still express an incomplete business rule.</a:t>
-            </a:r>
-          </a:p>
-          <a:p xmlns:a="http://schemas.openxmlformats.org/drawingml/2006/main">
-            <a:r>
-              <a:t/>
-            </a:r>
-          </a:p>
-          <a:p xmlns:a="http://schemas.openxmlformats.org/drawingml/2006/main">
-            <a:r>
-              <a:t>We will build the broader active condition in the combined query. First, keep the two questions separate: which rows qualify, and which columns should the result contain? WHERE answers the first question. The list after SELECT answers the second. Despite the word SELECT in SQL, relational selection is the row-filtering idea, not simply the name of the first SQL keyword.</a:t>
-            </a:r>
-          </a:p>
-          <a:p xmlns:a="http://schemas.openxmlformats.org/drawingml/2006/main">
-            <a:r>
-              <a:t/>
-            </a:r>
-          </a:p>
+              <a:t>First relational operation: selection. The Greek letter sigma. Selection keeps the rows that satisfy a condition, and here the condition is status equals open.</a:t>
+            </a:r>
+          </a:p>
+          <a:p xmlns:a="http://schemas.openxmlformats.org/drawingml/2006/main"/>
+          <a:p xmlns:a="http://schemas.openxmlformats.org/drawingml/2006/main">
+            <a:r>
+              <a:t>Let's apply it ourselves, row by row. Ticket 1001, status open. It passes. Ticket 1003, resolved. It fails. Ticket 1004, new. It also fails, because new is not the same word as open. So only the highlighted row, 1001, survives.</a:t>
+            </a:r>
+          </a:p>
+          <a:p xmlns:a="http://schemas.openxmlformats.org/drawingml/2006/main"/>
+          <a:p xmlns:a="http://schemas.openxmlformats.org/drawingml/2006/main">
+            <a:r>
+              <a:t>Now look at the SQL box. FROM tickets names the input. WHERE status equals open is the condition. SELECT star asks for every column of the rows that pass. Notice what did not happen. No status was changed, and no ticket was deleted. Tickets 1003 and 1004 are still sitting in the table. They just are not in this result.</a:t>
+            </a:r>
+          </a:p>
+          <a:p xmlns:a="http://schemas.openxmlformats.org/drawingml/2006/main"/>
+          <a:p xmlns:a="http://schemas.openxmlformats.org/drawingml/2006/main">
+            <a:r>
+              <a:t>Here is the trap, and it is the same trap as our mystery. Our dashboard promises every active ticket, and active means new or open. If someone wrote this query for that dashboard, every new request would vanish from the screen. The query is perfectly valid SQL, and it runs without a single error. It is just the wrong rule. Valid syntax does not mean a correct business rule.</a:t>
+            </a:r>
+          </a:p>
+          <a:p xmlns:a="http://schemas.openxmlformats.org/drawingml/2006/main"/>
+          <a:p xmlns:a="http://schemas.openxmlformats.org/drawingml/2006/main">
+            <a:r>
+              <a:t>Keep two questions apart. Which rows qualify? That is the WHERE clause. Which columns come back? That is the list after SELECT. And yes, this is confusing: the SQL keyword SELECT is not relational selection. Relational selection is the row filter, and in SQL that lives in WHERE.</a:t>
+            </a:r>
+          </a:p>
+          <a:p xmlns:a="http://schemas.openxmlformats.org/drawingml/2006/main"/>
           <a:p xmlns:a="http://schemas.openxmlformats.org/drawingml/2006/main">
             <a:r>
               <a:t>[Sources]</a:t>
@@ -1054,44 +1002,34 @@
           <a:lstStyle xmlns:a="http://schemas.openxmlformats.org/drawingml/2006/main"/>
           <a:p xmlns:a="http://schemas.openxmlformats.org/drawingml/2006/main">
             <a:r>
-              <a:t>Projection keeps selected attributes. Pi denotes projection in relational algebra. Here the highlighted columns are ticket_id and subject. Projecting those attributes gives a result with two columns. We have not added a condition on status, so the projection still represents all three displayed tickets.</a:t>
-            </a:r>
-          </a:p>
-          <a:p xmlns:a="http://schemas.openxmlformats.org/drawingml/2006/main">
-            <a:r>
-              <a:t/>
-            </a:r>
-          </a:p>
-          <a:p xmlns:a="http://schemas.openxmlformats.org/drawingml/2006/main">
-            <a:r>
-              <a:t>The SQL list after SELECT names the requested output columns. SELECT ticket_id comma subject FROM tickets returns those two attributes. Compare it with the preceding slide: the WHERE condition chose rows, while this list chooses columns. In the full lab table, the same statement would include all four tickets because the full table also contains ticket 1009. The slide is showing an excerpt rather than changing the lab's data.</a:t>
-            </a:r>
-          </a:p>
-          <a:p xmlns:a="http://schemas.openxmlformats.org/drawingml/2006/main">
-            <a:r>
-              <a:t/>
-            </a:r>
-          </a:p>
-          <a:p xmlns:a="http://schemas.openxmlformats.org/drawingml/2006/main">
-            <a:r>
-              <a:t>There is one important difference between classical projection and ordinary SQL. A mathematical relation is a set, so duplicate output tuples collapse into one. An ordinary SQL SELECT can keep duplicates. If we projected only assignee_id, repeated assignments to agent 201 could produce repeated values in SQL. SELECT DISTINCT is how SQL explicitly removes duplicates from the output. In today's identifier-and-subject projection, the unique ticket identifier distinguishes each row.</a:t>
-            </a:r>
-          </a:p>
-          <a:p xmlns:a="http://schemas.openxmlformats.org/drawingml/2006/main">
-            <a:r>
-              <a:t/>
-            </a:r>
-          </a:p>
-          <a:p xmlns:a="http://schemas.openxmlformats.org/drawingml/2006/main">
-            <a:r>
-              <a:t>Projection does not remove columns from the stored table. It describes what one query exposes to its reader. An application can display a short list containing identifiers and subjects while retaining statuses, assignments, and other information in the database. Later, we will also consider when exposing fewer columns supports a permission boundary, while recognizing that hiding a field on a screen alone does not enforce database security.</a:t>
-            </a:r>
-          </a:p>
-          <a:p xmlns:a="http://schemas.openxmlformats.org/drawingml/2006/main">
-            <a:r>
-              <a:t/>
-            </a:r>
-          </a:p>
+              <a:t>Second operation: projection, the Greek letter pi. Selection chose rows. Projection chooses columns.</a:t>
+            </a:r>
+          </a:p>
+          <a:p xmlns:a="http://schemas.openxmlformats.org/drawingml/2006/main"/>
+          <a:p xmlns:a="http://schemas.openxmlformats.org/drawingml/2006/main">
+            <a:r>
+              <a:t>Look at the highlighted columns, ticket_id and subject. Project those two and you get a two-column result. We did not add any condition on status, so all three tickets from the slide are still there, each with just two attributes. In the full lab table the same query would return four rows, because the lab also has ticket 1009.</a:t>
+            </a:r>
+          </a:p>
+          <a:p xmlns:a="http://schemas.openxmlformats.org/drawingml/2006/main"/>
+          <a:p xmlns:a="http://schemas.openxmlformats.org/drawingml/2006/main">
+            <a:r>
+              <a:t>Look at the SQL box. SELECT ticket_id, subject FROM tickets. The list after SELECT names the output columns. Compare that with the last slide: there the WHERE clause chose rows, and here the SELECT list chooses columns.</a:t>
+            </a:r>
+          </a:p>
+          <a:p xmlns:a="http://schemas.openxmlformats.org/drawingml/2006/main"/>
+          <a:p xmlns:a="http://schemas.openxmlformats.org/drawingml/2006/main">
+            <a:r>
+              <a:t>Now the difference the subtitle mentions. A mathematical relation is a set, so if two output rows are identical, they collapse into one. Ordinary SQL keeps both. Picture projecting only assignee_id. Tickets 1001 and 1003 both have 201, so SQL would show 201 twice. If you want duplicates removed, you have to ask with SELECT DISTINCT. In today's example that never comes up, because ticket_id is unique, so every row is already different.</a:t>
+            </a:r>
+          </a:p>
+          <a:p xmlns:a="http://schemas.openxmlformats.org/drawingml/2006/main"/>
+          <a:p xmlns:a="http://schemas.openxmlformats.org/drawingml/2006/main">
+            <a:r>
+              <a:t>Projection does not remove anything from the stored table. It only decides what this one query shows its reader. A screen can show IDs and subjects while the database keeps everything else. Later we will use a limited view of columns as part of a permission boundary. But hiding a field on a screen is not, by itself, security.</a:t>
+            </a:r>
+          </a:p>
+          <a:p xmlns:a="http://schemas.openxmlformats.org/drawingml/2006/main"/>
           <a:p xmlns:a="http://schemas.openxmlformats.org/drawingml/2006/main">
             <a:r>
               <a:t>[Sources]</a:t>
@@ -1174,44 +1112,40 @@
           <a:lstStyle xmlns:a="http://schemas.openxmlformats.org/drawingml/2006/main"/>
           <a:p xmlns:a="http://schemas.openxmlformats.org/drawingml/2006/main">
             <a:r>
-              <a:t>A Cartesian product pairs every row from one input with every row from another. The vertical bars in this notation mean the number of rows. With four tickets and two agents, there are eight possible ticket-agent pairs. That includes arbitrary pairs such as ticket 1001 with Noah even though its assignee identifier is 201.</a:t>
-            </a:r>
-          </a:p>
-          <a:p xmlns:a="http://schemas.openxmlformats.org/drawingml/2006/main">
-            <a:r>
-              <a:t/>
-            </a:r>
-          </a:p>
-          <a:p xmlns:a="http://schemas.openxmlformats.org/drawingml/2006/main">
-            <a:r>
-              <a:t>An equality join retains pairs whose values satisfy an equality condition. For this case, the condition compares tickets.assignee_id with agents.agent_id. Ticket 1001 matches Priya because both identifiers are 201. Ticket 1003 matches Priya for the same reason. Ticket 1004 and ticket 1009 have no matching agent because they are unassigned. Noah has no matching ticket in the original lab data.</a:t>
-            </a:r>
-          </a:p>
-          <a:p xmlns:a="http://schemas.openxmlformats.org/drawingml/2006/main">
-            <a:r>
-              <a:t/>
-            </a:r>
-          </a:p>
-          <a:p xmlns:a="http://schemas.openxmlformats.org/drawingml/2006/main">
-            <a:r>
-              <a:t>This is a conceptual explanation of join meaning. It does not require the database to physically build all eight pairs before filtering them. A database can choose an efficient algorithm that produces the same result. We will study those execution choices after we understand the desired rows.</a:t>
-            </a:r>
-          </a:p>
-          <a:p xmlns:a="http://schemas.openxmlformats.org/drawingml/2006/main">
-            <a:r>
-              <a:t/>
-            </a:r>
-          </a:p>
-          <a:p xmlns:a="http://schemas.openxmlformats.org/drawingml/2006/main">
-            <a:r>
-              <a:t>An inner join keeps only matches. A left join can preserve rows from its left input even when the right input has no match. That distinction is central to the dashboard problem. Keeping a ticket row in a query result does not require us to invent an assignee. We can preserve the ticket and show that the assignment is missing. The output row count depends on both the matching condition and the data. Neither the word join nor the size of a table is enough to predict it.</a:t>
-            </a:r>
-          </a:p>
-          <a:p xmlns:a="http://schemas.openxmlformats.org/drawingml/2006/main">
-            <a:r>
-              <a:t/>
-            </a:r>
-          </a:p>
+              <a:t>Now we combine two tables, and there are two very different ways to do it.</a:t>
+            </a:r>
+          </a:p>
+          <a:p xmlns:a="http://schemas.openxmlformats.org/drawingml/2006/main"/>
+          <a:p xmlns:a="http://schemas.openxmlformats.org/drawingml/2006/main">
+            <a:r>
+              <a:t>Look at the left box, the Cartesian product, R times S. It pairs every ticket with every agent. The vertical bars mean "number of rows." The full lab has 4 tickets and 2 agents, so the product has 8 pairs. Most of them are nonsense. Ticket 1001 gets paired with Agent 202, even though its assignee is 201. The product does not care what the rows mean.</a:t>
+            </a:r>
+          </a:p>
+          <a:p xmlns:a="http://schemas.openxmlformats.org/drawingml/2006/main"/>
+          <a:p xmlns:a="http://schemas.openxmlformats.org/drawingml/2006/main">
+            <a:r>
+              <a:t>The right box is the join. A join keeps only the pairs that satisfy a condition, and the condition is written right there: tickets.assignee_id equals agents.agent_id. That condition is the whole point. The join symbol by itself does not tell you what matches.</a:t>
+            </a:r>
+          </a:p>
+          <a:p xmlns:a="http://schemas.openxmlformats.org/drawingml/2006/main"/>
+          <a:p xmlns:a="http://schemas.openxmlformats.org/drawingml/2006/main">
+            <a:r>
+              <a:t>Ticket 1001 has 201, and Agent 201 has 201. Match. Ticket 1003, also 201. Match. Tickets 1004 and 1009 have NULL, and NULL matches nothing, so neither one produces a row. And Agent 202 has no ticket pointing at them in the lab data.</a:t>
+            </a:r>
+          </a:p>
+          <a:p xmlns:a="http://schemas.openxmlformats.org/drawingml/2006/main"/>
+          <a:p xmlns:a="http://schemas.openxmlformats.org/drawingml/2006/main">
+            <a:r>
+              <a:t>This is what a join means, not how it runs. The database does not have to build all 8 pairs first. It picks an efficient method that gives the same answer.</a:t>
+            </a:r>
+          </a:p>
+          <a:p xmlns:a="http://schemas.openxmlformats.org/drawingml/2006/main"/>
+          <a:p xmlns:a="http://schemas.openxmlformats.org/drawingml/2006/main">
+            <a:r>
+              <a:t>And look at the line at the bottom of the slide. An inner join keeps only matches. A left join can keep a ticket even when its assignee has no match, without inventing an agent. Hold on to that sentence, because it is the fix for our dashboard.</a:t>
+            </a:r>
+          </a:p>
+          <a:p xmlns:a="http://schemas.openxmlformats.org/drawingml/2006/main"/>
           <a:p xmlns:a="http://schemas.openxmlformats.org/drawingml/2006/main">
             <a:r>
               <a:t>[Sources]</a:t>
@@ -1294,44 +1228,34 @@
           <a:lstStyle xmlns:a="http://schemas.openxmlformats.org/drawingml/2006/main"/>
           <a:p xmlns:a="http://schemas.openxmlformats.org/drawingml/2006/main">
             <a:r>
-              <a:t>This query expresses the dashboard rule supplied in the lab. The left side explains the operations in words, and the right side shows their SQL representation. It uses all four lab tickets and both agents. You do not need to execute it to complete the assignment.</a:t>
-            </a:r>
-          </a:p>
-          <a:p xmlns:a="http://schemas.openxmlformats.org/drawingml/2006/main">
-            <a:r>
-              <a:t/>
-            </a:r>
-          </a:p>
-          <a:p xmlns:a="http://schemas.openxmlformats.org/drawingml/2006/main">
-            <a:r>
-              <a:t>FROM tickets AS t gives the tickets table the short name t. JOIN agents AS a introduces the agents table with the short name a. ON t.assignee_id equals a.agent_id supplies the matching condition. Because this is an inner join, a ticket without a matching agent does not produce an output row. WHERE then keeps statuses in the list new and open. IN means the status may equal either listed value. SELECT chooses the ticket identifier, subject, and matching agent name for the displayed result.</a:t>
-            </a:r>
-          </a:p>
-          <a:p xmlns:a="http://schemas.openxmlformats.org/drawingml/2006/main">
-            <a:r>
-              <a:t/>
-            </a:r>
-          </a:p>
-          <a:p xmlns:a="http://schemas.openxmlformats.org/drawingml/2006/main">
-            <a:r>
-              <a:t>These clauses let us name two independent decisions. One decision defines active work through the status condition. Another decision requires an agent match. A dashboard can implement the active condition correctly and still omit active work because of the join. The DBMS can execute that query exactly as written while the result violates the dashboard's promise.</a:t>
-            </a:r>
-          </a:p>
-          <a:p xmlns:a="http://schemas.openxmlformats.org/drawingml/2006/main">
-            <a:r>
-              <a:t/>
-            </a:r>
-          </a:p>
-          <a:p xmlns:a="http://schemas.openxmlformats.org/drawingml/2006/main">
-            <a:r>
-              <a:t>For the lab, compare the qualifying ticket identifiers with the identifiers the current dashboard actually returns. Then consider the supplied change that assigns ticket 1004 to Noah. That is a change to the data, not a change to the query's rule. Your explanation should distinguish those two ways of changing a result. If the intended report includes unassigned work, describe the necessary behavior in plain language. We will write and verify the corresponding outer join during the SQL review.</a:t>
-            </a:r>
-          </a:p>
-          <a:p xmlns:a="http://schemas.openxmlformats.org/drawingml/2006/main">
-            <a:r>
-              <a:t/>
-            </a:r>
-          </a:p>
+              <a:t>Here is the actual dashboard query from the lab. The left side says it in words. The right side is the SQL. You do not need to run it for the assignment.</a:t>
+            </a:r>
+          </a:p>
+          <a:p xmlns:a="http://schemas.openxmlformats.org/drawingml/2006/main"/>
+          <a:p xmlns:a="http://schemas.openxmlformats.org/drawingml/2006/main">
+            <a:r>
+              <a:t>FROM tickets AS t gives the tickets table the short name t. JOIN agents AS a brings in agents as a. ON t.assignee_id equals a.agent_id is the matching condition. Because this is an inner join, a ticket with no matching agent produces no row at all. WHERE t.status IN new, open keeps the active statuses. And the SELECT list returns the ticket ID, the subject, and the agent's name.</a:t>
+            </a:r>
+          </a:p>
+          <a:p xmlns:a="http://schemas.openxmlformats.org/drawingml/2006/main"/>
+          <a:p xmlns:a="http://schemas.openxmlformats.org/drawingml/2006/main">
+            <a:r>
+              <a:t>On the slide I numbered the steps match, then keep active, then choose columns. Your lab describes the first two in the other order. For an inner join with a WHERE condition, the order you think about them in does not change which rows come out.</a:t>
+            </a:r>
+          </a:p>
+          <a:p xmlns:a="http://schemas.openxmlformats.org/drawingml/2006/main"/>
+          <a:p xmlns:a="http://schemas.openxmlformats.org/drawingml/2006/main">
+            <a:r>
+              <a:t>This query contains two separate decisions. One defines active work, the status condition. The other requires an agent match. The status rule can be perfect and the dashboard can still drop active work because of the join. The DBMS runs this query exactly as written, and the result still breaks the dashboard's promise.</a:t>
+            </a:r>
+          </a:p>
+          <a:p xmlns:a="http://schemas.openxmlformats.org/drawingml/2006/main"/>
+          <a:p xmlns:a="http://schemas.openxmlformats.org/drawingml/2006/main">
+            <a:r>
+              <a:t>For the lab, list the IDs that should appear and compare them with what the dashboard shows. Then predict what happens if ticket 1004 is assigned to Agent 202. That changes the data, not the rule. Describe the fix in plain words. We write the outer join next week.</a:t>
+            </a:r>
+          </a:p>
+          <a:p xmlns:a="http://schemas.openxmlformats.org/drawingml/2006/main"/>
           <a:p xmlns:a="http://schemas.openxmlformats.org/drawingml/2006/main">
             <a:r>
               <a:t>[Sources]</a:t>
@@ -1414,44 +1338,46 @@
           <a:lstStyle xmlns:a="http://schemas.openxmlformats.org/drawingml/2006/main"/>
           <a:p xmlns:a="http://schemas.openxmlformats.org/drawingml/2006/main">
             <a:r>
-              <a:t>We can now connect the two parts of the week. A browser sends a request to an application. The application checks permissions and asks the DBMS to read or change stored data. A later dashboard query selects and combines some of that data. Those steps explain why a successful write and a complete report require separate checks.</a:t>
-            </a:r>
-          </a:p>
-          <a:p xmlns:a="http://schemas.openxmlformats.org/drawingml/2006/main">
-            <a:r>
-              <a:t/>
-            </a:r>
-          </a:p>
-          <a:p xmlns:a="http://schemas.openxmlformats.org/drawingml/2006/main">
-            <a:r>
-              <a:t>The relational vocabulary gives us a way to describe the data precisely. One ticket row represents one request. A primary key distinguishes that request from other requests. A nullable assignee reference can represent work that no agent has accepted yet. Selection decides which rows satisfy a condition. Projection decides which attributes a result contains. A join uses a matching condition to combine rows, and an inner join omits rows without matches.</a:t>
-            </a:r>
-          </a:p>
-          <a:p xmlns:a="http://schemas.openxmlformats.org/drawingml/2006/main">
-            <a:r>
-              <a:t/>
-            </a:r>
-          </a:p>
-          <a:p xmlns:a="http://schemas.openxmlformats.org/drawingml/2006/main">
-            <a:r>
-              <a:t>Use those ideas to finish the single individual lab in Brightspace. Its required response is the short request trace and the explanation based on the supplied rows, including the prediction after the assignment changes. You do not need to create a GitHub repository, install a database, or submit a second reflection for this exercise.</a:t>
-            </a:r>
-          </a:p>
-          <a:p xmlns:a="http://schemas.openxmlformats.org/drawingml/2006/main">
-            <a:r>
-              <a:t/>
-            </a:r>
-          </a:p>
-          <a:p xmlns:a="http://schemas.openxmlformats.org/drawingml/2006/main">
-            <a:r>
-              <a:t>Next week provides a substantial SQL review. We will write filters, work carefully with NULL, compare inner and outer joins, and construct summaries whose counts mean what we intend. We will also practice changing data inside a transaction and rolling the practice change back. The weekly guide identifies the assigned reading. In the complete course package that includes the relevant sections of our textbook. The Week 1-only package provides free PostgreSQL readings without requiring access to the unpublished book.</a:t>
-            </a:r>
-          </a:p>
-          <a:p xmlns:a="http://schemas.openxmlformats.org/drawingml/2006/main">
-            <a:r>
-              <a:t/>
-            </a:r>
-          </a:p>
+              <a:t>Let's pull the week together, box by box.</a:t>
+            </a:r>
+          </a:p>
+          <a:p xmlns:a="http://schemas.openxmlformats.org/drawingml/2006/main"/>
+          <a:p xmlns:a="http://schemas.openxmlformats.org/drawingml/2006/main">
+            <a:r>
+              <a:t>Request path: client, API, identity, DBMS, data. A browser sends a request, the application checks who is asking and what they may do, and the DBMS reads or changes stored data. A dashboard is a later, separate query. That is why a successful save and a complete report need separate checks.</a:t>
+            </a:r>
+          </a:p>
+          <a:p xmlns:a="http://schemas.openxmlformats.org/drawingml/2006/main"/>
+          <a:p xmlns:a="http://schemas.openxmlformats.org/drawingml/2006/main">
+            <a:r>
+              <a:t>System layers: the database is not the DBMS, and the DBMS is not the managed platform. Naming the layer tells you where to look.</a:t>
+            </a:r>
+          </a:p>
+          <a:p xmlns:a="http://schemas.openxmlformats.org/drawingml/2006/main"/>
+          <a:p xmlns:a="http://schemas.openxmlformats.org/drawingml/2006/main">
+            <a:r>
+              <a:t>Row meaning: relations, attributes, tuples, domains, keys. One ticket row is one request. The primary key tells requests apart. A nullable assignee lets us record work nobody has accepted yet.</a:t>
+            </a:r>
+          </a:p>
+          <a:p xmlns:a="http://schemas.openxmlformats.org/drawingml/2006/main"/>
+          <a:p xmlns:a="http://schemas.openxmlformats.org/drawingml/2006/main">
+            <a:r>
+              <a:t>Query operations: selection decides which rows qualify, projection decides which columns come back, and a join combines rows by a matching condition. An inner join drops rows that have no match. That one sentence explains our missing tickets.</a:t>
+            </a:r>
+          </a:p>
+          <a:p xmlns:a="http://schemas.openxmlformats.org/drawingml/2006/main"/>
+          <a:p xmlns:a="http://schemas.openxmlformats.org/drawingml/2006/main">
+            <a:r>
+              <a:t>Now the lab. It is one individual submission in Brightspace: your short request trace, your explanation based on the supplied rows, and your prediction after the assignment changes. The lab itself does not need SQL, a cloud account, or GitHub.</a:t>
+            </a:r>
+          </a:p>
+          <a:p xmlns:a="http://schemas.openxmlformats.org/drawingml/2006/main"/>
+          <a:p xmlns:a="http://schemas.openxmlformats.org/drawingml/2006/main">
+            <a:r>
+              <a:t>Next week is a substantial SQL review. We write filters, handle NULL carefully, compare inner and outer joins, and build summaries whose counts mean what we intend. We also practice changing data inside a transaction and rolling the change back. The Week 2 guide assigns the reading from Chapter 2. Before then, review filtering, NULL, and joins.</a:t>
+            </a:r>
+          </a:p>
+          <a:p xmlns:a="http://schemas.openxmlformats.org/drawingml/2006/main"/>
           <a:p xmlns:a="http://schemas.openxmlformats.org/drawingml/2006/main">
             <a:r>
               <a:t>[Sources]</a:t>
@@ -1609,44 +1535,34 @@
           <a:lstStyle xmlns:a="http://schemas.openxmlformats.org/drawingml/2006/main"/>
           <a:p xmlns:a="http://schemas.openxmlformats.org/drawingml/2006/main">
             <a:r>
-              <a:t>The repair desk is a fictional teaching case. Each ticket represents one request for work. The database records its identifier, subject, current status, and staff assignment. An identifier gives us a way to talk about the same request even if its subject or status changes.</a:t>
-            </a:r>
-          </a:p>
-          <a:p xmlns:a="http://schemas.openxmlformats.org/drawingml/2006/main">
-            <a:r>
-              <a:t/>
-            </a:r>
-          </a:p>
-          <a:p xmlns:a="http://schemas.openxmlformats.org/drawingml/2006/main">
-            <a:r>
-              <a:t>The dashboard promises to show every active request. We must define active before we can test that promise. In this exercise, new and open requests count as active. A resolved request does not. Those are application rules. A database cannot infer what a repair desk intends the word active to mean. Someone must express the rule in the software.</a:t>
-            </a:r>
-          </a:p>
-          <a:p xmlns:a="http://schemas.openxmlformats.org/drawingml/2006/main">
-            <a:r>
-              <a:t/>
-            </a:r>
-          </a:p>
-          <a:p xmlns:a="http://schemas.openxmlformats.org/drawingml/2006/main">
-            <a:r>
-              <a:t>The student has confirmation number 1004 for a broken bench. That number lets us compare the student's experience with the stored record and the dashboard result. It does not, by itself, prove which part of the system failed. A response could contain an incorrect number, or a later query could exclude a valid record. The lab supplies the stored rows so we can examine this distinction directly.</a:t>
-            </a:r>
-          </a:p>
-          <a:p xmlns:a="http://schemas.openxmlformats.org/drawingml/2006/main">
-            <a:r>
-              <a:t/>
-            </a:r>
-          </a:p>
-          <a:p xmlns:a="http://schemas.openxmlformats.org/drawingml/2006/main">
-            <a:r>
-              <a:t>There is an important difference between a table and a report made from that table. A table can contain resolved work, active work, and unassigned work. A report chooses some of those rows and some of their attributes. Every condition we add changes which facts the report includes. We will keep that distinction in view while tracing the request and learning the relational operations.</a:t>
-            </a:r>
-          </a:p>
-          <a:p xmlns:a="http://schemas.openxmlformats.org/drawingml/2006/main">
-            <a:r>
-              <a:t/>
-            </a:r>
-          </a:p>
+              <a:t>Here is the case we will use all week. It is a fictional repair desk, and it is small on purpose, so you can hold all of it in your head.</a:t>
+            </a:r>
+          </a:p>
+          <a:p xmlns:a="http://schemas.openxmlformats.org/drawingml/2006/main"/>
+          <a:p xmlns:a="http://schemas.openxmlformats.org/drawingml/2006/main">
+            <a:r>
+              <a:t>Look at the first card, stored facts. Each ticket has an ID, a subject, a status, and an assignee, and one row represents one request. The ID matters most. It lets us talk about the same request even when its subject or status changes.</a:t>
+            </a:r>
+          </a:p>
+          <a:p xmlns:a="http://schemas.openxmlformats.org/drawingml/2006/main"/>
+          <a:p xmlns:a="http://schemas.openxmlformats.org/drawingml/2006/main">
+            <a:r>
+              <a:t>The middle card is the dashboard's promise: every active request should appear. Notice we had to say what active means. Here it means status new or open. A resolved request is not active. That definition is a business rule. The database cannot guess what a repair desk means by the word active. Somebody has to write it into the software, and somebody can write it wrong.</a:t>
+            </a:r>
+          </a:p>
+          <a:p xmlns:a="http://schemas.openxmlformats.org/drawingml/2006/main"/>
+          <a:p xmlns:a="http://schemas.openxmlformats.org/drawingml/2006/main">
+            <a:r>
+              <a:t>The third card is the complaint. The student has confirmation 1004 for a broken bench, and staff cannot find it. That number lets us line up three things: what the student was told, what is stored, and what the dashboard shows. By itself it does not tell us which part failed.</a:t>
+            </a:r>
+          </a:p>
+          <a:p xmlns:a="http://schemas.openxmlformats.org/drawingml/2006/main"/>
+          <a:p xmlns:a="http://schemas.openxmlformats.org/drawingml/2006/main">
+            <a:r>
+              <a:t>Now read the sentence at the bottom, because it is the key idea of the week. A stored record and a query result can contain different rows. A table can hold resolved work, active work, and unassigned work. A report picks some of those rows. Every condition we add changes which facts make it in.</a:t>
+            </a:r>
+          </a:p>
+          <a:p xmlns:a="http://schemas.openxmlformats.org/drawingml/2006/main"/>
           <a:p xmlns:a="http://schemas.openxmlformats.org/drawingml/2006/main">
             <a:r>
               <a:t>[Sources]</a:t>
@@ -1724,44 +1640,28 @@
           <a:lstStyle xmlns:a="http://schemas.openxmlformats.org/drawingml/2006/main"/>
           <a:p xmlns:a="http://schemas.openxmlformats.org/drawingml/2006/main">
             <a:r>
-              <a:t>Read the upper diagram from left to right. The browser collects the student's description and sends an HTTP request to the application. HTTP is the protocol used for communication between the browser and a web service. POST commonly requests creation of a resource. The path slash API slash tickets identifies the operation's destination within this illustrative application. The object below it carries the description.</a:t>
-            </a:r>
-          </a:p>
-          <a:p xmlns:a="http://schemas.openxmlformats.org/drawingml/2006/main">
-            <a:r>
-              <a:t/>
-            </a:r>
-          </a:p>
-          <a:p xmlns:a="http://schemas.openxmlformats.org/drawingml/2006/main">
-            <a:r>
-              <a:t>The API endpoint is the application code that receives that request. It checks the caller's identity and whether the caller may create a ticket. Authentication establishes who the caller is. Authorization determines which operations that caller may perform. These checks may happen in more than one component, including database permissions.</a:t>
-            </a:r>
-          </a:p>
-          <a:p xmlns:a="http://schemas.openxmlformats.org/drawingml/2006/main">
-            <a:r>
-              <a:t/>
-            </a:r>
-          </a:p>
-          <a:p xmlns:a="http://schemas.openxmlformats.org/drawingml/2006/main">
-            <a:r>
-              <a:t>The application then asks the DBMS to insert a row. INSERT INTO names the table. The parenthesized list names the columns, and VALUES supplies the corresponding values in the same order. Here 1004 identifies the new request, the subject describes the bench, new records its initial status, and NULL means there is no assigned agent yet. This command illustrates the four-column table used in today's case, before ticket 1004 exists. It is not a setup script for the larger course database, and we are not running it as a lab requirement. Real applications commonly let the database generate an identifier.</a:t>
-            </a:r>
-          </a:p>
-          <a:p xmlns:a="http://schemas.openxmlformats.org/drawingml/2006/main">
-            <a:r>
-              <a:t/>
-            </a:r>
-          </a:p>
-          <a:p xmlns:a="http://schemas.openxmlformats.org/drawingml/2006/main">
-            <a:r>
-              <a:t>The DBMS checks applicable rules and coordinates the write. After a successful commit, the application can return confirmation to the browser. Commit means that the transaction has completed successfully according to the database's guarantees. Closing the browser should not erase a committed ticket. Displaying a list later requires a separate read operation, which can apply different conditions.</a:t>
-            </a:r>
-          </a:p>
-          <a:p xmlns:a="http://schemas.openxmlformats.org/drawingml/2006/main">
-            <a:r>
-              <a:t/>
-            </a:r>
-          </a:p>
+              <a:t>Let's follow the student's request from left to right across the top of the slide. Step one, the browser collects the description and sends an HTTP request. HTTP is how the browser talks to a web service. Look at the box on the left: POST slash api slash tickets. POST usually means "create something," the path says where, and the little object underneath carries the subject, Broken bench slat.</a:t>
+            </a:r>
+          </a:p>
+          <a:p xmlns:a="http://schemas.openxmlformats.org/drawingml/2006/main"/>
+          <a:p xmlns:a="http://schemas.openxmlformats.org/drawingml/2006/main">
+            <a:r>
+              <a:t>Step two, the API endpoint receives it. Step three is identity and rules, and this is where two words need to stay separate. Authentication asks who you are. Authorization asks what you are allowed to do. You can be correctly signed in and still not be allowed to do something, and those checks can happen in more than one place, including the database itself.</a:t>
+            </a:r>
+          </a:p>
+          <a:p xmlns:a="http://schemas.openxmlformats.org/drawingml/2006/main"/>
+          <a:p xmlns:a="http://schemas.openxmlformats.org/drawingml/2006/main">
+            <a:r>
+              <a:t>Step four, the application asks the DBMS to store a row. Look at the SQL on the right. INSERT INTO tickets names the table. The list in parentheses names the columns. VALUES gives the values in the same order: 1004, the subject, status new, and NULL for the assignee, because nobody has taken the job yet. This is an illustration of our four-column table. We are not running it, and real applications usually let the database generate the ID.</a:t>
+            </a:r>
+          </a:p>
+          <a:p xmlns:a="http://schemas.openxmlformats.org/drawingml/2006/main"/>
+          <a:p xmlns:a="http://schemas.openxmlformats.org/drawingml/2006/main">
+            <a:r>
+              <a:t>Why does commit matter? After the database commits, closing the browser should not erase the ticket. And showing a list later is a separate read, which can apply different conditions. Keep that in mind.</a:t>
+            </a:r>
+          </a:p>
+          <a:p xmlns:a="http://schemas.openxmlformats.org/drawingml/2006/main"/>
           <a:p xmlns:a="http://schemas.openxmlformats.org/drawingml/2006/main">
             <a:r>
               <a:t>[Sources]</a:t>
@@ -1849,44 +1749,34 @@
           <a:lstStyle xmlns:a="http://schemas.openxmlformats.org/drawingml/2006/main"/>
           <a:p xmlns:a="http://schemas.openxmlformats.org/drawingml/2006/main">
             <a:r>
-              <a:t>These three terms describe different parts of a system. The database is the organized data and its declared structure. In our repair-desk example, that includes the tickets, agent records, and rules governing valid relationships. A database can also contain indexes and other supporting information, which we will introduce when we study retrieval and administration.</a:t>
-            </a:r>
-          </a:p>
-          <a:p xmlns:a="http://schemas.openxmlformats.org/drawingml/2006/main">
-            <a:r>
-              <a:t/>
-            </a:r>
-          </a:p>
-          <a:p xmlns:a="http://schemas.openxmlformats.org/drawingml/2006/main">
-            <a:r>
-              <a:t>DBMS abbreviates database management system. It is executable software. PostgreSQL, MongoDB, and SQLite are examples, although they differ in their data models, deployment arrangements, and features. The DBMS accepts operations, evaluates queries, enforces the rules that have been configured, and manages changes to stored data. A useful query is still the developer's responsibility. A DBMS can correctly execute a query that answers the wrong business question.</a:t>
-            </a:r>
-          </a:p>
-          <a:p xmlns:a="http://schemas.openxmlformats.org/drawingml/2006/main">
-            <a:r>
-              <a:t/>
-            </a:r>
-          </a:p>
-          <a:p xmlns:a="http://schemas.openxmlformats.org/drawingml/2006/main">
-            <a:r>
-              <a:t>A managed platform operates database infrastructure and provides related services. Supabase provides a PostgreSQL database with an application platform around it. MongoDB Atlas manages MongoDB deployments. Their web dashboards let authorized people configure and inspect the service. The dashboard is an interface to the system rather than the data itself.</a:t>
-            </a:r>
-          </a:p>
-          <a:p xmlns:a="http://schemas.openxmlformats.org/drawingml/2006/main">
-            <a:r>
-              <a:t/>
-            </a:r>
-          </a:p>
-          <a:p xmlns:a="http://schemas.openxmlformats.org/drawingml/2006/main">
-            <a:r>
-              <a:t>This distinction helps us describe problems precisely. An invalid query differs from an unavailable database server. A missing permission differs from a disconnected browser session. It also helps us retain transferable knowledge. Understanding a primary key or a transaction remains useful when a vendor moves a button. Managed services change how we perform some operational work, but we still need to understand the data and the rules our application depends on.</a:t>
-            </a:r>
-          </a:p>
-          <a:p xmlns:a="http://schemas.openxmlformats.org/drawingml/2006/main">
-            <a:r>
-              <a:t/>
-            </a:r>
-          </a:p>
+              <a:t>Three words that people use as if they were the same thing. We are going to keep them apart, because it makes both design and troubleshooting much easier.</a:t>
+            </a:r>
+          </a:p>
+          <a:p xmlns:a="http://schemas.openxmlformats.org/drawingml/2006/main"/>
+          <a:p xmlns:a="http://schemas.openxmlformats.org/drawingml/2006/main">
+            <a:r>
+              <a:t>Look at the left column. The database is the organized data and its structure: tables, rows and constraints, or collections and documents, plus indexes and metadata. In our repair desk, that is the tickets, the agent records, and the rules about valid relationships.</a:t>
+            </a:r>
+          </a:p>
+          <a:p xmlns:a="http://schemas.openxmlformats.org/drawingml/2006/main"/>
+          <a:p xmlns:a="http://schemas.openxmlformats.org/drawingml/2006/main">
+            <a:r>
+              <a:t>The middle column is the DBMS, the software. PostgreSQL, MongoDB, and SQLite are all examples, and they differ a lot in data model and features. The DBMS accepts operations, runs queries, enforces the rules you configured, and manages changes. Here is the catch. A DBMS will correctly run a query that answers the wrong question. Asking the right question is still our job.</a:t>
+            </a:r>
+          </a:p>
+          <a:p xmlns:a="http://schemas.openxmlformats.org/drawingml/2006/main"/>
+          <a:p xmlns:a="http://schemas.openxmlformats.org/drawingml/2006/main">
+            <a:r>
+              <a:t>The right column is the managed platform: Supabase, MongoDB Atlas, Amazon RDS. A platform operates the DBMS for you and adds services around it. Its web dashboard is an interface to the system. It is not the data.</a:t>
+            </a:r>
+          </a:p>
+          <a:p xmlns:a="http://schemas.openxmlformats.org/drawingml/2006/main"/>
+          <a:p xmlns:a="http://schemas.openxmlformats.org/drawingml/2006/main">
+            <a:r>
+              <a:t>Why bother with the distinctions? Because a broken query is a different problem from a server that is down, and a missing permission is different from a dropped browser session. Naming the layer tells you where to look. It also keeps your knowledge portable. A primary key or a transaction means the same thing when a vendor moves a button next year.</a:t>
+            </a:r>
+          </a:p>
+          <a:p xmlns:a="http://schemas.openxmlformats.org/drawingml/2006/main"/>
           <a:p xmlns:a="http://schemas.openxmlformats.org/drawingml/2006/main">
             <a:r>
               <a:t>[Sources]</a:t>
@@ -1974,44 +1864,34 @@
           <a:lstStyle xmlns:a="http://schemas.openxmlformats.org/drawingml/2006/main"/>
           <a:p xmlns:a="http://schemas.openxmlformats.org/drawingml/2006/main">
             <a:r>
-              <a:t>This is a redacted Supabase project screenshot captured for the course in August 2026. It shows the project overview, not the rows in a ticket table. The database appears as one component with information about its health and resource use. Labels and layout may change, so we will learn the role of each tool rather than memorize the location of every control.</a:t>
-            </a:r>
-          </a:p>
-          <a:p xmlns:a="http://schemas.openxmlformats.org/drawingml/2006/main">
-            <a:r>
-              <a:t/>
-            </a:r>
-          </a:p>
-          <a:p xmlns:a="http://schemas.openxmlformats.org/drawingml/2006/main">
-            <a:r>
-              <a:t>Supabase gives a project a PostgreSQL database. PostgreSQL performs the relational database work: storing tables, evaluating SQL, enforcing constraints, and coordinating transactions. Supabase adds services and interfaces around that database. Its dashboard includes a table editor and a SQL editor. The table editor provides a visual way to inspect or edit rows. The SQL editor sends SQL commands to the database. They are different interfaces to the same underlying data.</a:t>
-            </a:r>
-          </a:p>
-          <a:p xmlns:a="http://schemas.openxmlformats.org/drawingml/2006/main">
-            <a:r>
-              <a:t/>
-            </a:r>
-          </a:p>
-          <a:p xmlns:a="http://schemas.openxmlformats.org/drawingml/2006/main">
-            <a:r>
-              <a:t>Authentication is another platform service. It can help an application identify a signed-in user. Identifying a user does not automatically grant appropriate access to every table. The application and database still need authorization rules. We will develop those rules later with concrete allowed and denied examples.</a:t>
-            </a:r>
-          </a:p>
-          <a:p xmlns:a="http://schemas.openxmlformats.org/drawingml/2006/main">
-            <a:r>
-              <a:t/>
-            </a:r>
-          </a:p>
-          <a:p xmlns:a="http://schemas.openxmlformats.org/drawingml/2006/main">
-            <a:r>
-              <a:t>A healthy status in an overview tells us something about service operation. It cannot certify that our dashboard includes every active ticket. That requires inspecting the query and its result. Likewise, a backup label does not establish that a particular plan provides every recovery feature. Today's purpose is to recognize the platform and database layers. You do not need to buy a plan or create a project for this week's exercise.</a:t>
-            </a:r>
-          </a:p>
-          <a:p xmlns:a="http://schemas.openxmlformats.org/drawingml/2006/main">
-            <a:r>
-              <a:t/>
-            </a:r>
-          </a:p>
+              <a:t>This is a real Supabase project screen, captured for the course in August 2026, with the account details redacted. Notice what it shows: the project overview, the health of the service, resource use. It does not show a single ticket. Screens like this change, so do not memorize where the buttons are. Learn what each tool is for.</a:t>
+            </a:r>
+          </a:p>
+          <a:p xmlns:a="http://schemas.openxmlformats.org/drawingml/2006/main"/>
+          <a:p xmlns:a="http://schemas.openxmlformats.org/drawingml/2006/main">
+            <a:r>
+              <a:t>Look at the two boxes at the bottom. The first one is what the platform adds: the dashboard, managed infrastructure, API services, authentication, logs, and configuration. The second is what PostgreSQL still does: tables, SQL, constraints, transactions, query planning, indexes, and roles. Supabase gives each project a real PostgreSQL database. All the relational work happens there.</a:t>
+            </a:r>
+          </a:p>
+          <a:p xmlns:a="http://schemas.openxmlformats.org/drawingml/2006/main"/>
+          <a:p xmlns:a="http://schemas.openxmlformats.org/drawingml/2006/main">
+            <a:r>
+              <a:t>Supabase has a table editor and a SQL editor. The table editor lets you look at rows visually. The SQL editor sends SQL to the database. They are two windows onto the same data.</a:t>
+            </a:r>
+          </a:p>
+          <a:p xmlns:a="http://schemas.openxmlformats.org/drawingml/2006/main"/>
+          <a:p xmlns:a="http://schemas.openxmlformats.org/drawingml/2006/main">
+            <a:r>
+              <a:t>Authentication is one of the platform services. It can tell the application who is signed in. It does not decide what that person may read. That still takes authorization rules, which we build later with tests that should succeed and tests that should be refused.</a:t>
+            </a:r>
+          </a:p>
+          <a:p xmlns:a="http://schemas.openxmlformats.org/drawingml/2006/main"/>
+          <a:p xmlns:a="http://schemas.openxmlformats.org/drawingml/2006/main">
+            <a:r>
+              <a:t>Here is why this matters for our mystery. A green "healthy" status tells you the service is running. It cannot tell you the dashboard includes every active ticket. Only the query and its result can. You do not need a project or a paid plan this week.</a:t>
+            </a:r>
+          </a:p>
+          <a:p xmlns:a="http://schemas.openxmlformats.org/drawingml/2006/main"/>
           <a:p xmlns:a="http://schemas.openxmlformats.org/drawingml/2006/main">
             <a:r>
               <a:t>[Sources]</a:t>
@@ -2094,44 +1974,34 @@
           <a:lstStyle xmlns:a="http://schemas.openxmlformats.org/drawingml/2006/main"/>
           <a:p xmlns:a="http://schemas.openxmlformats.org/drawingml/2006/main">
             <a:r>
-              <a:t>This second screenshot shows MongoDB Atlas. It is also a managed platform, but the database software here is MongoDB. An Atlas project organizes deployments and access settings. A cluster is a database deployment that an application can connect to. The word cluster has different precise meanings across products, so we will use each product's definition when we configure it.</a:t>
-            </a:r>
-          </a:p>
-          <a:p xmlns:a="http://schemas.openxmlformats.org/drawingml/2006/main">
-            <a:r>
-              <a:t/>
-            </a:r>
-          </a:p>
-          <a:p xmlns:a="http://schemas.openxmlformats.org/drawingml/2006/main">
-            <a:r>
-              <a:t>Inside MongoDB, a database contains collections. A collection holds documents. A document represents a record using named fields, and a field can itself contain a nested document or an array. MongoDB stores these documents using BSON, a binary representation that supports values such as dates in addition to familiar JSON-like structures. We will introduce JSON carefully before asking you to write MongoDB queries. No BSON syntax needs to be memorized today.</a:t>
-            </a:r>
-          </a:p>
-          <a:p xmlns:a="http://schemas.openxmlformats.org/drawingml/2006/main">
-            <a:r>
-              <a:t/>
-            </a:r>
-          </a:p>
-          <a:p xmlns:a="http://schemas.openxmlformats.org/drawingml/2006/main">
-            <a:r>
-              <a:t>Notice that access settings surround the database. A person can be able to sign in to the Atlas website while an application still cannot connect to a cluster. Database users, connection details, and network access rules affect that application connection. Website sign-in and database authentication are related operational concerns, but they are not interchangeable credentials.</a:t>
-            </a:r>
-          </a:p>
-          <a:p xmlns:a="http://schemas.openxmlformats.org/drawingml/2006/main">
-            <a:r>
-              <a:t/>
-            </a:r>
-          </a:p>
-          <a:p xmlns:a="http://schemas.openxmlformats.org/drawingml/2006/main">
-            <a:r>
-              <a:t>The two platform screenshots show a common pattern: an application connects to database software running somewhere, and a management interface helps people operate it. The main difference we will study is how the records are organized and queried. For now, both systems can store a support request, and neither can automatically decide which requests our repair-desk dashboard ought to display. This screenshot is a dated illustration, not a requirement to configure an account today.</a:t>
-            </a:r>
-          </a:p>
-          <a:p xmlns:a="http://schemas.openxmlformats.org/drawingml/2006/main">
-            <a:r>
-              <a:t/>
-            </a:r>
-          </a:p>
+              <a:t>Here is the second platform, MongoDB Atlas. Same pattern, different database software. Underneath this one is MongoDB, not PostgreSQL.</a:t>
+            </a:r>
+          </a:p>
+          <a:p xmlns:a="http://schemas.openxmlformats.org/drawingml/2006/main"/>
+          <a:p xmlns:a="http://schemas.openxmlformats.org/drawingml/2006/main">
+            <a:r>
+              <a:t>Look at the two boxes at the bottom. The Atlas layer is the project, the cluster, network access, database users, and logs. A project organizes your deployments and access settings. A cluster is a database deployment an application can connect to. Be careful with that word, because cluster means different things in different products, so we will use each product's own definition when we get there.</a:t>
+            </a:r>
+          </a:p>
+          <a:p xmlns:a="http://schemas.openxmlformats.org/drawingml/2006/main"/>
+          <a:p xmlns:a="http://schemas.openxmlformats.org/drawingml/2006/main">
+            <a:r>
+              <a:t>The MongoDB layer is databases, collections, documents, queries, and indexes. A database contains collections. A collection holds documents. A document is a record made of named fields, and a field can hold a nested document or a list. MongoDB stores documents in a format called BSON, a binary relative of JSON that also understands types like dates. You do not need any of that syntax today.</a:t>
+            </a:r>
+          </a:p>
+          <a:p xmlns:a="http://schemas.openxmlformats.org/drawingml/2006/main"/>
+          <a:p xmlns:a="http://schemas.openxmlformats.org/drawingml/2006/main">
+            <a:r>
+              <a:t>Here is something that surprises people. You can sign in to the Atlas website perfectly well while your application still cannot connect to the cluster. The website login and the database login are different credentials, and database users, connection details, and network rules all sit in between.</a:t>
+            </a:r>
+          </a:p>
+          <a:p xmlns:a="http://schemas.openxmlformats.org/drawingml/2006/main"/>
+          <a:p xmlns:a="http://schemas.openxmlformats.org/drawingml/2006/main">
+            <a:r>
+              <a:t>So both screenshots show the same pattern: database software running somewhere, and a management interface for people. Either system can store a support request. Neither one can decide which requests our dashboard ought to show. The note on the slide is true: no cloud account is needed for this week's lab.</a:t>
+            </a:r>
+          </a:p>
+          <a:p xmlns:a="http://schemas.openxmlformats.org/drawingml/2006/main"/>
           <a:p xmlns:a="http://schemas.openxmlformats.org/drawingml/2006/main">
             <a:r>
               <a:t>[Sources]</a:t>
@@ -2219,44 +2089,40 @@
           <a:lstStyle xmlns:a="http://schemas.openxmlformats.org/drawingml/2006/main"/>
           <a:p xmlns:a="http://schemas.openxmlformats.org/drawingml/2006/main">
             <a:r>
-              <a:t>We can describe database administration through the promises a working application needs to keep. Correctness means the stored facts and the operations on them follow the intended rules. In the repair desk, a ticket should retain its identity when its status changes, and an assigned agent should refer to a real staff record. We will use constraints to reject some invalid states and transactions to coordinate related changes.</a:t>
-            </a:r>
-          </a:p>
-          <a:p xmlns:a="http://schemas.openxmlformats.org/drawingml/2006/main">
-            <a:r>
-              <a:t/>
-            </a:r>
-          </a:p>
-          <a:p xmlns:a="http://schemas.openxmlformats.org/drawingml/2006/main">
-            <a:r>
-              <a:t>Security concerns which people or programs may read or change particular information. A student who submits a repair request should not gain permission to delete the entire ticket collection. Least privilege means granting the access needed for a task while withholding unrelated powers. We will test both permitted and rejected operations rather than assume a permission setup works.</a:t>
-            </a:r>
-          </a:p>
-          <a:p xmlns:a="http://schemas.openxmlformats.org/drawingml/2006/main">
-            <a:r>
-              <a:t/>
-            </a:r>
-          </a:p>
-          <a:p xmlns:a="http://schemas.openxmlformats.org/drawingml/2006/main">
-            <a:r>
-              <a:t>Availability concerns whether legitimate users can reach the service when they need it. A stopped server or broken connection can prevent a correct query from completing. Slow operations can also make a service impractical to use. We will learn to observe these conditions and distinguish them from errors in the query's meaning.</a:t>
-            </a:r>
-          </a:p>
-          <a:p xmlns:a="http://schemas.openxmlformats.org/drawingml/2006/main">
-            <a:r>
-              <a:t/>
-            </a:r>
-          </a:p>
-          <a:p xmlns:a="http://schemas.openxmlformats.org/drawingml/2006/main">
-            <a:r>
-              <a:t>Recovery concerns bringing useful data back after a mistake or failure. Creating a backup file is one action. Restoring it into a separate target and checking important records is how we learn whether it can support recovery. Those later exercises will build on the same habit we use today: state an expected outcome, examine the actual records, and explain the difference. We begin with four rows because the mechanism is easier to see before scale makes the symptoms harder to interpret.</a:t>
-            </a:r>
-          </a:p>
-          <a:p xmlns:a="http://schemas.openxmlformats.org/drawingml/2006/main">
-            <a:r>
-              <a:t/>
-            </a:r>
-          </a:p>
+              <a:t>So what does a database administrator actually do? Look at the center of the slide: shared data. The job is to keep that data correct, available, secure, and recoverable. </a:t>
+            </a:r>
+          </a:p>
+          <a:p xmlns:a="http://schemas.openxmlformats.org/drawingml/2006/main"/>
+          <a:p xmlns:a="http://schemas.openxmlformats.org/drawingml/2006/main">
+            <a:r>
+              <a:t>Correctness means the stored facts follow the intended rules. A ticket keeps its identity when its status changes. An assigned agent refers to a real staff record. Later we use constraints to reject bad values and transactions to coordinate related changes.</a:t>
+            </a:r>
+          </a:p>
+          <a:p xmlns:a="http://schemas.openxmlformats.org/drawingml/2006/main"/>
+          <a:p xmlns:a="http://schemas.openxmlformats.org/drawingml/2006/main">
+            <a:r>
+              <a:t>Availability means people can reach the service when they need it. A stopped server or a broken connection can stop a perfectly correct query. So can an operation that is just too slow to be usable. We will learn to tell those failures apart from a query that means the wrong thing.</a:t>
+            </a:r>
+          </a:p>
+          <a:p xmlns:a="http://schemas.openxmlformats.org/drawingml/2006/main"/>
+          <a:p xmlns:a="http://schemas.openxmlformats.org/drawingml/2006/main">
+            <a:r>
+              <a:t>Security means each person or program gets the access appropriate to its job. A student who submits a repair request should not be able to delete every ticket. That idea is called least privilege, and we will test it both ways: what is allowed, and what must be refused.</a:t>
+            </a:r>
+          </a:p>
+          <a:p xmlns:a="http://schemas.openxmlformats.org/drawingml/2006/main"/>
+          <a:p xmlns:a="http://schemas.openxmlformats.org/drawingml/2006/main">
+            <a:r>
+              <a:t>Recovery means getting useful records back after a mistake or a failure. Making a backup file is one step. Restoring it somewhere separate and checking the important rows is how you find out whether it actually works.</a:t>
+            </a:r>
+          </a:p>
+          <a:p xmlns:a="http://schemas.openxmlformats.org/drawingml/2006/main"/>
+          <a:p xmlns:a="http://schemas.openxmlformats.org/drawingml/2006/main">
+            <a:r>
+              <a:t>Every one of those later exercises uses the habit we start today: predict the outcome, look at the actual rows, explain the difference. We begin with four rows because the mechanism is easier to see before scale hides it.</a:t>
+            </a:r>
+          </a:p>
+          <a:p xmlns:a="http://schemas.openxmlformats.org/drawingml/2006/main"/>
           <a:p xmlns:a="http://schemas.openxmlformats.org/drawingml/2006/main">
             <a:r>
               <a:t>[Sources]</a:t>
@@ -2339,44 +2205,34 @@
           <a:lstStyle xmlns:a="http://schemas.openxmlformats.org/drawingml/2006/main"/>
           <a:p xmlns:a="http://schemas.openxmlformats.org/drawingml/2006/main">
             <a:r>
-              <a:t>Here is the reported problem again. The form reports success, but ticket 1004 does not appear on the staff dashboard. The response shown below says HTTP 201 Created and includes ticket identifier 1004. In normal HTTP semantics, 201 indicates that the request succeeded and created a resource. We still need to connect that response to the stored record and the later read operation.</a:t>
-            </a:r>
-          </a:p>
-          <a:p xmlns:a="http://schemas.openxmlformats.org/drawingml/2006/main">
-            <a:r>
-              <a:t/>
-            </a:r>
-          </a:p>
-          <a:p xmlns:a="http://schemas.openxmlformats.org/drawingml/2006/main">
-            <a:r>
-              <a:t>First, the client must have sent the intended request. Second, the application must have handled it and returned the response we are examining. Third, the database write must have committed. A commit is different from the browser merely displaying a message. Fourth, the query that refreshes the dashboard must include the ticket if it meets the dashboard's stated purpose.</a:t>
-            </a:r>
-          </a:p>
-          <a:p xmlns:a="http://schemas.openxmlformats.org/drawingml/2006/main">
-            <a:r>
-              <a:t/>
-            </a:r>
-          </a:p>
-          <a:p xmlns:a="http://schemas.openxmlformats.org/drawingml/2006/main">
-            <a:r>
-              <a:t>The supplied lab data lets us examine the fourth step without logging into a cloud account. If ticket 1004 is present in the table but absent from the query result, deletion is not the explanation supported by those rows. The row and the displayed result are two different objects. A filter can exclude a row, and a join can exclude a row that has no match. We will define both operations in the next part of the lesson.</a:t>
-            </a:r>
-          </a:p>
-          <a:p xmlns:a="http://schemas.openxmlformats.org/drawingml/2006/main">
-            <a:r>
-              <a:t/>
-            </a:r>
-          </a:p>
-          <a:p xmlns:a="http://schemas.openxmlformats.org/drawingml/2006/main">
-            <a:r>
-              <a:t>There are other possible causes in real applications, such as reading a different database or showing an older cached result. We should not add those explanations when the supplied case already identifies the relevant rule. A useful diagnosis names the observation, connects it to a mechanism, and proposes a change that addresses that mechanism. The second part of this week's lab develops exactly that explanation.</a:t>
-            </a:r>
-          </a:p>
-          <a:p xmlns:a="http://schemas.openxmlformats.org/drawingml/2006/main">
-            <a:r>
-              <a:t/>
-            </a:r>
-          </a:p>
+              <a:t>Back to the mystery. Look at the top box, the observed symptom: the form reports success, but ticket 1004 is absent from the staff dashboard.</a:t>
+            </a:r>
+          </a:p>
+          <a:p xmlns:a="http://schemas.openxmlformats.org/drawingml/2006/main"/>
+          <a:p xmlns:a="http://schemas.openxmlformats.org/drawingml/2006/main">
+            <a:r>
+              <a:t>Look at the response at the bottom: HTTP 201 Created, ticket_id 1004, status new. In HTTP, 201 means the request succeeded and created something. But it is one observation, and we still have to connect it to the stored row and to the later read.</a:t>
+            </a:r>
+          </a:p>
+          <a:p xmlns:a="http://schemas.openxmlformats.org/drawingml/2006/main"/>
+          <a:p xmlns:a="http://schemas.openxmlformats.org/drawingml/2006/main">
+            <a:r>
+              <a:t>So we check the path in four steps, the four numbered boxes. One, client: did the browser send the request we think it sent? Two, API: what status and body came back? Three, database: did the command actually commit? A commit is not the same thing as a success message on a screen. Four, the read path: is the query that builds the dashboard filtering the ticket out?</a:t>
+            </a:r>
+          </a:p>
+          <a:p xmlns:a="http://schemas.openxmlformats.org/drawingml/2006/main"/>
+          <a:p xmlns:a="http://schemas.openxmlformats.org/drawingml/2006/main">
+            <a:r>
+              <a:t>The write path and the read path are separate, and each can fail on its own. The lab gives you the stored rows, so you can check step four. If ticket 1004 is in the table and missing from the result, the rows do not support "it was deleted." A filter can drop a row, and so can a join that finds no match.</a:t>
+            </a:r>
+          </a:p>
+          <a:p xmlns:a="http://schemas.openxmlformats.org/drawingml/2006/main"/>
+          <a:p xmlns:a="http://schemas.openxmlformats.org/drawingml/2006/main">
+            <a:r>
+              <a:t>In real systems there are other suspects, like reading the wrong database or an old cached result. But do not invent causes the evidence does not point to. Name the observation, connect it to a mechanism, and propose a fix for that mechanism.</a:t>
+            </a:r>
+          </a:p>
+          <a:p xmlns:a="http://schemas.openxmlformats.org/drawingml/2006/main"/>
           <a:p xmlns:a="http://schemas.openxmlformats.org/drawingml/2006/main">
             <a:r>
               <a:t>[Sources]</a:t>
@@ -2459,44 +2315,34 @@
           <a:lstStyle xmlns:a="http://schemas.openxmlformats.org/drawingml/2006/main"/>
           <a:p xmlns:a="http://schemas.openxmlformats.org/drawingml/2006/main">
             <a:r>
-              <a:t>Our second meeting moves from the path of a request to the structure of its data. The relational model gives us a precise way to describe records and transformations. E. F. Codd introduced the relational model in 1970 as a way to describe data independently of many details of its physical storage. That separation helps explain why a query can state a desired result while the database chooses how to retrieve it.</a:t>
-            </a:r>
-          </a:p>
-          <a:p xmlns:a="http://schemas.openxmlformats.org/drawingml/2006/main">
-            <a:r>
-              <a:t/>
-            </a:r>
-          </a:p>
-          <a:p xmlns:a="http://schemas.openxmlformats.org/drawingml/2006/main">
-            <a:r>
-              <a:t>A relation is a set of tuples with named attributes. We can display it as a table, with one tuple per row and one attribute per column. The words are new labels for ideas we can inspect directly. We will identify what one row means before writing a query. For the tickets table, it means one support request.</a:t>
-            </a:r>
-          </a:p>
-          <a:p xmlns:a="http://schemas.openxmlformats.org/drawingml/2006/main">
-            <a:r>
-              <a:t/>
-            </a:r>
-          </a:p>
-          <a:p xmlns:a="http://schemas.openxmlformats.org/drawingml/2006/main">
-            <a:r>
-              <a:t>The two Greek symbols introduce operations on relations. Sigma denotes selection, which keeps rows satisfying a condition. Pi denotes projection, which keeps chosen attributes. We will first show these operations separately. A later example combines them with a join, which matches related rows.</a:t>
-            </a:r>
-          </a:p>
-          <a:p xmlns:a="http://schemas.openxmlformats.org/drawingml/2006/main">
-            <a:r>
-              <a:t/>
-            </a:r>
-          </a:p>
-          <a:p xmlns:a="http://schemas.openxmlformats.org/drawingml/2006/main">
-            <a:r>
-              <a:t>SQL draws on these ideas but does not follow every rule of classical set algebra. SQL results can contain duplicates, and SQL uses NULL for missing or unknown values. Classical relations do not contain duplicate tuples. We will make these differences explicit when they affect a result. Today's aim is to describe which rows and columns an operation should produce. The next week gives us extensive practice expressing and checking those descriptions in SQL.</a:t>
-            </a:r>
-          </a:p>
-          <a:p xmlns:a="http://schemas.openxmlformats.org/drawingml/2006/main">
-            <a:r>
-              <a:t/>
-            </a:r>
-          </a:p>
+              <a:t>Welcome to Day 2. Last time we followed a request through the system. Today we look at the shape of the data itself, and we need some precise language for that. That language is the relational model.</a:t>
+            </a:r>
+          </a:p>
+          <a:p xmlns:a="http://schemas.openxmlformats.org/drawingml/2006/main"/>
+          <a:p xmlns:a="http://schemas.openxmlformats.org/drawingml/2006/main">
+            <a:r>
+              <a:t>E. F. Codd introduced the relational model in 1970. His big idea was to describe data separately from how it is physically stored. That separation is why you can write a query that says what result you want and let the database decide how to fetch it.</a:t>
+            </a:r>
+          </a:p>
+          <a:p xmlns:a="http://schemas.openxmlformats.org/drawingml/2006/main"/>
+          <a:p xmlns:a="http://schemas.openxmlformats.org/drawingml/2006/main">
+            <a:r>
+              <a:t>A relation is a set of tuples with named attributes. You already know it as a table: one tuple per row, one attribute per column. Before we write any query, we always say what one row means. For the tickets table, one row means one support request. Look at the line on the right: a row represents one fact, and queries produce new results.</a:t>
+            </a:r>
+          </a:p>
+          <a:p xmlns:a="http://schemas.openxmlformats.org/drawingml/2006/main"/>
+          <a:p xmlns:a="http://schemas.openxmlformats.org/drawingml/2006/main">
+            <a:r>
+              <a:t>Now look at the two lines of relational algebra. The Greek letter sigma is selection. It keeps the rows that satisfy a condition, here status equals open. The letter pi is projection. It keeps the columns you choose, here ticket ID and subject. Later today we combine them with a join.</a:t>
+            </a:r>
+          </a:p>
+          <a:p xmlns:a="http://schemas.openxmlformats.org/drawingml/2006/main"/>
+          <a:p xmlns:a="http://schemas.openxmlformats.org/drawingml/2006/main">
+            <a:r>
+              <a:t>One honest caveat. SQL borrows these ideas but bends some of the rules. SQL results can contain duplicates, and SQL uses NULL for missing or unknown values. A classical relation has no duplicate tuples. Next week you get lots of practice writing these in SQL.</a:t>
+            </a:r>
+          </a:p>
+          <a:p xmlns:a="http://schemas.openxmlformats.org/drawingml/2006/main"/>
           <a:p xmlns:a="http://schemas.openxmlformats.org/drawingml/2006/main">
             <a:r>
               <a:t>[Sources]</a:t>
@@ -7016,7 +6862,7 @@
                           <a:ea typeface="Menlo"/>
                           <a:cs typeface="Menlo"/>
                         </a:rPr>
-                        <a:t>Priya Shah</a:t>
+                        <a:t>Agent 201</a:t>
                       </a:r>
                     </a:p>
                   </a:txBody>
@@ -7066,7 +6912,7 @@
                           <a:ea typeface="Menlo"/>
                           <a:cs typeface="Menlo"/>
                         </a:rPr>
-                        <a:t>Noah Williams</a:t>
+                        <a:t>Agent 202</a:t>
                       </a:r>
                     </a:p>
                   </a:txBody>

</xml_diff>